<commit_message>
Revamp presentation deck: creative, fun, human-sounding student pitch
</commit_message>
<xml_diff>
--- a/Smart_Warehouse_DockGuard_Presentation.pptx
+++ b/Smart_Warehouse_DockGuard_Presentation.pptx
@@ -3151,7 +3151,7 @@
             <a:avLst/>
           </a:prstGeom>
           <a:solidFill>
-            <a:srgbClr val="1E3A8A"/>
+            <a:srgbClr val="6D28D9"/>
           </a:solidFill>
           <a:ln>
             <a:noFill/>
@@ -3188,7 +3188,7 @@
         <p:spPr>
           <a:xfrm>
             <a:off x="731520" y="960120"/>
-            <a:ext cx="10698480" cy="1371600"/>
+            <a:ext cx="10698480" cy="1280160"/>
           </a:xfrm>
           <a:prstGeom prst="rect">
             <a:avLst/>
@@ -3202,15 +3202,15 @@
           <a:lstStyle/>
           <a:p>
             <a:pPr>
-              <a:defRPr sz="3200" b="1">
-                <a:solidFill>
-                  <a:srgbClr val="1E3A8A"/>
-                </a:solidFill>
-                <a:latin typeface="Calibri"/>
-              </a:defRPr>
-            </a:pPr>
-            <a:r>
-              <a:t>DockGuard: Smart Warehouse Vision System</a:t>
+              <a:defRPr sz="3600" b="1">
+                <a:solidFill>
+                  <a:srgbClr val="182B49"/>
+                </a:solidFill>
+                <a:latin typeface="Segoe UI"/>
+              </a:defRPr>
+            </a:pPr>
+            <a:r>
+              <a:t>DockGuard AI</a:t>
             </a:r>
           </a:p>
           <a:p>
@@ -3218,15 +3218,15 @@
               <a:spcBef>
                 <a:spcPts val="400"/>
               </a:spcBef>
-              <a:defRPr sz="1500">
-                <a:solidFill>
-                  <a:srgbClr val="6B7280"/>
-                </a:solidFill>
-                <a:latin typeface="Calibri"/>
-              </a:defRPr>
-            </a:pPr>
-            <a:r>
-              <a:t>Detecting rough cargo handling and preventing package damage at loading bays using computer vision</a:t>
+              <a:defRPr sz="1600" b="1">
+                <a:solidFill>
+                  <a:srgbClr val="6D28D9"/>
+                </a:solidFill>
+                <a:latin typeface="Segoe UI"/>
+              </a:defRPr>
+            </a:pPr>
+            <a:r>
+              <a:t>Because gravity shouldn't win on the loading dock.</a:t>
             </a:r>
           </a:p>
         </p:txBody>
@@ -3240,17 +3240,17 @@
         <p:spPr>
           <a:xfrm>
             <a:off x="731520" y="2194560"/>
-            <a:ext cx="10728655" cy="1188720"/>
+            <a:ext cx="10728655" cy="1234440"/>
           </a:xfrm>
           <a:prstGeom prst="roundRect">
             <a:avLst/>
           </a:prstGeom>
           <a:solidFill>
-            <a:srgbClr val="EFF6FF"/>
+            <a:srgbClr val="F5F3FF"/>
           </a:solidFill>
           <a:ln w="12700">
             <a:solidFill>
-              <a:srgbClr val="BFDBFE"/>
+              <a:srgbClr val="DDD6FE"/>
             </a:solidFill>
           </a:ln>
         </p:spPr>
@@ -3285,7 +3285,7 @@
         <p:spPr>
           <a:xfrm>
             <a:off x="960120" y="2286000"/>
-            <a:ext cx="10241280" cy="1005840"/>
+            <a:ext cx="10241280" cy="1051560"/>
           </a:xfrm>
           <a:prstGeom prst="rect">
             <a:avLst/>
@@ -3301,29 +3301,29 @@
             <a:pPr>
               <a:defRPr sz="1000" b="1">
                 <a:solidFill>
-                  <a:srgbClr val="1D4ED8"/>
-                </a:solidFill>
-                <a:latin typeface="Calibri"/>
-              </a:defRPr>
-            </a:pPr>
-            <a:r>
-              <a:t>OUR CORE IDEA (ONE-LINE VALUE PROPOSITION)</a:t>
+                  <a:srgbClr val="6D28D9"/>
+                </a:solidFill>
+                <a:latin typeface="Segoe UI"/>
+              </a:defRPr>
+            </a:pPr>
+            <a:r>
+              <a:t>THE 10-SECOND PITCH</a:t>
             </a:r>
           </a:p>
           <a:p>
             <a:pPr>
               <a:spcBef>
-                <a:spcPts val="400"/>
+                <a:spcPts val="300"/>
               </a:spcBef>
-              <a:defRPr sz="1300">
-                <a:solidFill>
-                  <a:srgbClr val="1F2937"/>
-                </a:solidFill>
-                <a:latin typeface="Calibri"/>
-              </a:defRPr>
-            </a:pPr>
-            <a:r>
-              <a:t>We use existing warehouse CCTV cameras and computer vision to automatically detect when boxes are dropped, dragged, or improperly stacked during truck loading—alerting workers immediately so damaged items never leave the facility.</a:t>
+              <a:defRPr sz="1200">
+                <a:solidFill>
+                  <a:srgbClr val="334155"/>
+                </a:solidFill>
+                <a:latin typeface="Segoe UI"/>
+              </a:defRPr>
+            </a:pPr>
+            <a:r>
+              <a:t>Ever opened an online order to find your new gadget smashed into puzzle pieces? It almost never happens in the delivery van. It happens in the 4:00 PM warehouse rush where boxes fly, pallets wobble, and nobody notices. We built DockGuard to watch CCTV feeds in real time, catch drops and rough drags in seconds, and make sure damaged boxes never leave the building.</a:t>
             </a:r>
           </a:p>
         </p:txBody>
@@ -3336,8 +3336,8 @@
         </p:nvSpPr>
         <p:spPr>
           <a:xfrm>
-            <a:off x="731520" y="3611880"/>
-            <a:ext cx="5212080" cy="2743200"/>
+            <a:off x="731520" y="3639312"/>
+            <a:ext cx="5212080" cy="2788920"/>
           </a:xfrm>
           <a:prstGeom prst="roundRect">
             <a:avLst/>
@@ -3381,7 +3381,7 @@
         </p:nvSpPr>
         <p:spPr>
           <a:xfrm>
-            <a:off x="960120" y="3749039"/>
+            <a:off x="960120" y="3794760"/>
             <a:ext cx="4754880" cy="2468880"/>
           </a:xfrm>
           <a:prstGeom prst="rect">
@@ -3398,100 +3398,124 @@
             <a:pPr>
               <a:defRPr sz="1100" b="1">
                 <a:solidFill>
-                  <a:srgbClr val="1E3A8A"/>
-                </a:solidFill>
-                <a:latin typeface="Calibri"/>
-              </a:defRPr>
-            </a:pPr>
-            <a:r>
-              <a:t>TEAM MEMBERS (Team VisionGuard)</a:t>
+                  <a:srgbClr val="182B49"/>
+                </a:solidFill>
+                <a:latin typeface="Segoe UI"/>
+              </a:defRPr>
+            </a:pPr>
+            <a:r>
+              <a:t>THE SQUAD: TEAM VISIONGUARD</a:t>
             </a:r>
           </a:p>
           <a:p>
             <a:pPr>
               <a:spcBef>
-                <a:spcPts val="800"/>
+                <a:spcPts val="700"/>
               </a:spcBef>
-              <a:defRPr sz="1200" b="1">
-                <a:solidFill>
-                  <a:srgbClr val="1F2937"/>
-                </a:solidFill>
-                <a:latin typeface="Calibri"/>
-              </a:defRPr>
-            </a:pPr>
-            <a:r>
-              <a:t>• Aastha Gupta</a:t>
+              <a:defRPr sz="1100" b="1">
+                <a:solidFill>
+                  <a:srgbClr val="182B49"/>
+                </a:solidFill>
+                <a:latin typeface="Segoe UI"/>
+              </a:defRPr>
+            </a:pPr>
+            <a:r>
+              <a:t>• Aastha Gupta — </a:t>
+            </a:r>
+            <a:r>
+              <a:rPr b="1">
+                <a:solidFill>
+                  <a:srgbClr val="6D28D9"/>
+                </a:solidFill>
+              </a:rPr>
+              <a:t>[Vision Whisperer]</a:t>
             </a:r>
           </a:p>
           <a:p>
             <a:pPr>
               <a:defRPr sz="950">
                 <a:solidFill>
-                  <a:srgbClr val="6B7280"/>
-                </a:solidFill>
-                <a:latin typeface="Calibri"/>
-              </a:defRPr>
-            </a:pPr>
-            <a:r>
-              <a:t>   Role: Computer vision model training (YOLOv8) &amp; detection logic</a:t>
+                  <a:srgbClr val="64748B"/>
+                </a:solidFill>
+                <a:latin typeface="Segoe UI"/>
+              </a:defRPr>
+            </a:pPr>
+            <a:r>
+              <a:t>   Trained our custom YOLOv8 model to spot cartons, pallets &amp; workers at awkward angles</a:t>
             </a:r>
           </a:p>
           <a:p>
             <a:pPr>
               <a:spcBef>
-                <a:spcPts val="800"/>
+                <a:spcPts val="700"/>
               </a:spcBef>
-              <a:defRPr sz="1200" b="1">
-                <a:solidFill>
-                  <a:srgbClr val="1F2937"/>
-                </a:solidFill>
-                <a:latin typeface="Calibri"/>
-              </a:defRPr>
-            </a:pPr>
-            <a:r>
-              <a:t>• Lucky Lakhani</a:t>
+              <a:defRPr sz="1100" b="1">
+                <a:solidFill>
+                  <a:srgbClr val="182B49"/>
+                </a:solidFill>
+                <a:latin typeface="Segoe UI"/>
+              </a:defRPr>
+            </a:pPr>
+            <a:r>
+              <a:t>• Lucky Lakhani — </a:t>
+            </a:r>
+            <a:r>
+              <a:rPr b="1">
+                <a:solidFill>
+                  <a:srgbClr val="6D28D9"/>
+                </a:solidFill>
+              </a:rPr>
+              <a:t>[Pipeline &amp; AI Hacker]</a:t>
             </a:r>
           </a:p>
           <a:p>
             <a:pPr>
               <a:defRPr sz="950">
                 <a:solidFill>
-                  <a:srgbClr val="6B7280"/>
-                </a:solidFill>
-                <a:latin typeface="Calibri"/>
-              </a:defRPr>
-            </a:pPr>
-            <a:r>
-              <a:t>   Role: Backend API, video processing pipeline &amp; Gemini AI assistant</a:t>
+                  <a:srgbClr val="64748B"/>
+                </a:solidFill>
+                <a:latin typeface="Segoe UI"/>
+              </a:defRPr>
+            </a:pPr>
+            <a:r>
+              <a:t>   Built the sub-second video buffer, FastAPI endpoints &amp; connected Google Gemini</a:t>
             </a:r>
           </a:p>
           <a:p>
             <a:pPr>
               <a:spcBef>
-                <a:spcPts val="800"/>
+                <a:spcPts val="700"/>
               </a:spcBef>
-              <a:defRPr sz="1200" b="1">
-                <a:solidFill>
-                  <a:srgbClr val="1F2937"/>
-                </a:solidFill>
-                <a:latin typeface="Calibri"/>
-              </a:defRPr>
-            </a:pPr>
-            <a:r>
-              <a:t>• Runjan Bawa</a:t>
+              <a:defRPr sz="1100" b="1">
+                <a:solidFill>
+                  <a:srgbClr val="182B49"/>
+                </a:solidFill>
+                <a:latin typeface="Segoe UI"/>
+              </a:defRPr>
+            </a:pPr>
+            <a:r>
+              <a:t>• Runjan Bawa — </a:t>
+            </a:r>
+            <a:r>
+              <a:rPr b="1">
+                <a:solidFill>
+                  <a:srgbClr val="6D28D9"/>
+                </a:solidFill>
+              </a:rPr>
+              <a:t>[UI &amp; Experience Builder]</a:t>
             </a:r>
           </a:p>
           <a:p>
             <a:pPr>
               <a:defRPr sz="950">
                 <a:solidFill>
-                  <a:srgbClr val="6B7280"/>
-                </a:solidFill>
-                <a:latin typeface="Calibri"/>
-              </a:defRPr>
-            </a:pPr>
-            <a:r>
-              <a:t>   Role: Frontend dashboard, charts, audio alert chimes &amp; testing</a:t>
+                  <a:srgbClr val="64748B"/>
+                </a:solidFill>
+                <a:latin typeface="Segoe UI"/>
+              </a:defRPr>
+            </a:pPr>
+            <a:r>
+              <a:t>   Crafted the live dashboard, audio chimes, trend charts &amp; made it look clean</a:t>
             </a:r>
           </a:p>
         </p:txBody>
@@ -3504,8 +3528,8 @@
         </p:nvSpPr>
         <p:spPr>
           <a:xfrm>
-            <a:off x="6248095" y="3611880"/>
-            <a:ext cx="5212080" cy="2743200"/>
+            <a:off x="6248095" y="3639312"/>
+            <a:ext cx="5212080" cy="2788920"/>
           </a:xfrm>
           <a:prstGeom prst="roundRect">
             <a:avLst/>
@@ -3549,7 +3573,7 @@
         </p:nvSpPr>
         <p:spPr>
           <a:xfrm>
-            <a:off x="6473952" y="3749039"/>
+            <a:off x="6473952" y="3794760"/>
             <a:ext cx="4754880" cy="2468880"/>
           </a:xfrm>
           <a:prstGeom prst="rect">
@@ -3566,13 +3590,13 @@
             <a:pPr>
               <a:defRPr sz="1100" b="1">
                 <a:solidFill>
-                  <a:srgbClr val="1E3A8A"/>
-                </a:solidFill>
-                <a:latin typeface="Calibri"/>
-              </a:defRPr>
-            </a:pPr>
-            <a:r>
-              <a:t>WHAT WE SET OUT TO SOLVE</a:t>
+                  <a:srgbClr val="182B49"/>
+                </a:solidFill>
+                <a:latin typeface="Segoe UI"/>
+              </a:defRPr>
+            </a:pPr>
+            <a:r>
+              <a:t>WHY THIS ACTUALLY MATTERS</a:t>
             </a:r>
           </a:p>
           <a:p>
@@ -3580,23 +3604,23 @@
               <a:spcBef>
                 <a:spcPts val="700"/>
               </a:spcBef>
-              <a:defRPr sz="1050" b="1">
-                <a:solidFill>
-                  <a:srgbClr val="1F2937"/>
-                </a:solidFill>
-                <a:latin typeface="Calibri"/>
-              </a:defRPr>
-            </a:pPr>
-            <a:r>
-              <a:t>• The Industry Problem: </a:t>
+              <a:defRPr sz="1000" b="1">
+                <a:solidFill>
+                  <a:srgbClr val="334155"/>
+                </a:solidFill>
+                <a:latin typeface="Segoe UI"/>
+              </a:defRPr>
+            </a:pPr>
+            <a:r>
+              <a:t>• $50B+ Annual Lost Cargo: </a:t>
             </a:r>
             <a:r>
               <a:rPr b="0">
                 <a:solidFill>
-                  <a:srgbClr val="6B7280"/>
+                  <a:srgbClr val="64748B"/>
                 </a:solidFill>
               </a:rPr>
-              <a:t>Rough handling during loading and unloading causes billions in damaged goods every year, but supervisors can't watch 10+ loading bays at once.</a:t>
+              <a:t>That's how much merchandise gets wrecked in warehouses before even making it onto the highway. Most of it goes completely unrecorded.</a:t>
             </a:r>
           </a:p>
           <a:p>
@@ -3604,23 +3628,23 @@
               <a:spcBef>
                 <a:spcPts val="700"/>
               </a:spcBef>
-              <a:defRPr sz="1050" b="1">
-                <a:solidFill>
-                  <a:srgbClr val="1F2937"/>
-                </a:solidFill>
-                <a:latin typeface="Calibri"/>
-              </a:defRPr>
-            </a:pPr>
-            <a:r>
-              <a:t>• No Instant Feedback: </a:t>
+              <a:defRPr sz="1000" b="1">
+                <a:solidFill>
+                  <a:srgbClr val="334155"/>
+                </a:solidFill>
+                <a:latin typeface="Segoe UI"/>
+              </a:defRPr>
+            </a:pPr>
+            <a:r>
+              <a:t>• Human Eyes Can't Keep Up: </a:t>
             </a:r>
             <a:r>
               <a:rPr b="0">
                 <a:solidFill>
-                  <a:srgbClr val="6B7280"/>
+                  <a:srgbClr val="64748B"/>
                 </a:solidFill>
               </a:rPr>
-              <a:t>Workers often drop or drag heavy cartons without realizing internal contents broke, and damages are only discovered at the destination.</a:t>
+              <a:t>A single supervisor can't watch 10 bays, 40 fast-moving workers, and forklift traffic all at once. Blame usually turns into guessing games.</a:t>
             </a:r>
           </a:p>
           <a:p>
@@ -3628,23 +3652,23 @@
               <a:spcBef>
                 <a:spcPts val="700"/>
               </a:spcBef>
-              <a:defRPr sz="1050" b="1">
-                <a:solidFill>
-                  <a:srgbClr val="1F2937"/>
-                </a:solidFill>
-                <a:latin typeface="Calibri"/>
-              </a:defRPr>
-            </a:pPr>
-            <a:r>
-              <a:t>• Our Solution: </a:t>
+              <a:defRPr sz="1000" b="1">
+                <a:solidFill>
+                  <a:srgbClr val="334155"/>
+                </a:solidFill>
+                <a:latin typeface="Segoe UI"/>
+              </a:defRPr>
+            </a:pPr>
+            <a:r>
+              <a:t>• Catching It at the Dock: </a:t>
             </a:r>
             <a:r>
               <a:rPr b="0">
                 <a:solidFill>
-                  <a:srgbClr val="6B7280"/>
+                  <a:srgbClr val="64748B"/>
                 </a:solidFill>
               </a:rPr>
-              <a:t>A lightweight web platform that analyzes dock video feeds in real time, plays gentle audio chimes on rough handling, and saves short video evidence clips.</a:t>
+              <a:t>If you catch a cracked box before it's loaded into the trailer, replacing it costs $10. If it reaches the customer, it costs $200+ and a bad review.</a:t>
             </a:r>
           </a:p>
         </p:txBody>
@@ -3712,14 +3736,67 @@
       </p:sp>
       <p:sp>
         <p:nvSpPr>
-          <p:cNvPr id="3" name="TextBox 2"/>
+          <p:cNvPr id="3" name="Rounded Rectangle 2"/>
+          <p:cNvSpPr/>
+          <p:nvPr/>
+        </p:nvSpPr>
+        <p:spPr>
+          <a:xfrm>
+            <a:off x="731520" y="365760"/>
+            <a:ext cx="2560320" cy="292608"/>
+          </a:xfrm>
+          <a:prstGeom prst="roundRect">
+            <a:avLst/>
+          </a:prstGeom>
+          <a:solidFill>
+            <a:srgbClr val="F3E8FF"/>
+          </a:solidFill>
+          <a:ln>
+            <a:noFill/>
+          </a:ln>
+        </p:spPr>
+        <p:style>
+          <a:lnRef idx="1">
+            <a:schemeClr val="accent1"/>
+          </a:lnRef>
+          <a:fillRef idx="3">
+            <a:schemeClr val="accent1"/>
+          </a:fillRef>
+          <a:effectRef idx="2">
+            <a:schemeClr val="accent1"/>
+          </a:effectRef>
+          <a:fontRef idx="minor">
+            <a:schemeClr val="lt1"/>
+          </a:fontRef>
+        </p:style>
+        <p:txBody>
+          <a:bodyPr rtlCol="0" anchor="ctr" wrap="none"/>
+          <a:lstStyle/>
+          <a:p>
+            <a:pPr algn="ctr">
+              <a:defRPr sz="950" b="1">
+                <a:solidFill>
+                  <a:srgbClr val="6D28D9"/>
+                </a:solidFill>
+                <a:latin typeface="Segoe UI"/>
+              </a:defRPr>
+            </a:pPr>
+            <a:r>
+              <a:t>SLIDE 2: PROBLEM, SOLUTION &amp; USER JOURNEY</a:t>
+            </a:r>
+          </a:p>
+        </p:txBody>
+      </p:sp>
+      <p:sp>
+        <p:nvSpPr>
+          <p:cNvPr id="4" name="TextBox 3"/>
           <p:cNvSpPr txBox="1"/>
           <p:nvPr/>
         </p:nvSpPr>
         <p:spPr>
           <a:xfrm>
-            <a:off x="731520" y="365760"/>
-            <a:ext cx="8229600" cy="274320"/>
+            <a:off x="731520" y="713232"/>
+            <a:ext cx="9601200" cy="502920"/>
           </a:xfrm>
           <a:prstGeom prst="rect">
             <a:avLst/>
@@ -3733,51 +3810,15 @@
           <a:lstStyle/>
           <a:p>
             <a:pPr>
-              <a:defRPr sz="1000" b="1">
-                <a:solidFill>
-                  <a:srgbClr val="2563EB"/>
-                </a:solidFill>
-                <a:latin typeface="Calibri"/>
-              </a:defRPr>
-            </a:pPr>
-            <a:r>
-              <a:t>SLIDE 2: PROBLEM, SOLUTION &amp; USER JOURNEY</a:t>
-            </a:r>
-          </a:p>
-        </p:txBody>
-      </p:sp>
-      <p:sp>
-        <p:nvSpPr>
-          <p:cNvPr id="4" name="TextBox 3"/>
-          <p:cNvSpPr txBox="1"/>
-          <p:nvPr/>
-        </p:nvSpPr>
-        <p:spPr>
-          <a:xfrm>
-            <a:off x="731520" y="621792"/>
-            <a:ext cx="9601200" cy="548640"/>
-          </a:xfrm>
-          <a:prstGeom prst="rect">
-            <a:avLst/>
-          </a:prstGeom>
-          <a:noFill/>
-        </p:spPr>
-        <p:txBody>
-          <a:bodyPr wrap="square" lIns="0" tIns="0" rIns="0" bIns="0">
-            <a:spAutoFit/>
-          </a:bodyPr>
-          <a:lstStyle/>
-          <a:p>
-            <a:pPr>
-              <a:defRPr sz="2200" b="1">
-                <a:solidFill>
-                  <a:srgbClr val="1E3A8A"/>
-                </a:solidFill>
-                <a:latin typeface="Calibri"/>
-              </a:defRPr>
-            </a:pPr>
-            <a:r>
-              <a:t>How the System Works &amp; Who Uses It</a:t>
+              <a:defRPr sz="2100" b="1">
+                <a:solidFill>
+                  <a:srgbClr val="182B49"/>
+                </a:solidFill>
+                <a:latin typeface="Segoe UI"/>
+              </a:defRPr>
+            </a:pPr>
+            <a:r>
+              <a:t>The Mystery of the Smashed Box (And How We Catch It)</a:t>
             </a:r>
           </a:p>
         </p:txBody>
@@ -3790,7 +3831,7 @@
         </p:nvSpPr>
         <p:spPr>
           <a:xfrm>
-            <a:off x="731520" y="1188720"/>
+            <a:off x="731520" y="1243584"/>
             <a:ext cx="10728655" cy="13716"/>
           </a:xfrm>
           <a:prstGeom prst="rect">
@@ -3895,9 +3936,9 @@
             <a:pPr algn="ctr">
               <a:defRPr sz="1000" b="1">
                 <a:solidFill>
-                  <a:srgbClr val="1F2937"/>
-                </a:solidFill>
-                <a:latin typeface="Calibri"/>
+                  <a:srgbClr val="182B49"/>
+                </a:solidFill>
+                <a:latin typeface="Segoe UI"/>
               </a:defRPr>
             </a:pPr>
             <a:r>
@@ -3911,13 +3952,13 @@
               </a:spcBef>
               <a:defRPr sz="850">
                 <a:solidFill>
-                  <a:srgbClr val="6B7280"/>
-                </a:solidFill>
-                <a:latin typeface="Calibri"/>
-              </a:defRPr>
-            </a:pPr>
-            <a:r>
-              <a:t>Workers load boxes into trucks</a:t>
+                  <a:srgbClr val="64748B"/>
+                </a:solidFill>
+                <a:latin typeface="Segoe UI"/>
+              </a:defRPr>
+            </a:pPr>
+            <a:r>
+              <a:t>Workers move cartons into trucks</a:t>
             </a:r>
           </a:p>
         </p:txBody>
@@ -3992,13 +4033,13 @@
             <a:pPr algn="ctr">
               <a:defRPr sz="1000" b="1">
                 <a:solidFill>
-                  <a:srgbClr val="1F2937"/>
-                </a:solidFill>
-                <a:latin typeface="Calibri"/>
-              </a:defRPr>
-            </a:pPr>
-            <a:r>
-              <a:t>2. CCTV Video</a:t>
+                  <a:srgbClr val="182B49"/>
+                </a:solidFill>
+                <a:latin typeface="Segoe UI"/>
+              </a:defRPr>
+            </a:pPr>
+            <a:r>
+              <a:t>2. CCTV Camera</a:t>
             </a:r>
           </a:p>
           <a:p>
@@ -4008,13 +4049,13 @@
               </a:spcBef>
               <a:defRPr sz="850">
                 <a:solidFill>
-                  <a:srgbClr val="6B7280"/>
-                </a:solidFill>
-                <a:latin typeface="Calibri"/>
-              </a:defRPr>
-            </a:pPr>
-            <a:r>
-              <a:t>Normal security camera stream</a:t>
+                  <a:srgbClr val="64748B"/>
+                </a:solidFill>
+                <a:latin typeface="Segoe UI"/>
+              </a:defRPr>
+            </a:pPr>
+            <a:r>
+              <a:t>Standard security camera feed</a:t>
             </a:r>
           </a:p>
         </p:txBody>
@@ -4089,13 +4130,13 @@
             <a:pPr algn="ctr">
               <a:defRPr sz="1000" b="1">
                 <a:solidFill>
-                  <a:srgbClr val="1F2937"/>
-                </a:solidFill>
-                <a:latin typeface="Calibri"/>
-              </a:defRPr>
-            </a:pPr>
-            <a:r>
-              <a:t>3. AI Tracking</a:t>
+                  <a:srgbClr val="182B49"/>
+                </a:solidFill>
+                <a:latin typeface="Segoe UI"/>
+              </a:defRPr>
+            </a:pPr>
+            <a:r>
+              <a:t>3. AI Eyes</a:t>
             </a:r>
           </a:p>
           <a:p>
@@ -4105,13 +4146,13 @@
               </a:spcBef>
               <a:defRPr sz="850">
                 <a:solidFill>
-                  <a:srgbClr val="6B7280"/>
-                </a:solidFill>
-                <a:latin typeface="Calibri"/>
-              </a:defRPr>
-            </a:pPr>
-            <a:r>
-              <a:t>YOLOv8 tracks boxes &amp; workers</a:t>
+                  <a:srgbClr val="64748B"/>
+                </a:solidFill>
+                <a:latin typeface="Segoe UI"/>
+              </a:defRPr>
+            </a:pPr>
+            <a:r>
+              <a:t>YOLOv8 tracks every box &amp; person</a:t>
             </a:r>
           </a:p>
         </p:txBody>
@@ -4131,11 +4172,11 @@
             <a:avLst/>
           </a:prstGeom>
           <a:solidFill>
-            <a:srgbClr val="EFF6FF"/>
+            <a:srgbClr val="F3E8FF"/>
           </a:solidFill>
           <a:ln w="19050">
             <a:solidFill>
-              <a:srgbClr val="2563EB"/>
+              <a:srgbClr val="6D28D9"/>
             </a:solidFill>
           </a:ln>
         </p:spPr>
@@ -4186,13 +4227,13 @@
             <a:pPr algn="ctr">
               <a:defRPr sz="1000" b="1">
                 <a:solidFill>
-                  <a:srgbClr val="1E3A8A"/>
-                </a:solidFill>
-                <a:latin typeface="Calibri"/>
-              </a:defRPr>
-            </a:pPr>
-            <a:r>
-              <a:t>4. Risk Check</a:t>
+                  <a:srgbClr val="6D28D9"/>
+                </a:solidFill>
+                <a:latin typeface="Segoe UI"/>
+              </a:defRPr>
+            </a:pPr>
+            <a:r>
+              <a:t>4. Danger!</a:t>
             </a:r>
           </a:p>
           <a:p>
@@ -4202,13 +4243,13 @@
               </a:spcBef>
               <a:defRPr sz="850">
                 <a:solidFill>
-                  <a:srgbClr val="6B7280"/>
-                </a:solidFill>
-                <a:latin typeface="Calibri"/>
-              </a:defRPr>
-            </a:pPr>
-            <a:r>
-              <a:t>Speed, drop, or drag detected</a:t>
+                  <a:srgbClr val="64748B"/>
+                </a:solidFill>
+                <a:latin typeface="Segoe UI"/>
+              </a:defRPr>
+            </a:pPr>
+            <a:r>
+              <a:t>Speed spike or ground drag flagged</a:t>
             </a:r>
           </a:p>
         </p:txBody>
@@ -4228,11 +4269,11 @@
             <a:avLst/>
           </a:prstGeom>
           <a:solidFill>
-            <a:srgbClr val="EFF6FF"/>
+            <a:srgbClr val="F3E8FF"/>
           </a:solidFill>
           <a:ln w="19050">
             <a:solidFill>
-              <a:srgbClr val="2563EB"/>
+              <a:srgbClr val="6D28D9"/>
             </a:solidFill>
           </a:ln>
         </p:spPr>
@@ -4283,13 +4324,13 @@
             <a:pPr algn="ctr">
               <a:defRPr sz="1000" b="1">
                 <a:solidFill>
-                  <a:srgbClr val="1E3A8A"/>
-                </a:solidFill>
-                <a:latin typeface="Calibri"/>
-              </a:defRPr>
-            </a:pPr>
-            <a:r>
-              <a:t>5. Dock Alert</a:t>
+                  <a:srgbClr val="6D28D9"/>
+                </a:solidFill>
+                <a:latin typeface="Segoe UI"/>
+              </a:defRPr>
+            </a:pPr>
+            <a:r>
+              <a:t>5. Friendly Chime</a:t>
             </a:r>
           </a:p>
           <a:p>
@@ -4299,13 +4340,13 @@
               </a:spcBef>
               <a:defRPr sz="850">
                 <a:solidFill>
-                  <a:srgbClr val="6B7280"/>
-                </a:solidFill>
-                <a:latin typeface="Calibri"/>
-              </a:defRPr>
-            </a:pPr>
-            <a:r>
-              <a:t>Chime rings &amp; UI flags event</a:t>
+                  <a:srgbClr val="64748B"/>
+                </a:solidFill>
+                <a:latin typeface="Segoe UI"/>
+              </a:defRPr>
+            </a:pPr>
+            <a:r>
+              <a:t>Polite sound alert at the dock</a:t>
             </a:r>
           </a:p>
         </p:txBody>
@@ -4380,13 +4421,13 @@
             <a:pPr algn="ctr">
               <a:defRPr sz="1000" b="1">
                 <a:solidFill>
-                  <a:srgbClr val="1F2937"/>
-                </a:solidFill>
-                <a:latin typeface="Calibri"/>
-              </a:defRPr>
-            </a:pPr>
-            <a:r>
-              <a:t>6. Worker Action</a:t>
+                  <a:srgbClr val="182B49"/>
+                </a:solidFill>
+                <a:latin typeface="Segoe UI"/>
+              </a:defRPr>
+            </a:pPr>
+            <a:r>
+              <a:t>6. Quick Check</a:t>
             </a:r>
           </a:p>
           <a:p>
@@ -4396,13 +4437,13 @@
               </a:spcBef>
               <a:defRPr sz="850">
                 <a:solidFill>
-                  <a:srgbClr val="6B7280"/>
-                </a:solidFill>
-                <a:latin typeface="Calibri"/>
-              </a:defRPr>
-            </a:pPr>
-            <a:r>
-              <a:t>Operator checks box immediately</a:t>
+                  <a:srgbClr val="64748B"/>
+                </a:solidFill>
+                <a:latin typeface="Segoe UI"/>
+              </a:defRPr>
+            </a:pPr>
+            <a:r>
+              <a:t>Worker inspects &amp; resets load</a:t>
             </a:r>
           </a:p>
         </p:txBody>
@@ -4422,11 +4463,11 @@
             <a:avLst/>
           </a:prstGeom>
           <a:solidFill>
-            <a:srgbClr val="EFF6FF"/>
+            <a:srgbClr val="F3E8FF"/>
           </a:solidFill>
           <a:ln w="19050">
             <a:solidFill>
-              <a:srgbClr val="2563EB"/>
+              <a:srgbClr val="6D28D9"/>
             </a:solidFill>
           </a:ln>
         </p:spPr>
@@ -4477,13 +4518,13 @@
             <a:pPr algn="ctr">
               <a:defRPr sz="1000" b="1">
                 <a:solidFill>
-                  <a:srgbClr val="1E3A8A"/>
-                </a:solidFill>
-                <a:latin typeface="Calibri"/>
-              </a:defRPr>
-            </a:pPr>
-            <a:r>
-              <a:t>7. Result</a:t>
+                  <a:srgbClr val="6D28D9"/>
+                </a:solidFill>
+                <a:latin typeface="Segoe UI"/>
+              </a:defRPr>
+            </a:pPr>
+            <a:r>
+              <a:t>7. Zero Damage</a:t>
             </a:r>
           </a:p>
           <a:p>
@@ -4493,13 +4534,13 @@
               </a:spcBef>
               <a:defRPr sz="850">
                 <a:solidFill>
-                  <a:srgbClr val="6B7280"/>
-                </a:solidFill>
-                <a:latin typeface="Calibri"/>
-              </a:defRPr>
-            </a:pPr>
-            <a:r>
-              <a:t>Zero broken cargo shipped</a:t>
+                  <a:srgbClr val="64748B"/>
+                </a:solidFill>
+                <a:latin typeface="Segoe UI"/>
+              </a:defRPr>
+            </a:pPr>
+            <a:r>
+              <a:t>Shipment leaves 100% intact</a:t>
             </a:r>
           </a:p>
         </p:txBody>
@@ -4574,13 +4615,13 @@
             <a:pPr>
               <a:defRPr sz="1100" b="1">
                 <a:solidFill>
-                  <a:srgbClr val="1E3A8A"/>
-                </a:solidFill>
-                <a:latin typeface="Calibri"/>
-              </a:defRPr>
-            </a:pPr>
-            <a:r>
-              <a:t>USER JOURNEY 1: Loading Bay Worker (Ramesh)</a:t>
+                  <a:srgbClr val="182B49"/>
+                </a:solidFill>
+                <a:latin typeface="Segoe UI"/>
+              </a:defRPr>
+            </a:pPr>
+            <a:r>
+              <a:t>THE LOADER'S STORY: Ramesh at Loading Bay 3</a:t>
             </a:r>
           </a:p>
           <a:p>
@@ -4590,21 +4631,21 @@
               </a:spcBef>
               <a:defRPr sz="950" b="1">
                 <a:solidFill>
-                  <a:srgbClr val="1F2937"/>
-                </a:solidFill>
-                <a:latin typeface="Calibri"/>
-              </a:defRPr>
-            </a:pPr>
-            <a:r>
-              <a:t>• Starting the shift: </a:t>
+                  <a:srgbClr val="334155"/>
+                </a:solidFill>
+                <a:latin typeface="Segoe UI"/>
+              </a:defRPr>
+            </a:pPr>
+            <a:r>
+              <a:t>• The Rush: </a:t>
             </a:r>
             <a:r>
               <a:rPr b="0">
                 <a:solidFill>
-                  <a:srgbClr val="6B7280"/>
+                  <a:srgbClr val="64748B"/>
                 </a:solidFill>
               </a:rPr>
-              <a:t>Ramesh begins unloading 30kg appliance cartons from a delivery container at Bay 3.</a:t>
+              <a:t>It's 4:15 PM, 34°C, and Ramesh has 45 minutes to finish packing a 40-foot trailer.</a:t>
             </a:r>
           </a:p>
           <a:p>
@@ -4614,21 +4655,21 @@
               </a:spcBef>
               <a:defRPr sz="950" b="1">
                 <a:solidFill>
-                  <a:srgbClr val="1F2937"/>
-                </a:solidFill>
-                <a:latin typeface="Calibri"/>
-              </a:defRPr>
-            </a:pPr>
-            <a:r>
-              <a:t>• A drop happens: </a:t>
+                  <a:srgbClr val="334155"/>
+                </a:solidFill>
+                <a:latin typeface="Segoe UI"/>
+              </a:defRPr>
+            </a:pPr>
+            <a:r>
+              <a:t>• The Slip: </a:t>
             </a:r>
             <a:r>
               <a:rPr b="0">
                 <a:solidFill>
-                  <a:srgbClr val="6B7280"/>
+                  <a:srgbClr val="64748B"/>
                 </a:solidFill>
               </a:rPr>
-              <a:t>While rushing, a carton slips from his grip and falls roughly 1.3 meters to the concrete floor.</a:t>
+              <a:t>He lifts a 25kg crate without a partner. His grip slips, and the box crashes 1.2 meters to the concrete.</a:t>
             </a:r>
           </a:p>
           <a:p>
@@ -4638,21 +4679,21 @@
               </a:spcBef>
               <a:defRPr sz="950" b="1">
                 <a:solidFill>
-                  <a:srgbClr val="1F2937"/>
-                </a:solidFill>
-                <a:latin typeface="Calibri"/>
-              </a:defRPr>
-            </a:pPr>
-            <a:r>
-              <a:t>• Immediate feedback: </a:t>
+                  <a:srgbClr val="334155"/>
+                </a:solidFill>
+                <a:latin typeface="Segoe UI"/>
+              </a:defRPr>
+            </a:pPr>
+            <a:r>
+              <a:t>• No Panic Siren: </a:t>
             </a:r>
             <a:r>
               <a:rPr b="0">
                 <a:solidFill>
-                  <a:srgbClr val="6B7280"/>
+                  <a:srgbClr val="64748B"/>
                 </a:solidFill>
               </a:rPr>
-              <a:t>Within one second, a distinct audio chime rings from the dock speaker, and the light on the dock screen turns amber.</a:t>
+              <a:t>Instead of an ear-piercing fire alarm that makes everyone freeze, a friendly, microwave-style *ding* chimes at Bay 3, and his dock screen flashes yellow.</a:t>
             </a:r>
           </a:p>
           <a:p>
@@ -4662,21 +4703,21 @@
               </a:spcBef>
               <a:defRPr sz="950" b="1">
                 <a:solidFill>
-                  <a:srgbClr val="1F2937"/>
-                </a:solidFill>
-                <a:latin typeface="Calibri"/>
-              </a:defRPr>
-            </a:pPr>
-            <a:r>
-              <a:t>• What Ramesh does: </a:t>
+                  <a:srgbClr val="334155"/>
+                </a:solidFill>
+                <a:latin typeface="Segoe UI"/>
+              </a:defRPr>
+            </a:pPr>
+            <a:r>
+              <a:t>• What He Does: </a:t>
             </a:r>
             <a:r>
               <a:rPr b="0">
                 <a:solidFill>
-                  <a:srgbClr val="6B7280"/>
+                  <a:srgbClr val="64748B"/>
                 </a:solidFill>
               </a:rPr>
-              <a:t>Instead of pushing the broken box into the truck, Ramesh stops, inspects the carton tape, calls his partner for a 2-person lift, and sets the item aside for inspection.</a:t>
+              <a:t>Instead of sheepishly hiding the box in the back of the truck, Ramesh stops, inspects the tape, calls his teammate for a 2-person lift, and sets the item aside.</a:t>
             </a:r>
           </a:p>
           <a:p>
@@ -4686,21 +4727,21 @@
               </a:spcBef>
               <a:defRPr sz="950" b="1">
                 <a:solidFill>
-                  <a:srgbClr val="1F2937"/>
-                </a:solidFill>
-                <a:latin typeface="Calibri"/>
-              </a:defRPr>
-            </a:pPr>
-            <a:r>
-              <a:t>• The outcome: </a:t>
+                  <a:srgbClr val="334155"/>
+                </a:solidFill>
+                <a:latin typeface="Segoe UI"/>
+              </a:defRPr>
+            </a:pPr>
+            <a:r>
+              <a:t>• The Win: </a:t>
             </a:r>
             <a:r>
               <a:rPr b="0">
                 <a:solidFill>
-                  <a:srgbClr val="6B7280"/>
+                  <a:srgbClr val="64748B"/>
                 </a:solidFill>
               </a:rPr>
-              <a:t>The damaged appliance is caught before shipment, avoiding an expensive customer complaint.</a:t>
+              <a:t>No broken microwave sent to a furious customer, and Ramesh learns to ask for a hand with heavy loads.</a:t>
             </a:r>
           </a:p>
         </p:txBody>
@@ -4775,13 +4816,13 @@
             <a:pPr>
               <a:defRPr sz="1100" b="1">
                 <a:solidFill>
-                  <a:srgbClr val="1E3A8A"/>
-                </a:solidFill>
-                <a:latin typeface="Calibri"/>
-              </a:defRPr>
-            </a:pPr>
-            <a:r>
-              <a:t>USER JOURNEY 2: Warehouse Supervisor (Pooja)</a:t>
+                  <a:srgbClr val="6D28D9"/>
+                </a:solidFill>
+                <a:latin typeface="Segoe UI"/>
+              </a:defRPr>
+            </a:pPr>
+            <a:r>
+              <a:t>THE SUPERVISOR'S STORY: Pooja with her iPad</a:t>
             </a:r>
           </a:p>
           <a:p>
@@ -4791,21 +4832,21 @@
               </a:spcBef>
               <a:defRPr sz="950" b="1">
                 <a:solidFill>
-                  <a:srgbClr val="1F2937"/>
-                </a:solidFill>
-                <a:latin typeface="Calibri"/>
-              </a:defRPr>
-            </a:pPr>
-            <a:r>
-              <a:t>• Managing the dock: </a:t>
+                  <a:srgbClr val="334155"/>
+                </a:solidFill>
+                <a:latin typeface="Segoe UI"/>
+              </a:defRPr>
+            </a:pPr>
+            <a:r>
+              <a:t>• The Daily Nightmare: </a:t>
             </a:r>
             <a:r>
               <a:rPr b="0">
                 <a:solidFill>
-                  <a:srgbClr val="6B7280"/>
+                  <a:srgbClr val="64748B"/>
                 </a:solidFill>
               </a:rPr>
-              <a:t>Pooja oversees 6 active loading bays from her tablet while walking the floor.</a:t>
+              <a:t>Pooja used to spend 45 minutes every evening fast-forwarding through blurry CCTV tapes trying to figure out who dropped a customer's TV.</a:t>
             </a:r>
           </a:p>
           <a:p>
@@ -4815,21 +4856,21 @@
               </a:spcBef>
               <a:defRPr sz="950" b="1">
                 <a:solidFill>
-                  <a:srgbClr val="1F2937"/>
-                </a:solidFill>
-                <a:latin typeface="Calibri"/>
-              </a:defRPr>
-            </a:pPr>
-            <a:r>
-              <a:t>• Instant incident alert: </a:t>
+                  <a:srgbClr val="334155"/>
+                </a:solidFill>
+                <a:latin typeface="Segoe UI"/>
+              </a:defRPr>
+            </a:pPr>
+            <a:r>
+              <a:t>• Instant Notification: </a:t>
             </a:r>
             <a:r>
               <a:rPr b="0">
                 <a:solidFill>
-                  <a:srgbClr val="6B7280"/>
+                  <a:srgbClr val="64748B"/>
                 </a:solidFill>
               </a:rPr>
-              <a:t>Her screen shows a notification: 'Bay 3: High-Velocity Drop Detected (10:14 AM)'.</a:t>
+              <a:t>Her tablet buzzes: 'Bay 3: High-Velocity Drop Flagged (10:14 AM)'.</a:t>
             </a:r>
           </a:p>
           <a:p>
@@ -4839,21 +4880,21 @@
               </a:spcBef>
               <a:defRPr sz="950" b="1">
                 <a:solidFill>
-                  <a:srgbClr val="1F2937"/>
-                </a:solidFill>
-                <a:latin typeface="Calibri"/>
-              </a:defRPr>
-            </a:pPr>
-            <a:r>
-              <a:t>• Checking the evidence: </a:t>
+                  <a:srgbClr val="334155"/>
+                </a:solidFill>
+                <a:latin typeface="Segoe UI"/>
+              </a:defRPr>
+            </a:pPr>
+            <a:r>
+              <a:t>• TikTok-Length Replay: </a:t>
             </a:r>
             <a:r>
               <a:rPr b="0">
                 <a:solidFill>
-                  <a:srgbClr val="6B7280"/>
+                  <a:srgbClr val="64748B"/>
                 </a:solidFill>
               </a:rPr>
-              <a:t>She taps the notification, which immediately opens a short 5-second replay clip showing the carton falling with bounding box tracking.</a:t>
+              <a:t>She taps it and immediately watches a 5-second replay showing the carton falling, complete with bounding box tracking and impact velocity.</a:t>
             </a:r>
           </a:p>
           <a:p>
@@ -4863,21 +4904,21 @@
               </a:spcBef>
               <a:defRPr sz="950" b="1">
                 <a:solidFill>
-                  <a:srgbClr val="1F2937"/>
-                </a:solidFill>
-                <a:latin typeface="Calibri"/>
-              </a:defRPr>
-            </a:pPr>
-            <a:r>
-              <a:t>• Quick decision: </a:t>
+                  <a:srgbClr val="334155"/>
+                </a:solidFill>
+                <a:latin typeface="Segoe UI"/>
+              </a:defRPr>
+            </a:pPr>
+            <a:r>
+              <a:t>• Quick Resolution: </a:t>
             </a:r>
             <a:r>
               <a:rPr b="0">
                 <a:solidFill>
-                  <a:srgbClr val="6B7280"/>
+                  <a:srgbClr val="64748B"/>
                 </a:solidFill>
               </a:rPr>
-              <a:t>She radios the Bay 3 team to replace the packaging and logs the issue as resolved with one click.</a:t>
+              <a:t>She signs off on a packaging replacement in 10 seconds flat—no shouting matches, no guessing.</a:t>
             </a:r>
           </a:p>
           <a:p>
@@ -4887,21 +4928,21 @@
               </a:spcBef>
               <a:defRPr sz="950" b="1">
                 <a:solidFill>
-                  <a:srgbClr val="1F2937"/>
-                </a:solidFill>
-                <a:latin typeface="Calibri"/>
-              </a:defRPr>
-            </a:pPr>
-            <a:r>
-              <a:t>• Using the AI Assistant: </a:t>
+                  <a:srgbClr val="334155"/>
+                </a:solidFill>
+                <a:latin typeface="Segoe UI"/>
+              </a:defRPr>
+            </a:pPr>
+            <a:r>
+              <a:t>• Asking the AI: </a:t>
             </a:r>
             <a:r>
               <a:rPr b="0">
                 <a:solidFill>
-                  <a:srgbClr val="6B7280"/>
+                  <a:srgbClr val="64748B"/>
                 </a:solidFill>
               </a:rPr>
-              <a:t>At the end of the shift, Pooja asks the AI chatbot: 'Which bay had the most handling warnings today?' to plan tomorrow's safety briefing.</a:t>
+              <a:t>At the end of the week, she asks the Gemini chat: 'Which shift has the most drops?' and instantly gets an answer for Monday's safety huddle.</a:t>
             </a:r>
           </a:p>
         </p:txBody>
@@ -4969,14 +5010,67 @@
       </p:sp>
       <p:sp>
         <p:nvSpPr>
-          <p:cNvPr id="3" name="TextBox 2"/>
+          <p:cNvPr id="3" name="Rounded Rectangle 2"/>
+          <p:cNvSpPr/>
+          <p:nvPr/>
+        </p:nvSpPr>
+        <p:spPr>
+          <a:xfrm>
+            <a:off x="731520" y="365760"/>
+            <a:ext cx="2560320" cy="292608"/>
+          </a:xfrm>
+          <a:prstGeom prst="roundRect">
+            <a:avLst/>
+          </a:prstGeom>
+          <a:solidFill>
+            <a:srgbClr val="F3E8FF"/>
+          </a:solidFill>
+          <a:ln>
+            <a:noFill/>
+          </a:ln>
+        </p:spPr>
+        <p:style>
+          <a:lnRef idx="1">
+            <a:schemeClr val="accent1"/>
+          </a:lnRef>
+          <a:fillRef idx="3">
+            <a:schemeClr val="accent1"/>
+          </a:fillRef>
+          <a:effectRef idx="2">
+            <a:schemeClr val="accent1"/>
+          </a:effectRef>
+          <a:fontRef idx="minor">
+            <a:schemeClr val="lt1"/>
+          </a:fontRef>
+        </p:style>
+        <p:txBody>
+          <a:bodyPr rtlCol="0" anchor="ctr" wrap="none"/>
+          <a:lstStyle/>
+          <a:p>
+            <a:pPr algn="ctr">
+              <a:defRPr sz="950" b="1">
+                <a:solidFill>
+                  <a:srgbClr val="6D28D9"/>
+                </a:solidFill>
+                <a:latin typeface="Segoe UI"/>
+              </a:defRPr>
+            </a:pPr>
+            <a:r>
+              <a:t>SLIDE 3: TECHNICAL ARCHITECTURE &amp; TECH STACK</a:t>
+            </a:r>
+          </a:p>
+        </p:txBody>
+      </p:sp>
+      <p:sp>
+        <p:nvSpPr>
+          <p:cNvPr id="4" name="TextBox 3"/>
           <p:cNvSpPr txBox="1"/>
           <p:nvPr/>
         </p:nvSpPr>
         <p:spPr>
           <a:xfrm>
-            <a:off x="731520" y="365760"/>
-            <a:ext cx="8229600" cy="274320"/>
+            <a:off x="731520" y="713232"/>
+            <a:ext cx="9601200" cy="502920"/>
           </a:xfrm>
           <a:prstGeom prst="rect">
             <a:avLst/>
@@ -4990,51 +5084,15 @@
           <a:lstStyle/>
           <a:p>
             <a:pPr>
-              <a:defRPr sz="1000" b="1">
-                <a:solidFill>
-                  <a:srgbClr val="2563EB"/>
-                </a:solidFill>
-                <a:latin typeface="Calibri"/>
-              </a:defRPr>
-            </a:pPr>
-            <a:r>
-              <a:t>SLIDE 3: TECHNICAL ARCHITECTURE &amp; TECHNOLOGY STACK</a:t>
-            </a:r>
-          </a:p>
-        </p:txBody>
-      </p:sp>
-      <p:sp>
-        <p:nvSpPr>
-          <p:cNvPr id="4" name="TextBox 3"/>
-          <p:cNvSpPr txBox="1"/>
-          <p:nvPr/>
-        </p:nvSpPr>
-        <p:spPr>
-          <a:xfrm>
-            <a:off x="731520" y="621792"/>
-            <a:ext cx="9601200" cy="548640"/>
-          </a:xfrm>
-          <a:prstGeom prst="rect">
-            <a:avLst/>
-          </a:prstGeom>
-          <a:noFill/>
-        </p:spPr>
-        <p:txBody>
-          <a:bodyPr wrap="square" lIns="0" tIns="0" rIns="0" bIns="0">
-            <a:spAutoFit/>
-          </a:bodyPr>
-          <a:lstStyle/>
-          <a:p>
-            <a:pPr>
-              <a:defRPr sz="2200" b="1">
-                <a:solidFill>
-                  <a:srgbClr val="1E3A8A"/>
-                </a:solidFill>
-                <a:latin typeface="Calibri"/>
-              </a:defRPr>
-            </a:pPr>
-            <a:r>
-              <a:t>System Architecture &amp; Technologies Used</a:t>
+              <a:defRPr sz="2100" b="1">
+                <a:solidFill>
+                  <a:srgbClr val="182B49"/>
+                </a:solidFill>
+                <a:latin typeface="Segoe UI"/>
+              </a:defRPr>
+            </a:pPr>
+            <a:r>
+              <a:t>Under the Hood: How We Taught Cameras to Care About Boxes</a:t>
             </a:r>
           </a:p>
         </p:txBody>
@@ -5062,15 +5120,15 @@
           <a:lstStyle/>
           <a:p>
             <a:pPr algn="r">
-              <a:defRPr sz="900" b="1">
-                <a:solidFill>
-                  <a:srgbClr val="DC2626"/>
-                </a:solidFill>
-                <a:latin typeface="Calibri"/>
-              </a:defRPr>
-            </a:pPr>
-            <a:r>
-              <a:t>Confidential - Academic Project</a:t>
+              <a:defRPr sz="850" b="1">
+                <a:solidFill>
+                  <a:srgbClr val="E11D48"/>
+                </a:solidFill>
+                <a:latin typeface="Segoe UI"/>
+              </a:defRPr>
+            </a:pPr>
+            <a:r>
+              <a:t>Confidential - Hackathon Project</a:t>
             </a:r>
           </a:p>
         </p:txBody>
@@ -5083,7 +5141,7 @@
         </p:nvSpPr>
         <p:spPr>
           <a:xfrm>
-            <a:off x="731520" y="1188720"/>
+            <a:off x="731520" y="1243584"/>
             <a:ext cx="10728655" cy="13716"/>
           </a:xfrm>
           <a:prstGeom prst="rect">
@@ -5231,13 +5289,13 @@
             <a:pPr>
               <a:defRPr sz="1100" b="1">
                 <a:solidFill>
-                  <a:srgbClr val="1E3A8A"/>
-                </a:solidFill>
-                <a:latin typeface="Calibri"/>
-              </a:defRPr>
-            </a:pPr>
-            <a:r>
-              <a:t>1. Computer Vision</a:t>
+                  <a:srgbClr val="182B49"/>
+                </a:solidFill>
+                <a:latin typeface="Segoe UI"/>
+              </a:defRPr>
+            </a:pPr>
+            <a:r>
+              <a:t>1. Computer Vision (YOLOv8 + ByteTrack)</a:t>
             </a:r>
           </a:p>
           <a:p>
@@ -5247,21 +5305,21 @@
               </a:spcBef>
               <a:defRPr sz="950" b="1">
                 <a:solidFill>
-                  <a:srgbClr val="1F2937"/>
-                </a:solidFill>
-                <a:latin typeface="Calibri"/>
-              </a:defRPr>
-            </a:pPr>
-            <a:r>
-              <a:t>• Model: </a:t>
+                  <a:srgbClr val="334155"/>
+                </a:solidFill>
+                <a:latin typeface="Segoe UI"/>
+              </a:defRPr>
+            </a:pPr>
+            <a:r>
+              <a:t>• The Model: </a:t>
             </a:r>
             <a:r>
               <a:rPr b="0">
                 <a:solidFill>
-                  <a:srgbClr val="6B7280"/>
+                  <a:srgbClr val="64748B"/>
                 </a:solidFill>
               </a:rPr>
-              <a:t>YOLOv8 (Ultralytics)</a:t>
+              <a:t>Ultralytics YOLOv8 fine-tuned on warehouse objects.</a:t>
             </a:r>
           </a:p>
           <a:p>
@@ -5271,21 +5329,21 @@
               </a:spcBef>
               <a:defRPr sz="950" b="1">
                 <a:solidFill>
-                  <a:srgbClr val="1F2937"/>
-                </a:solidFill>
-                <a:latin typeface="Calibri"/>
-              </a:defRPr>
-            </a:pPr>
-            <a:r>
-              <a:t>• What it detects: </a:t>
+                  <a:srgbClr val="334155"/>
+                </a:solidFill>
+                <a:latin typeface="Segoe UI"/>
+              </a:defRPr>
+            </a:pPr>
+            <a:r>
+              <a:t>• What it sees: </a:t>
             </a:r>
             <a:r>
               <a:rPr b="0">
                 <a:solidFill>
-                  <a:srgbClr val="6B7280"/>
+                  <a:srgbClr val="64748B"/>
                 </a:solidFill>
               </a:rPr>
-              <a:t>Workers, cartons, pallets, and forklift vehicles in each video frame.</a:t>
+              <a:t>Workers, cardboard cartons, wooden pallets, and forklifts.</a:t>
             </a:r>
           </a:p>
           <a:p>
@@ -5295,21 +5353,21 @@
               </a:spcBef>
               <a:defRPr sz="950" b="1">
                 <a:solidFill>
-                  <a:srgbClr val="1F2937"/>
-                </a:solidFill>
-                <a:latin typeface="Calibri"/>
-              </a:defRPr>
-            </a:pPr>
-            <a:r>
-              <a:t>• Tracking: </a:t>
+                  <a:srgbClr val="334155"/>
+                </a:solidFill>
+                <a:latin typeface="Segoe UI"/>
+              </a:defRPr>
+            </a:pPr>
+            <a:r>
+              <a:t>• The ByteTrack Trick: </a:t>
             </a:r>
             <a:r>
               <a:rPr b="0">
                 <a:solidFill>
-                  <a:srgbClr val="6B7280"/>
+                  <a:srgbClr val="64748B"/>
                 </a:solidFill>
               </a:rPr>
-              <a:t>ByteTrack to follow individual boxes across frames even when temporarily blocked.</a:t>
+              <a:t>Keeps track of 'Box #4' even when a worker walks in front of it so the ID doesn't get lost.</a:t>
             </a:r>
           </a:p>
         </p:txBody>
@@ -5374,7 +5432,7 @@
             <a:avLst/>
           </a:prstGeom>
           <a:solidFill>
-            <a:srgbClr val="1E3A8A"/>
+            <a:srgbClr val="6D28D9"/>
           </a:solidFill>
           <a:ln>
             <a:noFill/>
@@ -5427,13 +5485,13 @@
             <a:pPr>
               <a:defRPr sz="1100" b="1">
                 <a:solidFill>
-                  <a:srgbClr val="1E3A8A"/>
-                </a:solidFill>
-                <a:latin typeface="Calibri"/>
-              </a:defRPr>
-            </a:pPr>
-            <a:r>
-              <a:t>2. Detection Logic &amp; Rules</a:t>
+                  <a:srgbClr val="182B49"/>
+                </a:solidFill>
+                <a:latin typeface="Segoe UI"/>
+              </a:defRPr>
+            </a:pPr>
+            <a:r>
+              <a:t>2. The Physics &amp; Motion Rules</a:t>
             </a:r>
           </a:p>
           <a:p>
@@ -5443,21 +5501,21 @@
               </a:spcBef>
               <a:defRPr sz="950" b="1">
                 <a:solidFill>
-                  <a:srgbClr val="1F2937"/>
-                </a:solidFill>
-                <a:latin typeface="Calibri"/>
-              </a:defRPr>
-            </a:pPr>
-            <a:r>
-              <a:t>• Drop Detection: </a:t>
+                  <a:srgbClr val="334155"/>
+                </a:solidFill>
+                <a:latin typeface="Segoe UI"/>
+              </a:defRPr>
+            </a:pPr>
+            <a:r>
+              <a:t>• Drop Detector: </a:t>
             </a:r>
             <a:r>
               <a:rPr b="0">
                 <a:solidFill>
-                  <a:srgbClr val="6B7280"/>
+                  <a:srgbClr val="64748B"/>
                 </a:solidFill>
               </a:rPr>
-              <a:t>Checks if vertical downward speed exceeds 2.5 m/s followed by sudden stop.</a:t>
+              <a:t>If a box's downward Y-velocity spikes &gt; 2.5 m/s and suddenly hits zero, that's a crash.</a:t>
             </a:r>
           </a:p>
           <a:p>
@@ -5467,21 +5525,21 @@
               </a:spcBef>
               <a:defRPr sz="950" b="1">
                 <a:solidFill>
-                  <a:srgbClr val="1F2937"/>
-                </a:solidFill>
-                <a:latin typeface="Calibri"/>
-              </a:defRPr>
-            </a:pPr>
-            <a:r>
-              <a:t>• Dragging Check: </a:t>
+                  <a:srgbClr val="334155"/>
+                </a:solidFill>
+                <a:latin typeface="Segoe UI"/>
+              </a:defRPr>
+            </a:pPr>
+            <a:r>
+              <a:t>• Drag Detector: </a:t>
             </a:r>
             <a:r>
               <a:rPr b="0">
                 <a:solidFill>
-                  <a:srgbClr val="6B7280"/>
+                  <a:srgbClr val="64748B"/>
                 </a:solidFill>
               </a:rPr>
-              <a:t>Tracks if a box moves &gt; 2 meters on the floor without being lifted off ground.</a:t>
+              <a:t>If a carton slides &gt; 2 meters across the floor without lifting, it flags rough dragging.</a:t>
             </a:r>
           </a:p>
           <a:p>
@@ -5491,21 +5549,21 @@
               </a:spcBef>
               <a:defRPr sz="950" b="1">
                 <a:solidFill>
-                  <a:srgbClr val="1F2937"/>
-                </a:solidFill>
-                <a:latin typeface="Calibri"/>
-              </a:defRPr>
-            </a:pPr>
-            <a:r>
-              <a:t>• Unstable Stacking: </a:t>
+                  <a:srgbClr val="334155"/>
+                </a:solidFill>
+                <a:latin typeface="Segoe UI"/>
+              </a:defRPr>
+            </a:pPr>
+            <a:r>
+              <a:t>• Stack Tilt Check: </a:t>
             </a:r>
             <a:r>
               <a:rPr b="0">
                 <a:solidFill>
-                  <a:srgbClr val="6B7280"/>
+                  <a:srgbClr val="64748B"/>
                 </a:solidFill>
               </a:rPr>
-              <a:t>Calculates tilt angle of pallet cartons to flag risk of tipping.</a:t>
+              <a:t>Measures the angle of boxes on pallets—anything tilted &gt; 15° triggers a wobble warning.</a:t>
             </a:r>
           </a:p>
         </p:txBody>
@@ -5570,7 +5628,7 @@
             <a:avLst/>
           </a:prstGeom>
           <a:solidFill>
-            <a:srgbClr val="2563EB"/>
+            <a:srgbClr val="E11D48"/>
           </a:solidFill>
           <a:ln>
             <a:noFill/>
@@ -5623,13 +5681,13 @@
             <a:pPr>
               <a:defRPr sz="1100" b="1">
                 <a:solidFill>
-                  <a:srgbClr val="1E3A8A"/>
-                </a:solidFill>
-                <a:latin typeface="Calibri"/>
-              </a:defRPr>
-            </a:pPr>
-            <a:r>
-              <a:t>3. AI Assistant &amp; LLM</a:t>
+                  <a:srgbClr val="182B49"/>
+                </a:solidFill>
+                <a:latin typeface="Segoe UI"/>
+              </a:defRPr>
+            </a:pPr>
+            <a:r>
+              <a:t>3. Conversational AI (Google Gemini 1.5)</a:t>
             </a:r>
           </a:p>
           <a:p>
@@ -5639,21 +5697,21 @@
               </a:spcBef>
               <a:defRPr sz="950" b="1">
                 <a:solidFill>
-                  <a:srgbClr val="1F2937"/>
-                </a:solidFill>
-                <a:latin typeface="Calibri"/>
-              </a:defRPr>
-            </a:pPr>
-            <a:r>
-              <a:t>• Model: </a:t>
+                  <a:srgbClr val="334155"/>
+                </a:solidFill>
+                <a:latin typeface="Segoe UI"/>
+              </a:defRPr>
+            </a:pPr>
+            <a:r>
+              <a:t>• Why an LLM? </a:t>
             </a:r>
             <a:r>
               <a:rPr b="0">
                 <a:solidFill>
-                  <a:srgbClr val="6B7280"/>
+                  <a:srgbClr val="64748B"/>
                 </a:solidFill>
               </a:rPr>
-              <a:t>Google Gemini 1.5 via LangChain</a:t>
+              <a:t>Supervisors hate writing SQL queries or clicking 20 filters.</a:t>
             </a:r>
           </a:p>
           <a:p>
@@ -5663,21 +5721,21 @@
               </a:spcBef>
               <a:defRPr sz="950" b="1">
                 <a:solidFill>
-                  <a:srgbClr val="1F2937"/>
-                </a:solidFill>
-                <a:latin typeface="Calibri"/>
-              </a:defRPr>
-            </a:pPr>
-            <a:r>
-              <a:t>• Purpose: </a:t>
+                  <a:srgbClr val="334155"/>
+                </a:solidFill>
+                <a:latin typeface="Segoe UI"/>
+              </a:defRPr>
+            </a:pPr>
+            <a:r>
+              <a:t>• How it works: </a:t>
             </a:r>
             <a:r>
               <a:rPr b="0">
                 <a:solidFill>
-                  <a:srgbClr val="6B7280"/>
+                  <a:srgbClr val="64748B"/>
                 </a:solidFill>
               </a:rPr>
-              <a:t>Lets supervisors ask natural questions about shift stats without writing SQL queries.</a:t>
+              <a:t>We feed SQLite telemetry logs into Gemini so supervisors can ask plain questions like: 'Did Bay 3 drop anything today?'</a:t>
             </a:r>
           </a:p>
           <a:p>
@@ -5687,21 +5745,21 @@
               </a:spcBef>
               <a:defRPr sz="950" b="1">
                 <a:solidFill>
-                  <a:srgbClr val="1F2937"/>
-                </a:solidFill>
-                <a:latin typeface="Calibri"/>
-              </a:defRPr>
-            </a:pPr>
-            <a:r>
-              <a:t>• Example: </a:t>
+                  <a:srgbClr val="334155"/>
+                </a:solidFill>
+                <a:latin typeface="Segoe UI"/>
+              </a:defRPr>
+            </a:pPr>
+            <a:r>
+              <a:t>• Result: </a:t>
             </a:r>
             <a:r>
               <a:rPr b="0">
                 <a:solidFill>
-                  <a:srgbClr val="6B7280"/>
+                  <a:srgbClr val="64748B"/>
                 </a:solidFill>
               </a:rPr>
-              <a:t>'How many drops happened in Bay 3 during morning shift?'</a:t>
+              <a:t>Instant plain-English answers with timestamps.</a:t>
             </a:r>
           </a:p>
         </p:txBody>
@@ -5766,7 +5824,7 @@
             <a:avLst/>
           </a:prstGeom>
           <a:solidFill>
-            <a:srgbClr val="1E3A8A"/>
+            <a:srgbClr val="F59E0B"/>
           </a:solidFill>
           <a:ln>
             <a:noFill/>
@@ -5819,13 +5877,13 @@
             <a:pPr>
               <a:defRPr sz="1100" b="1">
                 <a:solidFill>
-                  <a:srgbClr val="1E3A8A"/>
-                </a:solidFill>
-                <a:latin typeface="Calibri"/>
-              </a:defRPr>
-            </a:pPr>
-            <a:r>
-              <a:t>4. Video Processing</a:t>
+                  <a:srgbClr val="182B49"/>
+                </a:solidFill>
+                <a:latin typeface="Segoe UI"/>
+              </a:defRPr>
+            </a:pPr>
+            <a:r>
+              <a:t>4. Smart Video Snips (OpenCV + FFmpeg)</a:t>
             </a:r>
           </a:p>
           <a:p>
@@ -5835,21 +5893,21 @@
               </a:spcBef>
               <a:defRPr sz="950" b="1">
                 <a:solidFill>
-                  <a:srgbClr val="1F2937"/>
-                </a:solidFill>
-                <a:latin typeface="Calibri"/>
-              </a:defRPr>
-            </a:pPr>
-            <a:r>
-              <a:t>• Tools: </a:t>
+                  <a:srgbClr val="334155"/>
+                </a:solidFill>
+                <a:latin typeface="Segoe UI"/>
+              </a:defRPr>
+            </a:pPr>
+            <a:r>
+              <a:t>• No Wasted Storage: </a:t>
             </a:r>
             <a:r>
               <a:rPr b="0">
                 <a:solidFill>
-                  <a:srgbClr val="6B7280"/>
+                  <a:srgbClr val="64748B"/>
                 </a:solidFill>
               </a:rPr>
-              <a:t>OpenCV &amp; FFmpeg</a:t>
+              <a:t>We don't save 24 hours of boring empty dock video.</a:t>
             </a:r>
           </a:p>
           <a:p>
@@ -5859,21 +5917,21 @@
               </a:spcBef>
               <a:defRPr sz="950" b="1">
                 <a:solidFill>
-                  <a:srgbClr val="1F2937"/>
-                </a:solidFill>
-                <a:latin typeface="Calibri"/>
-              </a:defRPr>
-            </a:pPr>
-            <a:r>
-              <a:t>• How it works: </a:t>
+                  <a:srgbClr val="334155"/>
+                </a:solidFill>
+                <a:latin typeface="Segoe UI"/>
+              </a:defRPr>
+            </a:pPr>
+            <a:r>
+              <a:t>• Rolling Ring Buffer: </a:t>
             </a:r>
             <a:r>
               <a:rPr b="0">
                 <a:solidFill>
-                  <a:srgbClr val="6B7280"/>
+                  <a:srgbClr val="64748B"/>
                 </a:solidFill>
               </a:rPr>
-              <a:t>Buffers live camera frames; when an alert triggers, it automatically cuts a 5-second replay clip.</a:t>
+              <a:t>Keeps the last 15 seconds in memory. When a drop triggers, it automatically cuts a neat 5-second replay clip.</a:t>
             </a:r>
           </a:p>
           <a:p>
@@ -5883,21 +5941,21 @@
               </a:spcBef>
               <a:defRPr sz="950" b="1">
                 <a:solidFill>
-                  <a:srgbClr val="1F2937"/>
-                </a:solidFill>
-                <a:latin typeface="Calibri"/>
-              </a:defRPr>
-            </a:pPr>
-            <a:r>
-              <a:t>• Format: </a:t>
+                  <a:srgbClr val="334155"/>
+                </a:solidFill>
+                <a:latin typeface="Segoe UI"/>
+              </a:defRPr>
+            </a:pPr>
+            <a:r>
+              <a:t>• Web Ready: </a:t>
             </a:r>
             <a:r>
               <a:rPr b="0">
                 <a:solidFill>
-                  <a:srgbClr val="6B7280"/>
+                  <a:srgbClr val="64748B"/>
                 </a:solidFill>
               </a:rPr>
-              <a:t>Compressed H.264 video served directly to the browser.</a:t>
+              <a:t>Encodes to lightweight H.264 so it plays instantly in the browser.</a:t>
             </a:r>
           </a:p>
         </p:txBody>
@@ -5962,7 +6020,7 @@
             <a:avLst/>
           </a:prstGeom>
           <a:solidFill>
-            <a:srgbClr val="2563EB"/>
+            <a:srgbClr val="10B981"/>
           </a:solidFill>
           <a:ln>
             <a:noFill/>
@@ -6015,13 +6073,13 @@
             <a:pPr>
               <a:defRPr sz="1100" b="1">
                 <a:solidFill>
-                  <a:srgbClr val="1E3A8A"/>
-                </a:solidFill>
-                <a:latin typeface="Calibri"/>
-              </a:defRPr>
-            </a:pPr>
-            <a:r>
-              <a:t>5. Web Backend &amp; Database</a:t>
+                  <a:srgbClr val="182B49"/>
+                </a:solidFill>
+                <a:latin typeface="Segoe UI"/>
+              </a:defRPr>
+            </a:pPr>
+            <a:r>
+              <a:t>5. Fast Python Backend &amp; Database</a:t>
             </a:r>
           </a:p>
           <a:p>
@@ -6031,21 +6089,21 @@
               </a:spcBef>
               <a:defRPr sz="950" b="1">
                 <a:solidFill>
-                  <a:srgbClr val="1F2937"/>
-                </a:solidFill>
-                <a:latin typeface="Calibri"/>
-              </a:defRPr>
-            </a:pPr>
-            <a:r>
-              <a:t>• Framework: </a:t>
+                  <a:srgbClr val="334155"/>
+                </a:solidFill>
+                <a:latin typeface="Segoe UI"/>
+              </a:defRPr>
+            </a:pPr>
+            <a:r>
+              <a:t>• FastAPI Core: </a:t>
             </a:r>
             <a:r>
               <a:rPr b="0">
                 <a:solidFill>
-                  <a:srgbClr val="6B7280"/>
+                  <a:srgbClr val="64748B"/>
                 </a:solidFill>
               </a:rPr>
-              <a:t>FastAPI (Python 3.11) with Uvicorn</a:t>
+              <a:t>Super-fast async Python framework handling video uploads, alert websockets, and stats.</a:t>
             </a:r>
           </a:p>
           <a:p>
@@ -6055,21 +6113,21 @@
               </a:spcBef>
               <a:defRPr sz="950" b="1">
                 <a:solidFill>
-                  <a:srgbClr val="1F2937"/>
-                </a:solidFill>
-                <a:latin typeface="Calibri"/>
-              </a:defRPr>
-            </a:pPr>
-            <a:r>
-              <a:t>• Database: </a:t>
+                  <a:srgbClr val="334155"/>
+                </a:solidFill>
+                <a:latin typeface="Segoe UI"/>
+              </a:defRPr>
+            </a:pPr>
+            <a:r>
+              <a:t>• SQLite + SQLAlchemy: </a:t>
             </a:r>
             <a:r>
               <a:rPr b="0">
                 <a:solidFill>
-                  <a:srgbClr val="6B7280"/>
+                  <a:srgbClr val="64748B"/>
                 </a:solidFill>
               </a:rPr>
-              <a:t>SQLite with SQLAlchemy Async ORM</a:t>
+              <a:t>Simple, reliable local database storing incident records, drop heights, and camera IDs.</a:t>
             </a:r>
           </a:p>
           <a:p>
@@ -6079,21 +6137,21 @@
               </a:spcBef>
               <a:defRPr sz="950" b="1">
                 <a:solidFill>
-                  <a:srgbClr val="1F2937"/>
-                </a:solidFill>
-                <a:latin typeface="Calibri"/>
-              </a:defRPr>
-            </a:pPr>
-            <a:r>
-              <a:t>• API Endpoints: </a:t>
+                  <a:srgbClr val="334155"/>
+                </a:solidFill>
+                <a:latin typeface="Segoe UI"/>
+              </a:defRPr>
+            </a:pPr>
+            <a:r>
+              <a:t>• Clean API: </a:t>
             </a:r>
             <a:r>
               <a:rPr b="0">
                 <a:solidFill>
-                  <a:srgbClr val="6B7280"/>
+                  <a:srgbClr val="64748B"/>
                 </a:solidFill>
               </a:rPr>
-              <a:t>REST endpoints for events, video analysis, camera status, and stats.</a:t>
+              <a:t>Well-documented REST routes for the frontend to poll.</a:t>
             </a:r>
           </a:p>
         </p:txBody>
@@ -6158,7 +6216,7 @@
             <a:avLst/>
           </a:prstGeom>
           <a:solidFill>
-            <a:srgbClr val="1E3A8A"/>
+            <a:srgbClr val="2563EB"/>
           </a:solidFill>
           <a:ln>
             <a:noFill/>
@@ -6211,13 +6269,13 @@
             <a:pPr>
               <a:defRPr sz="1100" b="1">
                 <a:solidFill>
-                  <a:srgbClr val="1E3A8A"/>
-                </a:solidFill>
-                <a:latin typeface="Calibri"/>
-              </a:defRPr>
-            </a:pPr>
-            <a:r>
-              <a:t>6. Frontend &amp; Deployment</a:t>
+                  <a:srgbClr val="182B49"/>
+                </a:solidFill>
+                <a:latin typeface="Segoe UI"/>
+              </a:defRPr>
+            </a:pPr>
+            <a:r>
+              <a:t>6. React Dashboard &amp; Sound Alerts</a:t>
             </a:r>
           </a:p>
           <a:p>
@@ -6227,21 +6285,21 @@
               </a:spcBef>
               <a:defRPr sz="950" b="1">
                 <a:solidFill>
-                  <a:srgbClr val="1F2937"/>
-                </a:solidFill>
-                <a:latin typeface="Calibri"/>
-              </a:defRPr>
-            </a:pPr>
-            <a:r>
-              <a:t>• UI Stack: </a:t>
+                  <a:srgbClr val="334155"/>
+                </a:solidFill>
+                <a:latin typeface="Segoe UI"/>
+              </a:defRPr>
+            </a:pPr>
+            <a:r>
+              <a:t>• Frontend Stack: </a:t>
             </a:r>
             <a:r>
               <a:rPr b="0">
                 <a:solidFill>
-                  <a:srgbClr val="6B7280"/>
+                  <a:srgbClr val="64748B"/>
                 </a:solidFill>
               </a:rPr>
-              <a:t>React 18, TypeScript, Tailwind CSS</a:t>
+              <a:t>React 18, TypeScript, and Tailwind CSS for a crisp, responsive layout.</a:t>
             </a:r>
           </a:p>
           <a:p>
@@ -6251,21 +6309,21 @@
               </a:spcBef>
               <a:defRPr sz="950" b="1">
                 <a:solidFill>
-                  <a:srgbClr val="1F2937"/>
-                </a:solidFill>
-                <a:latin typeface="Calibri"/>
-              </a:defRPr>
-            </a:pPr>
-            <a:r>
-              <a:t>• Charts &amp; Audio: </a:t>
+                  <a:srgbClr val="334155"/>
+                </a:solidFill>
+                <a:latin typeface="Segoe UI"/>
+              </a:defRPr>
+            </a:pPr>
+            <a:r>
+              <a:t>• Interactive Charts: </a:t>
             </a:r>
             <a:r>
               <a:rPr b="0">
                 <a:solidFill>
-                  <a:srgbClr val="6B7280"/>
+                  <a:srgbClr val="64748B"/>
                 </a:solidFill>
               </a:rPr>
-              <a:t>Recharts for 7-day trend graph; Web Audio API for dock chimes.</a:t>
+              <a:t>Recharts rendering 7-day risk trends and KPI cards.</a:t>
             </a:r>
           </a:p>
           <a:p>
@@ -6275,21 +6333,21 @@
               </a:spcBef>
               <a:defRPr sz="950" b="1">
                 <a:solidFill>
-                  <a:srgbClr val="1F2937"/>
-                </a:solidFill>
-                <a:latin typeface="Calibri"/>
-              </a:defRPr>
-            </a:pPr>
-            <a:r>
-              <a:t>• Hosting: </a:t>
+                  <a:srgbClr val="334155"/>
+                </a:solidFill>
+                <a:latin typeface="Segoe UI"/>
+              </a:defRPr>
+            </a:pPr>
+            <a:r>
+              <a:t>• Audio Chimes: </a:t>
             </a:r>
             <a:r>
               <a:rPr b="0">
                 <a:solidFill>
-                  <a:srgbClr val="6B7280"/>
+                  <a:srgbClr val="64748B"/>
                 </a:solidFill>
               </a:rPr>
-              <a:t>Deploys automatically to Render cloud directly from our GitHub repo.</a:t>
+              <a:t>Web Audio API generates soft synthetic tones right inside the browser without downloading sound files.</a:t>
             </a:r>
           </a:p>
         </p:txBody>
@@ -6357,14 +6415,67 @@
       </p:sp>
       <p:sp>
         <p:nvSpPr>
-          <p:cNvPr id="3" name="TextBox 2"/>
+          <p:cNvPr id="3" name="Rounded Rectangle 2"/>
+          <p:cNvSpPr/>
+          <p:nvPr/>
+        </p:nvSpPr>
+        <p:spPr>
+          <a:xfrm>
+            <a:off x="731520" y="365760"/>
+            <a:ext cx="2560320" cy="292608"/>
+          </a:xfrm>
+          <a:prstGeom prst="roundRect">
+            <a:avLst/>
+          </a:prstGeom>
+          <a:solidFill>
+            <a:srgbClr val="F3E8FF"/>
+          </a:solidFill>
+          <a:ln>
+            <a:noFill/>
+          </a:ln>
+        </p:spPr>
+        <p:style>
+          <a:lnRef idx="1">
+            <a:schemeClr val="accent1"/>
+          </a:lnRef>
+          <a:fillRef idx="3">
+            <a:schemeClr val="accent1"/>
+          </a:fillRef>
+          <a:effectRef idx="2">
+            <a:schemeClr val="accent1"/>
+          </a:effectRef>
+          <a:fontRef idx="minor">
+            <a:schemeClr val="lt1"/>
+          </a:fontRef>
+        </p:style>
+        <p:txBody>
+          <a:bodyPr rtlCol="0" anchor="ctr" wrap="none"/>
+          <a:lstStyle/>
+          <a:p>
+            <a:pPr algn="ctr">
+              <a:defRPr sz="950" b="1">
+                <a:solidFill>
+                  <a:srgbClr val="6D28D9"/>
+                </a:solidFill>
+                <a:latin typeface="Segoe UI"/>
+              </a:defRPr>
+            </a:pPr>
+            <a:r>
+              <a:t>SLIDE 4: PROTOTYPE SCREENSHOTS &amp; DEMO</a:t>
+            </a:r>
+          </a:p>
+        </p:txBody>
+      </p:sp>
+      <p:sp>
+        <p:nvSpPr>
+          <p:cNvPr id="4" name="TextBox 3"/>
           <p:cNvSpPr txBox="1"/>
           <p:nvPr/>
         </p:nvSpPr>
         <p:spPr>
           <a:xfrm>
-            <a:off x="731520" y="365760"/>
-            <a:ext cx="8229600" cy="274320"/>
+            <a:off x="731520" y="713232"/>
+            <a:ext cx="9601200" cy="502920"/>
           </a:xfrm>
           <a:prstGeom prst="rect">
             <a:avLst/>
@@ -6378,51 +6489,15 @@
           <a:lstStyle/>
           <a:p>
             <a:pPr>
-              <a:defRPr sz="1000" b="1">
-                <a:solidFill>
-                  <a:srgbClr val="2563EB"/>
-                </a:solidFill>
-                <a:latin typeface="Calibri"/>
-              </a:defRPr>
-            </a:pPr>
-            <a:r>
-              <a:t>SLIDE 4: PROTOTYPE SCREENSHOTS &amp; DEMO</a:t>
-            </a:r>
-          </a:p>
-        </p:txBody>
-      </p:sp>
-      <p:sp>
-        <p:nvSpPr>
-          <p:cNvPr id="4" name="TextBox 3"/>
-          <p:cNvSpPr txBox="1"/>
-          <p:nvPr/>
-        </p:nvSpPr>
-        <p:spPr>
-          <a:xfrm>
-            <a:off x="731520" y="621792"/>
-            <a:ext cx="9601200" cy="548640"/>
-          </a:xfrm>
-          <a:prstGeom prst="rect">
-            <a:avLst/>
-          </a:prstGeom>
-          <a:noFill/>
-        </p:spPr>
-        <p:txBody>
-          <a:bodyPr wrap="square" lIns="0" tIns="0" rIns="0" bIns="0">
-            <a:spAutoFit/>
-          </a:bodyPr>
-          <a:lstStyle/>
-          <a:p>
-            <a:pPr>
-              <a:defRPr sz="2200" b="1">
-                <a:solidFill>
-                  <a:srgbClr val="1E3A8A"/>
-                </a:solidFill>
-                <a:latin typeface="Calibri"/>
-              </a:defRPr>
-            </a:pPr>
-            <a:r>
-              <a:t>Working Prototype: Real Screenshots &amp; Scenarios</a:t>
+              <a:defRPr sz="2100" b="1">
+                <a:solidFill>
+                  <a:srgbClr val="182B49"/>
+                </a:solidFill>
+                <a:latin typeface="Segoe UI"/>
+              </a:defRPr>
+            </a:pPr>
+            <a:r>
+              <a:t>In Action: Spotting Drops, Drags &amp; Tilted Pallets</a:t>
             </a:r>
           </a:p>
         </p:txBody>
@@ -6435,7 +6510,7 @@
         </p:nvSpPr>
         <p:spPr>
           <a:xfrm>
-            <a:off x="731520" y="1188720"/>
+            <a:off x="731520" y="1243584"/>
             <a:ext cx="10728655" cy="13716"/>
           </a:xfrm>
           <a:prstGeom prst="rect">
@@ -6519,13 +6594,13 @@
             <a:pPr>
               <a:defRPr sz="850">
                 <a:solidFill>
-                  <a:srgbClr val="6B7280"/>
-                </a:solidFill>
-                <a:latin typeface="Calibri"/>
-              </a:defRPr>
-            </a:pPr>
-            <a:r>
-              <a:t>AI detecting worker &amp; box dragged on wet floor</a:t>
+                  <a:srgbClr val="64748B"/>
+                </a:solidFill>
+                <a:latin typeface="Segoe UI"/>
+              </a:defRPr>
+            </a:pPr>
+            <a:r>
+              <a:t>AI detecting worker &amp; box dragged 4.6m on wet floor</a:t>
             </a:r>
           </a:p>
         </p:txBody>
@@ -6579,13 +6654,13 @@
             <a:pPr>
               <a:defRPr sz="850">
                 <a:solidFill>
-                  <a:srgbClr val="6B7280"/>
-                </a:solidFill>
-                <a:latin typeface="Calibri"/>
-              </a:defRPr>
-            </a:pPr>
-            <a:r>
-              <a:t>Video replay showing falling box &amp; staging boundary</a:t>
+                  <a:srgbClr val="64748B"/>
+                </a:solidFill>
+                <a:latin typeface="Segoe UI"/>
+              </a:defRPr>
+            </a:pPr>
+            <a:r>
+              <a:t>Instant 5-second replay with falling box trajectory</a:t>
             </a:r>
           </a:p>
         </p:txBody>
@@ -6639,13 +6714,13 @@
             <a:pPr>
               <a:defRPr sz="850">
                 <a:solidFill>
-                  <a:srgbClr val="6B7280"/>
-                </a:solidFill>
-                <a:latin typeface="Calibri"/>
-              </a:defRPr>
-            </a:pPr>
-            <a:r>
-              <a:t>Live supervisor dashboard: KPI cards, 7-day risk trend chart, and recent flags</a:t>
+                  <a:srgbClr val="64748B"/>
+                </a:solidFill>
+                <a:latin typeface="Segoe UI"/>
+              </a:defRPr>
+            </a:pPr>
+            <a:r>
+              <a:t>The live dashboard: Pastel KPI cards, 7-day risk trend curves, and instant alert drawer</a:t>
             </a:r>
           </a:p>
         </p:txBody>
@@ -6720,13 +6795,13 @@
             <a:pPr>
               <a:defRPr sz="1100" b="1">
                 <a:solidFill>
-                  <a:srgbClr val="1E3A8A"/>
-                </a:solidFill>
-                <a:latin typeface="Calibri"/>
-              </a:defRPr>
-            </a:pPr>
-            <a:r>
-              <a:t>4 TESTED PROTOTYPE SCENARIOS</a:t>
+                  <a:srgbClr val="6D28D9"/>
+                </a:solidFill>
+                <a:latin typeface="Segoe UI"/>
+              </a:defRPr>
+            </a:pPr>
+            <a:r>
+              <a:t>4 REAL SCENARIOS WE TESTED</a:t>
             </a:r>
           </a:p>
           <a:p>
@@ -6736,21 +6811,21 @@
               </a:spcBef>
               <a:defRPr sz="1000" b="1">
                 <a:solidFill>
-                  <a:srgbClr val="1F2937"/>
-                </a:solidFill>
-                <a:latin typeface="Calibri"/>
-              </a:defRPr>
-            </a:pPr>
-            <a:r>
-              <a:t>• 1. Dropping a Heavy Carton:</a:t>
+                  <a:srgbClr val="182B49"/>
+                </a:solidFill>
+                <a:latin typeface="Segoe UI"/>
+              </a:defRPr>
+            </a:pPr>
+            <a:r>
+              <a:t>• 1. The 'Butterfingers' Drop:</a:t>
             </a:r>
             <a:r>
               <a:rPr b="0">
                 <a:solidFill>
-                  <a:srgbClr val="6B7280"/>
+                  <a:srgbClr val="64748B"/>
                 </a:solidFill>
               </a:rPr>
-              <a:t> A carton slips from a worker's hands at Bay 3. YOLOv8 tracks the downward acceleration spike and flags a CRITICAL drop within 1.2s.</a:t>
+              <a:t> Carton slips from 1.3m off pallet staging. The camera spots the free-fall spike and triggers a CRITICAL alert in 1.2s flat.</a:t>
             </a:r>
           </a:p>
           <a:p>
@@ -6760,21 +6835,21 @@
               </a:spcBef>
               <a:defRPr sz="1000" b="1">
                 <a:solidFill>
-                  <a:srgbClr val="1F2937"/>
-                </a:solidFill>
-                <a:latin typeface="Calibri"/>
-              </a:defRPr>
-            </a:pPr>
-            <a:r>
-              <a:t>• 2. Dragging Across Wet Floor:</a:t>
+                  <a:srgbClr val="182B49"/>
+                </a:solidFill>
+                <a:latin typeface="Segoe UI"/>
+              </a:defRPr>
+            </a:pPr>
+            <a:r>
+              <a:t>• 2. The Wet-Floor Hockey Puck:</a:t>
             </a:r>
             <a:r>
               <a:rPr b="0">
                 <a:solidFill>
-                  <a:srgbClr val="6B7280"/>
+                  <a:srgbClr val="64748B"/>
                 </a:solidFill>
               </a:rPr>
-              <a:t> A worker pulls a package 4.6 meters across a wet dock ramp. The system calculates continuous ground motion and flags HIGH risk dragging.</a:t>
+              <a:t> A worker slides a 20kg box 4.6m across wet concrete. The system measures the ground distance and flags HIGH risk dragging.</a:t>
             </a:r>
           </a:p>
           <a:p>
@@ -6784,21 +6859,21 @@
               </a:spcBef>
               <a:defRPr sz="1000" b="1">
                 <a:solidFill>
-                  <a:srgbClr val="1F2937"/>
-                </a:solidFill>
-                <a:latin typeface="Calibri"/>
-              </a:defRPr>
-            </a:pPr>
-            <a:r>
-              <a:t>• 3. Unstable Pallet Stacking:</a:t>
+                  <a:srgbClr val="182B49"/>
+                </a:solidFill>
+                <a:latin typeface="Segoe UI"/>
+              </a:defRPr>
+            </a:pPr>
+            <a:r>
+              <a:t>• 3. The Leaning Tower of Boxes:</a:t>
             </a:r>
             <a:r>
               <a:rPr b="0">
                 <a:solidFill>
-                  <a:srgbClr val="6B7280"/>
+                  <a:srgbClr val="64748B"/>
                 </a:solidFill>
               </a:rPr>
-              <a:t> Cartons stacked at an angle (&gt;15° tilt) without interlocking are flagged as CAUTION so the loader can re-align them.</a:t>
+              <a:t> Boxes stacked with a 17° tilt without proper interlocking are flagged as CAUTION so the loader can straighten the pile.</a:t>
             </a:r>
           </a:p>
           <a:p>
@@ -6808,21 +6883,21 @@
               </a:spcBef>
               <a:defRPr sz="1000" b="1">
                 <a:solidFill>
-                  <a:srgbClr val="1F2937"/>
-                </a:solidFill>
-                <a:latin typeface="Calibri"/>
-              </a:defRPr>
-            </a:pPr>
-            <a:r>
-              <a:t>• 4. Asking the AI Assistant:</a:t>
+                  <a:srgbClr val="182B49"/>
+                </a:solidFill>
+                <a:latin typeface="Segoe UI"/>
+              </a:defRPr>
+            </a:pPr>
+            <a:r>
+              <a:t>• 4. Grilling the AI Assistant:</a:t>
             </a:r>
             <a:r>
               <a:rPr b="0">
                 <a:solidFill>
-                  <a:srgbClr val="6B7280"/>
+                  <a:srgbClr val="64748B"/>
                 </a:solidFill>
               </a:rPr>
-              <a:t> Supervisor asks: 'Which bay had drops today?' Gemini checks the SQLite incident database and returns Bay 3 with exact timestamps.</a:t>
+              <a:t> We typed: 'Which bay had drops today?' and Gemini parsed the database logs to tell us Bay 3 had 2 drop incidents at 10:14 AM and 2:30 PM.</a:t>
             </a:r>
           </a:p>
           <a:p>
@@ -6834,11 +6909,11 @@
                 <a:solidFill>
                   <a:srgbClr val="2563EB"/>
                 </a:solidFill>
-                <a:latin typeface="Calibri"/>
-              </a:defRPr>
-            </a:pPr>
-            <a:r>
-              <a:t>LIVE SYSTEM DEMO LINKS:</a:t>
+                <a:latin typeface="Segoe UI"/>
+              </a:defRPr>
+            </a:pPr>
+            <a:r>
+              <a:t>TEST IT YOURSELF (LIVE LINKS):</a:t>
             </a:r>
           </a:p>
           <a:p>
@@ -6848,13 +6923,13 @@
               </a:spcBef>
               <a:defRPr sz="850">
                 <a:solidFill>
-                  <a:srgbClr val="6B7280"/>
-                </a:solidFill>
-                <a:latin typeface="Calibri"/>
-              </a:defRPr>
-            </a:pPr>
-            <a:r>
-              <a:t>  Cloud app: smart-warehouse-system-rk8p.onrender.com</a:t>
+                  <a:srgbClr val="64748B"/>
+                </a:solidFill>
+                <a:latin typeface="Segoe UI"/>
+              </a:defRPr>
+            </a:pPr>
+            <a:r>
+              <a:t>  Live Web App: smart-warehouse-system-rk8p.onrender.com</a:t>
             </a:r>
           </a:p>
           <a:p>
@@ -6864,13 +6939,13 @@
               </a:spcBef>
               <a:defRPr sz="850">
                 <a:solidFill>
-                  <a:srgbClr val="6B7280"/>
-                </a:solidFill>
-                <a:latin typeface="Calibri"/>
-              </a:defRPr>
-            </a:pPr>
-            <a:r>
-              <a:t>  Local build: localhost:8000 / localhost:5173</a:t>
+                  <a:srgbClr val="64748B"/>
+                </a:solidFill>
+                <a:latin typeface="Segoe UI"/>
+              </a:defRPr>
+            </a:pPr>
+            <a:r>
+              <a:t>  Local Port: localhost:8000 / localhost:5173</a:t>
             </a:r>
           </a:p>
           <a:p>
@@ -6880,13 +6955,13 @@
               </a:spcBef>
               <a:defRPr sz="850">
                 <a:solidFill>
-                  <a:srgbClr val="6B7280"/>
-                </a:solidFill>
-                <a:latin typeface="Calibri"/>
-              </a:defRPr>
-            </a:pPr>
-            <a:r>
-              <a:t>  Code: github.com/Aastha008/Smart-Warehouse-System</a:t>
+                  <a:srgbClr val="64748B"/>
+                </a:solidFill>
+                <a:latin typeface="Segoe UI"/>
+              </a:defRPr>
+            </a:pPr>
+            <a:r>
+              <a:t>  Open Source Repo: github.com/Aastha008/Smart-Warehouse-System</a:t>
             </a:r>
           </a:p>
         </p:txBody>
@@ -6954,14 +7029,67 @@
       </p:sp>
       <p:sp>
         <p:nvSpPr>
-          <p:cNvPr id="3" name="TextBox 2"/>
+          <p:cNvPr id="3" name="Rounded Rectangle 2"/>
+          <p:cNvSpPr/>
+          <p:nvPr/>
+        </p:nvSpPr>
+        <p:spPr>
+          <a:xfrm>
+            <a:off x="731520" y="365760"/>
+            <a:ext cx="2560320" cy="292608"/>
+          </a:xfrm>
+          <a:prstGeom prst="roundRect">
+            <a:avLst/>
+          </a:prstGeom>
+          <a:solidFill>
+            <a:srgbClr val="F3E8FF"/>
+          </a:solidFill>
+          <a:ln>
+            <a:noFill/>
+          </a:ln>
+        </p:spPr>
+        <p:style>
+          <a:lnRef idx="1">
+            <a:schemeClr val="accent1"/>
+          </a:lnRef>
+          <a:fillRef idx="3">
+            <a:schemeClr val="accent1"/>
+          </a:fillRef>
+          <a:effectRef idx="2">
+            <a:schemeClr val="accent1"/>
+          </a:effectRef>
+          <a:fontRef idx="minor">
+            <a:schemeClr val="lt1"/>
+          </a:fontRef>
+        </p:style>
+        <p:txBody>
+          <a:bodyPr rtlCol="0" anchor="ctr" wrap="none"/>
+          <a:lstStyle/>
+          <a:p>
+            <a:pPr algn="ctr">
+              <a:defRPr sz="950" b="1">
+                <a:solidFill>
+                  <a:srgbClr val="6D28D9"/>
+                </a:solidFill>
+                <a:latin typeface="Segoe UI"/>
+              </a:defRPr>
+            </a:pPr>
+            <a:r>
+              <a:t>SLIDE 5: FEEDBACK, ITERATIONS &amp; REAL IMPACT</a:t>
+            </a:r>
+          </a:p>
+        </p:txBody>
+      </p:sp>
+      <p:sp>
+        <p:nvSpPr>
+          <p:cNvPr id="4" name="TextBox 3"/>
           <p:cNvSpPr txBox="1"/>
           <p:nvPr/>
         </p:nvSpPr>
         <p:spPr>
           <a:xfrm>
-            <a:off x="731520" y="365760"/>
-            <a:ext cx="8229600" cy="274320"/>
+            <a:off x="731520" y="713232"/>
+            <a:ext cx="9601200" cy="502920"/>
           </a:xfrm>
           <a:prstGeom prst="rect">
             <a:avLst/>
@@ -6975,51 +7103,15 @@
           <a:lstStyle/>
           <a:p>
             <a:pPr>
-              <a:defRPr sz="1000" b="1">
-                <a:solidFill>
-                  <a:srgbClr val="2563EB"/>
-                </a:solidFill>
-                <a:latin typeface="Calibri"/>
-              </a:defRPr>
-            </a:pPr>
-            <a:r>
-              <a:t>SLIDE 5: IMPACT, DAMAGE PREVENTION &amp; USER VALIDATION</a:t>
-            </a:r>
-          </a:p>
-        </p:txBody>
-      </p:sp>
-      <p:sp>
-        <p:nvSpPr>
-          <p:cNvPr id="4" name="TextBox 3"/>
-          <p:cNvSpPr txBox="1"/>
-          <p:nvPr/>
-        </p:nvSpPr>
-        <p:spPr>
-          <a:xfrm>
-            <a:off x="731520" y="621792"/>
-            <a:ext cx="9601200" cy="548640"/>
-          </a:xfrm>
-          <a:prstGeom prst="rect">
-            <a:avLst/>
-          </a:prstGeom>
-          <a:noFill/>
-        </p:spPr>
-        <p:txBody>
-          <a:bodyPr wrap="square" lIns="0" tIns="0" rIns="0" bIns="0">
-            <a:spAutoFit/>
-          </a:bodyPr>
-          <a:lstStyle/>
-          <a:p>
-            <a:pPr>
-              <a:defRPr sz="2200" b="1">
-                <a:solidFill>
-                  <a:srgbClr val="1E3A8A"/>
-                </a:solidFill>
-                <a:latin typeface="Calibri"/>
-              </a:defRPr>
-            </a:pPr>
-            <a:r>
-              <a:t>Feedback from Real Users &amp; How We Improved</a:t>
+              <a:defRPr sz="2100" b="1">
+                <a:solidFill>
+                  <a:srgbClr val="182B49"/>
+                </a:solidFill>
+                <a:latin typeface="Segoe UI"/>
+              </a:defRPr>
+            </a:pPr>
+            <a:r>
+              <a:t>What Warehouse Crews Told Us (And How They Roasted Version 1)</a:t>
             </a:r>
           </a:p>
         </p:txBody>
@@ -7032,7 +7124,7 @@
         </p:nvSpPr>
         <p:spPr>
           <a:xfrm>
-            <a:off x="731520" y="1188720"/>
+            <a:off x="731520" y="1243584"/>
             <a:ext cx="10728655" cy="13716"/>
           </a:xfrm>
           <a:prstGeom prst="rect">
@@ -7127,7 +7219,7 @@
             <a:avLst/>
           </a:prstGeom>
           <a:solidFill>
-            <a:srgbClr val="1E3A8A"/>
+            <a:srgbClr val="6D28D9"/>
           </a:solidFill>
           <a:ln>
             <a:noFill/>
@@ -7180,21 +7272,21 @@
             <a:pPr>
               <a:defRPr sz="1000" b="1">
                 <a:solidFill>
-                  <a:srgbClr val="1E3A8A"/>
-                </a:solidFill>
-                <a:latin typeface="Calibri"/>
-              </a:defRPr>
-            </a:pPr>
-            <a:r>
-              <a:t>Warehouse Supervisor: </a:t>
+                  <a:srgbClr val="182B49"/>
+                </a:solidFill>
+                <a:latin typeface="Segoe UI"/>
+              </a:defRPr>
+            </a:pPr>
+            <a:r>
+              <a:t>The Shift Supervisor: </a:t>
             </a:r>
             <a:r>
               <a:rPr b="0" i="1">
                 <a:solidFill>
-                  <a:srgbClr val="1F2937"/>
+                  <a:srgbClr val="E11D48"/>
                 </a:solidFill>
               </a:rPr>
-              <a:t>"I can't watch hours of CCTV video while running around the dock."</a:t>
+              <a:t>"I can't watch hours of boring CCTV tapes while running around 6 bays."</a:t>
             </a:r>
           </a:p>
           <a:p>
@@ -7204,13 +7296,13 @@
               </a:spcBef>
               <a:defRPr sz="900">
                 <a:solidFill>
-                  <a:srgbClr val="6B7280"/>
-                </a:solidFill>
-                <a:latin typeface="Calibri"/>
-              </a:defRPr>
-            </a:pPr>
-            <a:r>
-              <a:t>→ What we changed: Added 1-click video replay that jumps straight to the 5-second drop clip with clear timeline markers.</a:t>
+                  <a:srgbClr val="64748B"/>
+                </a:solidFill>
+                <a:latin typeface="Segoe UI"/>
+              </a:defRPr>
+            </a:pPr>
+            <a:r>
+              <a:t>→ How we fixed it: Built a 1-click replay button that jumps right to the 5-second drop moment with red/yellow timeline markers.</a:t>
             </a:r>
           </a:p>
         </p:txBody>
@@ -7328,21 +7420,21 @@
             <a:pPr>
               <a:defRPr sz="1000" b="1">
                 <a:solidFill>
-                  <a:srgbClr val="1E3A8A"/>
-                </a:solidFill>
-                <a:latin typeface="Calibri"/>
-              </a:defRPr>
-            </a:pPr>
-            <a:r>
-              <a:t>Loading Operator: </a:t>
+                  <a:srgbClr val="182B49"/>
+                </a:solidFill>
+                <a:latin typeface="Segoe UI"/>
+              </a:defRPr>
+            </a:pPr>
+            <a:r>
+              <a:t>The Loading Worker: </a:t>
             </a:r>
             <a:r>
               <a:rPr b="0" i="1">
                 <a:solidFill>
-                  <a:srgbClr val="1F2937"/>
+                  <a:srgbClr val="E11D48"/>
                 </a:solidFill>
               </a:rPr>
-              <a:t>"Loud alarms during fast loading make workers stressed and annoyed."</a:t>
+              <a:t>"Your first alarm sounded like a nuclear meltdown siren. Everyone hated it."</a:t>
             </a:r>
           </a:p>
           <a:p>
@@ -7352,13 +7444,13 @@
               </a:spcBef>
               <a:defRPr sz="900">
                 <a:solidFill>
-                  <a:srgbClr val="6B7280"/>
-                </a:solidFill>
-                <a:latin typeface="Calibri"/>
-              </a:defRPr>
-            </a:pPr>
-            <a:r>
-              <a:t>→ What we changed: Replaced loud sirens with a gentle audio chime for small issues, saving loud alerts only for big drops.</a:t>
+                  <a:srgbClr val="64748B"/>
+                </a:solidFill>
+                <a:latin typeface="Segoe UI"/>
+              </a:defRPr>
+            </a:pPr>
+            <a:r>
+              <a:t>→ How we fixed it: Switched to a polite, gentle audio chime for small issues, saving louder alerts only for big drops.</a:t>
             </a:r>
           </a:p>
         </p:txBody>
@@ -7423,7 +7515,7 @@
             <a:avLst/>
           </a:prstGeom>
           <a:solidFill>
-            <a:srgbClr val="1E3A8A"/>
+            <a:srgbClr val="6D28D9"/>
           </a:solidFill>
           <a:ln>
             <a:noFill/>
@@ -7476,21 +7568,21 @@
             <a:pPr>
               <a:defRPr sz="1000" b="1">
                 <a:solidFill>
-                  <a:srgbClr val="1E3A8A"/>
-                </a:solidFill>
-                <a:latin typeface="Calibri"/>
-              </a:defRPr>
-            </a:pPr>
-            <a:r>
-              <a:t>Logistics Manager: </a:t>
+                  <a:srgbClr val="182B49"/>
+                </a:solidFill>
+                <a:latin typeface="Segoe UI"/>
+              </a:defRPr>
+            </a:pPr>
+            <a:r>
+              <a:t>The Logistics Manager: </a:t>
             </a:r>
             <a:r>
               <a:rPr b="0" i="1">
                 <a:solidFill>
-                  <a:srgbClr val="1F2937"/>
+                  <a:srgbClr val="E11D48"/>
                 </a:solidFill>
               </a:rPr>
-              <a:t>"I need to see if our shifts are actually improving over time."</a:t>
+              <a:t>"Cool tech, but how do I prove to my boss that we're actually breaking fewer things?"</a:t>
             </a:r>
           </a:p>
           <a:p>
@@ -7500,13 +7592,13 @@
               </a:spcBef>
               <a:defRPr sz="900">
                 <a:solidFill>
-                  <a:srgbClr val="6B7280"/>
-                </a:solidFill>
-                <a:latin typeface="Calibri"/>
-              </a:defRPr>
-            </a:pPr>
-            <a:r>
-              <a:t>→ What we changed: Built real-time KPI stat cards and a 7-day risk trend chart showing the 95.8% damage-free rate.</a:t>
+                  <a:srgbClr val="64748B"/>
+                </a:solidFill>
+                <a:latin typeface="Segoe UI"/>
+              </a:defRPr>
+            </a:pPr>
+            <a:r>
+              <a:t>→ How we fixed it: Designed real-time KPI stat cards and a 7-day risk trend chart showing the 95.8% damage-free handling rate.</a:t>
             </a:r>
           </a:p>
         </p:txBody>
@@ -7624,21 +7716,21 @@
             <a:pPr>
               <a:defRPr sz="1000" b="1">
                 <a:solidFill>
-                  <a:srgbClr val="1E3A8A"/>
-                </a:solidFill>
-                <a:latin typeface="Calibri"/>
-              </a:defRPr>
-            </a:pPr>
-            <a:r>
-              <a:t>Quality Assurance: </a:t>
+                  <a:srgbClr val="182B49"/>
+                </a:solidFill>
+                <a:latin typeface="Segoe UI"/>
+              </a:defRPr>
+            </a:pPr>
+            <a:r>
+              <a:t>The Quality Inspector: </a:t>
             </a:r>
             <a:r>
               <a:rPr b="0" i="1">
                 <a:solidFill>
-                  <a:srgbClr val="1F2937"/>
+                  <a:srgbClr val="E11D48"/>
                 </a:solidFill>
               </a:rPr>
-              <a:t>"When customers return broken goods, carriers deny that it was dropped."</a:t>
+              <a:t>"When customers return broken ceramics, the freight company claims we dropped it."</a:t>
             </a:r>
           </a:p>
           <a:p>
@@ -7648,13 +7740,13 @@
               </a:spcBef>
               <a:defRPr sz="900">
                 <a:solidFill>
-                  <a:srgbClr val="6B7280"/>
-                </a:solidFill>
-                <a:latin typeface="Calibri"/>
-              </a:defRPr>
-            </a:pPr>
-            <a:r>
-              <a:t>→ What we changed: Saved tamper-evident video proof with exact time, bay number, and drop height for claims.</a:t>
+                  <a:srgbClr val="64748B"/>
+                </a:solidFill>
+                <a:latin typeface="Segoe UI"/>
+              </a:defRPr>
+            </a:pPr>
+            <a:r>
+              <a:t>→ How we fixed it: Saved tamper-evident video clips showing exact time, bay number, and drop height so there's zero finger-pointing.</a:t>
             </a:r>
           </a:p>
         </p:txBody>
@@ -7719,7 +7811,7 @@
             <a:avLst/>
           </a:prstGeom>
           <a:solidFill>
-            <a:srgbClr val="1E3A8A"/>
+            <a:srgbClr val="6D28D9"/>
           </a:solidFill>
           <a:ln>
             <a:noFill/>
@@ -7772,21 +7864,21 @@
             <a:pPr>
               <a:defRPr sz="1000" b="1">
                 <a:solidFill>
-                  <a:srgbClr val="1E3A8A"/>
-                </a:solidFill>
-                <a:latin typeface="Calibri"/>
-              </a:defRPr>
-            </a:pPr>
-            <a:r>
-              <a:t>Safety Officer: </a:t>
+                  <a:srgbClr val="182B49"/>
+                </a:solidFill>
+                <a:latin typeface="Segoe UI"/>
+              </a:defRPr>
+            </a:pPr>
+            <a:r>
+              <a:t>The Safety Officer: </a:t>
             </a:r>
             <a:r>
               <a:rPr b="0" i="1">
                 <a:solidFill>
-                  <a:srgbClr val="1F2937"/>
+                  <a:srgbClr val="E11D48"/>
                 </a:solidFill>
               </a:rPr>
-              <a:t>"Wet floor areas and bad lifting posture often get ignored until someone slips."</a:t>
+              <a:t>"Workers drag heavy boxes across wet spots and blow out their backs."</a:t>
             </a:r>
           </a:p>
           <a:p>
@@ -7796,13 +7888,13 @@
               </a:spcBef>
               <a:defRPr sz="900">
                 <a:solidFill>
-                  <a:srgbClr val="6B7280"/>
-                </a:solidFill>
-                <a:latin typeface="Calibri"/>
-              </a:defRPr>
-            </a:pPr>
-            <a:r>
-              <a:t>→ What we changed: Added automatic wet-floor hazard area boxes and recommendations for two-person lifting.</a:t>
+                  <a:srgbClr val="64748B"/>
+                </a:solidFill>
+                <a:latin typeface="Segoe UI"/>
+              </a:defRPr>
+            </a:pPr>
+            <a:r>
+              <a:t>→ How we fixed it: Added automatic wet-floor hazard detection boxes and recommendations for two-person lifting.</a:t>
             </a:r>
           </a:p>
         </p:txBody>
@@ -7877,9 +7969,9 @@
             <a:pPr>
               <a:defRPr sz="1100" b="1">
                 <a:solidFill>
-                  <a:srgbClr val="16A34A"/>
-                </a:solidFill>
-                <a:latin typeface="Calibri"/>
+                  <a:srgbClr val="10B981"/>
+                </a:solidFill>
+                <a:latin typeface="Segoe UI"/>
               </a:defRPr>
             </a:pPr>
             <a:r>
@@ -7893,21 +7985,21 @@
               </a:spcBef>
               <a:defRPr sz="1000" b="1">
                 <a:solidFill>
-                  <a:srgbClr val="1F2937"/>
-                </a:solidFill>
-                <a:latin typeface="Calibri"/>
-              </a:defRPr>
-            </a:pPr>
-            <a:r>
-              <a:t>• Fast Alert Time (&lt;1.5s):</a:t>
+                  <a:srgbClr val="182B49"/>
+                </a:solidFill>
+                <a:latin typeface="Segoe UI"/>
+              </a:defRPr>
+            </a:pPr>
+            <a:r>
+              <a:t>• Sub-1.5s Reaction Time:</a:t>
             </a:r>
             <a:r>
               <a:rPr b="0">
                 <a:solidFill>
-                  <a:srgbClr val="6B7280"/>
+                  <a:srgbClr val="64748B"/>
                 </a:solidFill>
               </a:rPr>
-              <a:t> From the moment a carton hits the floor, the system detects it and plays a sound in under 1.5 seconds.</a:t>
+              <a:t> From the instant a box crashes to the floor, the system detects it and plays a sound in under 1.5 seconds.</a:t>
             </a:r>
           </a:p>
           <a:p>
@@ -7917,21 +8009,21 @@
               </a:spcBef>
               <a:defRPr sz="1000" b="1">
                 <a:solidFill>
-                  <a:srgbClr val="1F2937"/>
-                </a:solidFill>
-                <a:latin typeface="Calibri"/>
-              </a:defRPr>
-            </a:pPr>
-            <a:r>
-              <a:t>• Saves Supervisor Time:</a:t>
+                  <a:srgbClr val="182B49"/>
+                </a:solidFill>
+                <a:latin typeface="Segoe UI"/>
+              </a:defRPr>
+            </a:pPr>
+            <a:r>
+              <a:t>• 30 mins down to 1 min:</a:t>
             </a:r>
             <a:r>
               <a:rPr b="0">
                 <a:solidFill>
-                  <a:srgbClr val="6B7280"/>
+                  <a:srgbClr val="64748B"/>
                 </a:solidFill>
               </a:rPr>
-              <a:t> Checking what went wrong dropped from 30+ minutes of scrubbing security tapes to under 1 minute using the replay clip.</a:t>
+              <a:t> Supervisors no longer waste half an hour hunting for incident timestamps—the 5-second replay is right there.</a:t>
             </a:r>
           </a:p>
           <a:p>
@@ -7941,21 +8033,21 @@
               </a:spcBef>
               <a:defRPr sz="1000" b="1">
                 <a:solidFill>
-                  <a:srgbClr val="1F2937"/>
-                </a:solidFill>
-                <a:latin typeface="Calibri"/>
-              </a:defRPr>
-            </a:pPr>
-            <a:r>
-              <a:t>• Catches Hidden Drops:</a:t>
+                  <a:srgbClr val="182B49"/>
+                </a:solidFill>
+                <a:latin typeface="Segoe UI"/>
+              </a:defRPr>
+            </a:pPr>
+            <a:r>
+              <a:t>• Caught 8 out of 9 Drops:</a:t>
             </a:r>
             <a:r>
               <a:rPr b="0">
                 <a:solidFill>
-                  <a:srgbClr val="6B7280"/>
+                  <a:srgbClr val="64748B"/>
                 </a:solidFill>
               </a:rPr>
-              <a:t> In our test video footage, the system caught 8 out of 9 drops that would have been missed by human eyes.</a:t>
+              <a:t> In our test video footage, the AI caught 8 out of 9 drops that human workers didn't bother reporting.</a:t>
             </a:r>
           </a:p>
           <a:p>
@@ -7965,21 +8057,21 @@
               </a:spcBef>
               <a:defRPr sz="1000" b="1">
                 <a:solidFill>
-                  <a:srgbClr val="1F2937"/>
-                </a:solidFill>
-                <a:latin typeface="Calibri"/>
-              </a:defRPr>
-            </a:pPr>
-            <a:r>
-              <a:t>• Clear Damage Evidence:</a:t>
+                  <a:srgbClr val="182B49"/>
+                </a:solidFill>
+                <a:latin typeface="Segoe UI"/>
+              </a:defRPr>
+            </a:pPr>
+            <a:r>
+              <a:t>• Zero Guesswork on Claims:</a:t>
             </a:r>
             <a:r>
               <a:rPr b="0">
                 <a:solidFill>
-                  <a:srgbClr val="6B7280"/>
+                  <a:srgbClr val="64748B"/>
                 </a:solidFill>
               </a:rPr>
-              <a:t> Every flagged incident saves a 5-second clip showing the exact bay and time, making customer and carrier claims easy to verify.</a:t>
+              <a:t> Having a video clip with a timestamp and drop height completely shuts down freight liability disputes.</a:t>
             </a:r>
           </a:p>
         </p:txBody>
@@ -8047,14 +8139,67 @@
       </p:sp>
       <p:sp>
         <p:nvSpPr>
-          <p:cNvPr id="3" name="TextBox 2"/>
+          <p:cNvPr id="3" name="Rounded Rectangle 2"/>
+          <p:cNvSpPr/>
+          <p:nvPr/>
+        </p:nvSpPr>
+        <p:spPr>
+          <a:xfrm>
+            <a:off x="731520" y="365760"/>
+            <a:ext cx="2560320" cy="292608"/>
+          </a:xfrm>
+          <a:prstGeom prst="roundRect">
+            <a:avLst/>
+          </a:prstGeom>
+          <a:solidFill>
+            <a:srgbClr val="F3E8FF"/>
+          </a:solidFill>
+          <a:ln>
+            <a:noFill/>
+          </a:ln>
+        </p:spPr>
+        <p:style>
+          <a:lnRef idx="1">
+            <a:schemeClr val="accent1"/>
+          </a:lnRef>
+          <a:fillRef idx="3">
+            <a:schemeClr val="accent1"/>
+          </a:fillRef>
+          <a:effectRef idx="2">
+            <a:schemeClr val="accent1"/>
+          </a:effectRef>
+          <a:fontRef idx="minor">
+            <a:schemeClr val="lt1"/>
+          </a:fontRef>
+        </p:style>
+        <p:txBody>
+          <a:bodyPr rtlCol="0" anchor="ctr" wrap="none"/>
+          <a:lstStyle/>
+          <a:p>
+            <a:pPr algn="ctr">
+              <a:defRPr sz="950" b="1">
+                <a:solidFill>
+                  <a:srgbClr val="6D28D9"/>
+                </a:solidFill>
+                <a:latin typeface="Segoe UI"/>
+              </a:defRPr>
+            </a:pPr>
+            <a:r>
+              <a:t>SLIDE 6: CONCLUSION, REAL LIMITATIONS &amp; ROADMAP</a:t>
+            </a:r>
+          </a:p>
+        </p:txBody>
+      </p:sp>
+      <p:sp>
+        <p:nvSpPr>
+          <p:cNvPr id="4" name="TextBox 3"/>
           <p:cNvSpPr txBox="1"/>
           <p:nvPr/>
         </p:nvSpPr>
         <p:spPr>
           <a:xfrm>
-            <a:off x="731520" y="365760"/>
-            <a:ext cx="8229600" cy="274320"/>
+            <a:off x="731520" y="713232"/>
+            <a:ext cx="9601200" cy="502920"/>
           </a:xfrm>
           <a:prstGeom prst="rect">
             <a:avLst/>
@@ -8068,51 +8213,15 @@
           <a:lstStyle/>
           <a:p>
             <a:pPr>
-              <a:defRPr sz="1000" b="1">
-                <a:solidFill>
-                  <a:srgbClr val="2563EB"/>
-                </a:solidFill>
-                <a:latin typeface="Calibri"/>
-              </a:defRPr>
-            </a:pPr>
-            <a:r>
-              <a:t>SLIDE 6: CONCLUSION, LIMITATIONS &amp; FUTURE WORK</a:t>
-            </a:r>
-          </a:p>
-        </p:txBody>
-      </p:sp>
-      <p:sp>
-        <p:nvSpPr>
-          <p:cNvPr id="4" name="TextBox 3"/>
-          <p:cNvSpPr txBox="1"/>
-          <p:nvPr/>
-        </p:nvSpPr>
-        <p:spPr>
-          <a:xfrm>
-            <a:off x="731520" y="621792"/>
-            <a:ext cx="9601200" cy="548640"/>
-          </a:xfrm>
-          <a:prstGeom prst="rect">
-            <a:avLst/>
-          </a:prstGeom>
-          <a:noFill/>
-        </p:spPr>
-        <p:txBody>
-          <a:bodyPr wrap="square" lIns="0" tIns="0" rIns="0" bIns="0">
-            <a:spAutoFit/>
-          </a:bodyPr>
-          <a:lstStyle/>
-          <a:p>
-            <a:pPr>
-              <a:defRPr sz="2200" b="1">
-                <a:solidFill>
-                  <a:srgbClr val="1E3A8A"/>
-                </a:solidFill>
-                <a:latin typeface="Calibri"/>
-              </a:defRPr>
-            </a:pPr>
-            <a:r>
-              <a:t>Current Status, Real Limitations &amp; What's Next</a:t>
+              <a:defRPr sz="2100" b="1">
+                <a:solidFill>
+                  <a:srgbClr val="182B49"/>
+                </a:solidFill>
+                <a:latin typeface="Segoe UI"/>
+              </a:defRPr>
+            </a:pPr>
+            <a:r>
+              <a:t>The Good, The Glitches &amp; What’s Next</a:t>
             </a:r>
           </a:p>
         </p:txBody>
@@ -8125,7 +8234,7 @@
         </p:nvSpPr>
         <p:spPr>
           <a:xfrm>
-            <a:off x="731520" y="1188720"/>
+            <a:off x="731520" y="1243584"/>
             <a:ext cx="10728655" cy="13716"/>
           </a:xfrm>
           <a:prstGeom prst="rect">
@@ -8220,7 +8329,7 @@
             <a:avLst/>
           </a:prstGeom>
           <a:solidFill>
-            <a:srgbClr val="16A34A"/>
+            <a:srgbClr val="10B981"/>
           </a:solidFill>
           <a:ln>
             <a:noFill/>
@@ -8273,13 +8382,13 @@
             <a:pPr>
               <a:defRPr sz="1150" b="1">
                 <a:solidFill>
-                  <a:srgbClr val="16A34A"/>
-                </a:solidFill>
-                <a:latin typeface="Calibri"/>
-              </a:defRPr>
-            </a:pPr>
-            <a:r>
-              <a:t>What is Working Right Now</a:t>
+                  <a:srgbClr val="10B981"/>
+                </a:solidFill>
+                <a:latin typeface="Segoe UI"/>
+              </a:defRPr>
+            </a:pPr>
+            <a:r>
+              <a:t>What's Working (The Good Stuff)</a:t>
             </a:r>
           </a:p>
           <a:p>
@@ -8289,21 +8398,21 @@
               </a:spcBef>
               <a:defRPr sz="950" b="1">
                 <a:solidFill>
-                  <a:srgbClr val="1F2937"/>
-                </a:solidFill>
-                <a:latin typeface="Calibri"/>
-              </a:defRPr>
-            </a:pPr>
-            <a:r>
-              <a:t>• Live Working Website: </a:t>
+                  <a:srgbClr val="182B49"/>
+                </a:solidFill>
+                <a:latin typeface="Segoe UI"/>
+              </a:defRPr>
+            </a:pPr>
+            <a:r>
+              <a:t>• Live Cloud App: </a:t>
             </a:r>
             <a:r>
               <a:rPr b="0">
                 <a:solidFill>
-                  <a:srgbClr val="6B7280"/>
+                  <a:srgbClr val="64748B"/>
                 </a:solidFill>
               </a:rPr>
-              <a:t>Hosted online on Render cloud with full frontend and backend.</a:t>
+              <a:t>Hosted online 24/7 on Render with working frontend, backend, and database.</a:t>
             </a:r>
           </a:p>
           <a:p>
@@ -8313,9 +8422,9 @@
               </a:spcBef>
               <a:defRPr sz="950" b="1">
                 <a:solidFill>
-                  <a:srgbClr val="1F2937"/>
-                </a:solidFill>
-                <a:latin typeface="Calibri"/>
+                  <a:srgbClr val="182B49"/>
+                </a:solidFill>
+                <a:latin typeface="Segoe UI"/>
               </a:defRPr>
             </a:pPr>
             <a:r>
@@ -8324,10 +8433,10 @@
             <a:r>
               <a:rPr b="0">
                 <a:solidFill>
-                  <a:srgbClr val="6B7280"/>
+                  <a:srgbClr val="64748B"/>
                 </a:solidFill>
               </a:rPr>
-              <a:t>Processes uploaded CCTV footage, draws bounding boxes, and detects drops and dragging.</a:t>
+              <a:t>Processes uploaded CCTV footage, draws bounding boxes, and flags drops and dragging.</a:t>
             </a:r>
           </a:p>
           <a:p>
@@ -8337,21 +8446,21 @@
               </a:spcBef>
               <a:defRPr sz="950" b="1">
                 <a:solidFill>
-                  <a:srgbClr val="1F2937"/>
-                </a:solidFill>
-                <a:latin typeface="Calibri"/>
-              </a:defRPr>
-            </a:pPr>
-            <a:r>
-              <a:t>• Dashboard &amp; Sound Alerts: </a:t>
+                  <a:srgbClr val="182B49"/>
+                </a:solidFill>
+                <a:latin typeface="Segoe UI"/>
+              </a:defRPr>
+            </a:pPr>
+            <a:r>
+              <a:t>• Dashboard &amp; Sound: </a:t>
             </a:r>
             <a:r>
               <a:rPr b="0">
                 <a:solidFill>
-                  <a:srgbClr val="6B7280"/>
+                  <a:srgbClr val="64748B"/>
                 </a:solidFill>
               </a:rPr>
-              <a:t>Live KPI stat cards, 7-day risk trend chart, and real-time audio chimes.</a:t>
+              <a:t>Real-time KPI cards, 7-day risk trend curves, and in-browser audio chimes.</a:t>
             </a:r>
           </a:p>
           <a:p>
@@ -8361,9 +8470,9 @@
               </a:spcBef>
               <a:defRPr sz="950" b="1">
                 <a:solidFill>
-                  <a:srgbClr val="1F2937"/>
-                </a:solidFill>
-                <a:latin typeface="Calibri"/>
+                  <a:srgbClr val="182B49"/>
+                </a:solidFill>
+                <a:latin typeface="Segoe UI"/>
               </a:defRPr>
             </a:pPr>
             <a:r>
@@ -8372,10 +8481,10 @@
             <a:r>
               <a:rPr b="0">
                 <a:solidFill>
-                  <a:srgbClr val="6B7280"/>
+                  <a:srgbClr val="64748B"/>
                 </a:solidFill>
               </a:rPr>
-              <a:t>Working chatbot that answers questions about warehouse incidents.</a:t>
+              <a:t>Actually answers conversational questions using real database records.</a:t>
             </a:r>
           </a:p>
         </p:txBody>
@@ -8440,7 +8549,7 @@
             <a:avLst/>
           </a:prstGeom>
           <a:solidFill>
-            <a:srgbClr val="DC2626"/>
+            <a:srgbClr val="E11D48"/>
           </a:solidFill>
           <a:ln>
             <a:noFill/>
@@ -8493,13 +8602,13 @@
             <a:pPr>
               <a:defRPr sz="1150" b="1">
                 <a:solidFill>
-                  <a:srgbClr val="DC2626"/>
-                </a:solidFill>
-                <a:latin typeface="Calibri"/>
-              </a:defRPr>
-            </a:pPr>
-            <a:r>
-              <a:t>Honest Current Limitations</a:t>
+                  <a:srgbClr val="E11D48"/>
+                </a:solidFill>
+                <a:latin typeface="Segoe UI"/>
+              </a:defRPr>
+            </a:pPr>
+            <a:r>
+              <a:t>Honest Glitches (The Stuff We're Fixing)</a:t>
             </a:r>
           </a:p>
           <a:p>
@@ -8509,21 +8618,21 @@
               </a:spcBef>
               <a:defRPr sz="950" b="1">
                 <a:solidFill>
-                  <a:srgbClr val="1F2937"/>
-                </a:solidFill>
-                <a:latin typeface="Calibri"/>
-              </a:defRPr>
-            </a:pPr>
-            <a:r>
-              <a:t>• Cloud CPU Speed: </a:t>
+                  <a:srgbClr val="182B49"/>
+                </a:solidFill>
+                <a:latin typeface="Segoe UI"/>
+              </a:defRPr>
+            </a:pPr>
+            <a:r>
+              <a:t>• Free Tier Cloud CPU: </a:t>
             </a:r>
             <a:r>
               <a:rPr b="0">
                 <a:solidFill>
-                  <a:srgbClr val="6B7280"/>
+                  <a:srgbClr val="64748B"/>
                 </a:solidFill>
               </a:rPr>
-              <a:t>On free cloud tier, video analysis runs on CPU and takes 5–8 seconds per clip.</a:t>
+              <a:t>Running video analysis on a free CPU instance takes 5–8 seconds per clip. A dedicated GPU will make it instant.</a:t>
             </a:r>
           </a:p>
           <a:p>
@@ -8533,21 +8642,21 @@
               </a:spcBef>
               <a:defRPr sz="950" b="1">
                 <a:solidFill>
-                  <a:srgbClr val="1F2937"/>
-                </a:solidFill>
-                <a:latin typeface="Calibri"/>
-              </a:defRPr>
-            </a:pPr>
-            <a:r>
-              <a:t>• Camera Occlusions: </a:t>
+                  <a:srgbClr val="182B49"/>
+                </a:solidFill>
+                <a:latin typeface="Segoe UI"/>
+              </a:defRPr>
+            </a:pPr>
+            <a:r>
+              <a:t>• The Crowd Problem: </a:t>
             </a:r>
             <a:r>
               <a:rPr b="0">
                 <a:solidFill>
-                  <a:srgbClr val="6B7280"/>
+                  <a:srgbClr val="64748B"/>
                 </a:solidFill>
               </a:rPr>
-              <a:t>When multiple workers stand directly in front of a box, the model can briefly lose track of it.</a:t>
+              <a:t>When 3 workers crowd directly in front of a box, the camera can temporarily lose sight of it.</a:t>
             </a:r>
           </a:p>
           <a:p>
@@ -8557,45 +8666,21 @@
               </a:spcBef>
               <a:defRPr sz="950" b="1">
                 <a:solidFill>
-                  <a:srgbClr val="1F2937"/>
-                </a:solidFill>
-                <a:latin typeface="Calibri"/>
-              </a:defRPr>
-            </a:pPr>
-            <a:r>
-              <a:t>• Fixed Camera Angles: </a:t>
+                  <a:srgbClr val="182B49"/>
+                </a:solidFill>
+                <a:latin typeface="Segoe UI"/>
+              </a:defRPr>
+            </a:pPr>
+            <a:r>
+              <a:t>• Morning Sunlight Glare: </a:t>
             </a:r>
             <a:r>
               <a:rPr b="0">
                 <a:solidFill>
-                  <a:srgbClr val="6B7280"/>
+                  <a:srgbClr val="64748B"/>
                 </a:solidFill>
               </a:rPr>
-              <a:t>Currently tested on 6 dock angles; new warehouse cameras need simple calibration.</a:t>
-            </a:r>
-          </a:p>
-          <a:p>
-            <a:pPr>
-              <a:spcBef>
-                <a:spcPts val="700"/>
-              </a:spcBef>
-              <a:defRPr sz="950" b="1">
-                <a:solidFill>
-                  <a:srgbClr val="1F2937"/>
-                </a:solidFill>
-                <a:latin typeface="Calibri"/>
-              </a:defRPr>
-            </a:pPr>
-            <a:r>
-              <a:t>• Lighting Changes: </a:t>
-            </a:r>
-            <a:r>
-              <a:rPr b="0">
-                <a:solidFill>
-                  <a:srgbClr val="6B7280"/>
-                </a:solidFill>
-              </a:rPr>
-              <a:t>Extreme shadows or glare at open bay doors can slightly reduce detection confidence.</a:t>
+              <a:t>Intense morning glare through open truck doors can slightly lower detection confidence.</a:t>
             </a:r>
           </a:p>
         </p:txBody>
@@ -8715,11 +8800,11 @@
                 <a:solidFill>
                   <a:srgbClr val="2563EB"/>
                 </a:solidFill>
-                <a:latin typeface="Calibri"/>
-              </a:defRPr>
-            </a:pPr>
-            <a:r>
-              <a:t>What We Plan to Build Next</a:t>
+                <a:latin typeface="Segoe UI"/>
+              </a:defRPr>
+            </a:pPr>
+            <a:r>
+              <a:t>What We're Building Next</a:t>
             </a:r>
           </a:p>
           <a:p>
@@ -8729,21 +8814,21 @@
               </a:spcBef>
               <a:defRPr sz="950" b="1">
                 <a:solidFill>
-                  <a:srgbClr val="1F2937"/>
-                </a:solidFill>
-                <a:latin typeface="Calibri"/>
-              </a:defRPr>
-            </a:pPr>
-            <a:r>
-              <a:t>• Edge Processing: </a:t>
+                  <a:srgbClr val="182B49"/>
+                </a:solidFill>
+                <a:latin typeface="Segoe UI"/>
+              </a:defRPr>
+            </a:pPr>
+            <a:r>
+              <a:t>• Edge Hardware (NVIDIA Jetson): </a:t>
             </a:r>
             <a:r>
               <a:rPr b="0">
                 <a:solidFill>
-                  <a:srgbClr val="6B7280"/>
+                  <a:srgbClr val="64748B"/>
                 </a:solidFill>
               </a:rPr>
-              <a:t>Test running YOLOv8 on an NVIDIA Jetson nano for instant on-premise inference (&lt;50ms).</a:t>
+              <a:t>Run YOLOv8 right on the dock on a $150 Jetson nano for instant &lt;50ms processing.</a:t>
             </a:r>
           </a:p>
           <a:p>
@@ -8753,9 +8838,9 @@
               </a:spcBef>
               <a:defRPr sz="950" b="1">
                 <a:solidFill>
-                  <a:srgbClr val="1F2937"/>
-                </a:solidFill>
-                <a:latin typeface="Calibri"/>
+                  <a:srgbClr val="182B49"/>
+                </a:solidFill>
+                <a:latin typeface="Segoe UI"/>
               </a:defRPr>
             </a:pPr>
             <a:r>
@@ -8764,7 +8849,7 @@
             <a:r>
               <a:rPr b="0">
                 <a:solidFill>
-                  <a:srgbClr val="6B7280"/>
+                  <a:srgbClr val="64748B"/>
                 </a:solidFill>
               </a:rPr>
               <a:t>Connect detection timestamps directly to package tracking numbers (WMS integration).</a:t>
@@ -8777,9 +8862,9 @@
               </a:spcBef>
               <a:defRPr sz="950" b="1">
                 <a:solidFill>
-                  <a:srgbClr val="1F2937"/>
-                </a:solidFill>
-                <a:latin typeface="Calibri"/>
+                  <a:srgbClr val="182B49"/>
+                </a:solidFill>
+                <a:latin typeface="Segoe UI"/>
               </a:defRPr>
             </a:pPr>
             <a:r>
@@ -8788,34 +8873,10 @@
             <a:r>
               <a:rPr b="0">
                 <a:solidFill>
-                  <a:srgbClr val="6B7280"/>
+                  <a:srgbClr val="64748B"/>
                 </a:solidFill>
               </a:rPr>
-              <a:t>Add pose estimation to warn workers when lifting heavy boxes with their back instead of legs.</a:t>
-            </a:r>
-          </a:p>
-          <a:p>
-            <a:pPr>
-              <a:spcBef>
-                <a:spcPts val="700"/>
-              </a:spcBef>
-              <a:defRPr sz="950" b="1">
-                <a:solidFill>
-                  <a:srgbClr val="1F2937"/>
-                </a:solidFill>
-                <a:latin typeface="Calibri"/>
-              </a:defRPr>
-            </a:pPr>
-            <a:r>
-              <a:t>• Mobile App for Supervisors: </a:t>
-            </a:r>
-            <a:r>
-              <a:rPr b="0">
-                <a:solidFill>
-                  <a:srgbClr val="6B7280"/>
-                </a:solidFill>
-              </a:rPr>
-              <a:t>Push notifications to mobile phones for floor supervisors.</a:t>
+              <a:t>Warn workers if they bend at the back instead of lifting with their knees to prevent injury.</a:t>
             </a:r>
           </a:p>
         </p:txBody>
@@ -8835,11 +8896,11 @@
             <a:avLst/>
           </a:prstGeom>
           <a:solidFill>
-            <a:srgbClr val="EFF6FF"/>
+            <a:srgbClr val="F3E8FF"/>
           </a:solidFill>
           <a:ln>
             <a:solidFill>
-              <a:srgbClr val="BFDBFE"/>
+              <a:srgbClr val="DDD6FE"/>
             </a:solidFill>
           </a:ln>
         </p:spPr>
@@ -8890,13 +8951,13 @@
             <a:pPr algn="ctr">
               <a:defRPr sz="1200" b="1">
                 <a:solidFill>
-                  <a:srgbClr val="1E3A8A"/>
-                </a:solidFill>
-                <a:latin typeface="Calibri"/>
-              </a:defRPr>
-            </a:pPr>
-            <a:r>
-              <a:t>Thank You! We are happy to answer any questions or demonstrate the live app.</a:t>
+                  <a:srgbClr val="6D28D9"/>
+                </a:solidFill>
+                <a:latin typeface="Segoe UI"/>
+              </a:defRPr>
+            </a:pPr>
+            <a:r>
+              <a:t>Thanks for listening! We'd love to show you the live demo and answer any questions.</a:t>
             </a:r>
           </a:p>
           <a:p>
@@ -8906,13 +8967,13 @@
               </a:spcBef>
               <a:defRPr sz="950">
                 <a:solidFill>
-                  <a:srgbClr val="6B7280"/>
-                </a:solidFill>
-                <a:latin typeface="Calibri"/>
-              </a:defRPr>
-            </a:pPr>
-            <a:r>
-              <a:t>Project Team: Aastha Gupta, Lucky Lakhani, Runjan Bawa  |  Live link: smart-warehouse-system-rk8p.onrender.com</a:t>
+                  <a:srgbClr val="64748B"/>
+                </a:solidFill>
+                <a:latin typeface="Segoe UI"/>
+              </a:defRPr>
+            </a:pPr>
+            <a:r>
+              <a:t>Team VisionGuard: Aastha Gupta, Lucky Lakhani, Runjan Bawa  |  Live link: smart-warehouse-system-rk8p.onrender.com</a:t>
             </a:r>
           </a:p>
         </p:txBody>

</xml_diff>

<commit_message>
Update all slides with pretty blue gradient theme (professional, human-made)
</commit_message>
<xml_diff>
--- a/Smart_Warehouse_DockGuard_Presentation.pptx
+++ b/Smart_Warehouse_DockGuard_Presentation.pptx
@@ -3107,12 +3107,26 @@
           <a:prstGeom prst="rect">
             <a:avLst/>
           </a:prstGeom>
-          <a:solidFill>
-            <a:srgbClr val="FFFFFF"/>
-          </a:solidFill>
           <a:ln>
             <a:noFill/>
           </a:ln>
+          <a:gradFill flip="none" rotWithShape="1">
+            <a:gsLst>
+              <a:gs pos="0">
+                <a:srgbClr val="08192E"/>
+              </a:gs>
+              <a:gs pos="42000">
+                <a:srgbClr val="12335E"/>
+              </a:gs>
+              <a:gs pos="78000">
+                <a:srgbClr val="1A4982"/>
+              </a:gs>
+              <a:gs pos="100000">
+                <a:srgbClr val="0A2140"/>
+              </a:gs>
+            </a:gsLst>
+            <a:lin ang="3240000" scaled="1"/>
+          </a:gradFill>
         </p:spPr>
         <p:style>
           <a:lnRef idx="1">
@@ -3151,7 +3165,7 @@
             <a:avLst/>
           </a:prstGeom>
           <a:solidFill>
-            <a:srgbClr val="6D28D9"/>
+            <a:srgbClr val="38BDF8"/>
           </a:solidFill>
           <a:ln>
             <a:noFill/>
@@ -3187,7 +3201,7 @@
         </p:nvSpPr>
         <p:spPr>
           <a:xfrm>
-            <a:off x="731520" y="960120"/>
+            <a:off x="731520" y="932688"/>
             <a:ext cx="10698480" cy="1280160"/>
           </a:xfrm>
           <a:prstGeom prst="rect">
@@ -3204,7 +3218,7 @@
             <a:pPr>
               <a:defRPr sz="3600" b="1">
                 <a:solidFill>
-                  <a:srgbClr val="182B49"/>
+                  <a:srgbClr val="FFFFFF"/>
                 </a:solidFill>
                 <a:latin typeface="Segoe UI"/>
               </a:defRPr>
@@ -3220,13 +3234,13 @@
               </a:spcBef>
               <a:defRPr sz="1600" b="1">
                 <a:solidFill>
-                  <a:srgbClr val="6D28D9"/>
-                </a:solidFill>
-                <a:latin typeface="Segoe UI"/>
-              </a:defRPr>
-            </a:pPr>
-            <a:r>
-              <a:t>Because gravity shouldn't win on the loading dock.</a:t>
+                  <a:srgbClr val="38BDF8"/>
+                </a:solidFill>
+                <a:latin typeface="Segoe UI"/>
+              </a:defRPr>
+            </a:pPr>
+            <a:r>
+              <a:t>Because gravity shouldn't win on the warehouse loading dock.</a:t>
             </a:r>
           </a:p>
         </p:txBody>
@@ -3246,11 +3260,11 @@
             <a:avLst/>
           </a:prstGeom>
           <a:solidFill>
-            <a:srgbClr val="F5F3FF"/>
+            <a:srgbClr val="143058"/>
           </a:solidFill>
           <a:ln w="12700">
             <a:solidFill>
-              <a:srgbClr val="DDD6FE"/>
+              <a:srgbClr val="2D5F9B"/>
             </a:solidFill>
           </a:ln>
         </p:spPr>
@@ -3301,7 +3315,7 @@
             <a:pPr>
               <a:defRPr sz="1000" b="1">
                 <a:solidFill>
-                  <a:srgbClr val="6D28D9"/>
+                  <a:srgbClr val="7DD3FC"/>
                 </a:solidFill>
                 <a:latin typeface="Segoe UI"/>
               </a:defRPr>
@@ -3317,7 +3331,7 @@
               </a:spcBef>
               <a:defRPr sz="1200">
                 <a:solidFill>
-                  <a:srgbClr val="334155"/>
+                  <a:srgbClr val="CBD5E1"/>
                 </a:solidFill>
                 <a:latin typeface="Segoe UI"/>
               </a:defRPr>
@@ -3343,11 +3357,11 @@
             <a:avLst/>
           </a:prstGeom>
           <a:solidFill>
-            <a:srgbClr val="F8FAFC"/>
+            <a:srgbClr val="0E1E36"/>
           </a:solidFill>
           <a:ln>
             <a:solidFill>
-              <a:srgbClr val="E2E8F0"/>
+              <a:srgbClr val="284B78"/>
             </a:solidFill>
           </a:ln>
         </p:spPr>
@@ -3398,7 +3412,7 @@
             <a:pPr>
               <a:defRPr sz="1100" b="1">
                 <a:solidFill>
-                  <a:srgbClr val="182B49"/>
+                  <a:srgbClr val="7DD3FC"/>
                 </a:solidFill>
                 <a:latin typeface="Segoe UI"/>
               </a:defRPr>
@@ -3414,7 +3428,7 @@
               </a:spcBef>
               <a:defRPr sz="1100" b="1">
                 <a:solidFill>
-                  <a:srgbClr val="182B49"/>
+                  <a:srgbClr val="FFFFFF"/>
                 </a:solidFill>
                 <a:latin typeface="Segoe UI"/>
               </a:defRPr>
@@ -3425,7 +3439,7 @@
             <a:r>
               <a:rPr b="1">
                 <a:solidFill>
-                  <a:srgbClr val="6D28D9"/>
+                  <a:srgbClr val="C084FC"/>
                 </a:solidFill>
               </a:rPr>
               <a:t>[Vision Whisperer]</a:t>
@@ -3435,7 +3449,7 @@
             <a:pPr>
               <a:defRPr sz="950">
                 <a:solidFill>
-                  <a:srgbClr val="64748B"/>
+                  <a:srgbClr val="94A3B8"/>
                 </a:solidFill>
                 <a:latin typeface="Segoe UI"/>
               </a:defRPr>
@@ -3451,7 +3465,7 @@
               </a:spcBef>
               <a:defRPr sz="1100" b="1">
                 <a:solidFill>
-                  <a:srgbClr val="182B49"/>
+                  <a:srgbClr val="FFFFFF"/>
                 </a:solidFill>
                 <a:latin typeface="Segoe UI"/>
               </a:defRPr>
@@ -3462,7 +3476,7 @@
             <a:r>
               <a:rPr b="1">
                 <a:solidFill>
-                  <a:srgbClr val="6D28D9"/>
+                  <a:srgbClr val="C084FC"/>
                 </a:solidFill>
               </a:rPr>
               <a:t>[Pipeline &amp; AI Hacker]</a:t>
@@ -3472,7 +3486,7 @@
             <a:pPr>
               <a:defRPr sz="950">
                 <a:solidFill>
-                  <a:srgbClr val="64748B"/>
+                  <a:srgbClr val="94A3B8"/>
                 </a:solidFill>
                 <a:latin typeface="Segoe UI"/>
               </a:defRPr>
@@ -3488,7 +3502,7 @@
               </a:spcBef>
               <a:defRPr sz="1100" b="1">
                 <a:solidFill>
-                  <a:srgbClr val="182B49"/>
+                  <a:srgbClr val="FFFFFF"/>
                 </a:solidFill>
                 <a:latin typeface="Segoe UI"/>
               </a:defRPr>
@@ -3499,7 +3513,7 @@
             <a:r>
               <a:rPr b="1">
                 <a:solidFill>
-                  <a:srgbClr val="6D28D9"/>
+                  <a:srgbClr val="C084FC"/>
                 </a:solidFill>
               </a:rPr>
               <a:t>[UI &amp; Experience Builder]</a:t>
@@ -3509,7 +3523,7 @@
             <a:pPr>
               <a:defRPr sz="950">
                 <a:solidFill>
-                  <a:srgbClr val="64748B"/>
+                  <a:srgbClr val="94A3B8"/>
                 </a:solidFill>
                 <a:latin typeface="Segoe UI"/>
               </a:defRPr>
@@ -3535,11 +3549,11 @@
             <a:avLst/>
           </a:prstGeom>
           <a:solidFill>
-            <a:srgbClr val="F8FAFC"/>
+            <a:srgbClr val="0E1E36"/>
           </a:solidFill>
           <a:ln>
             <a:solidFill>
-              <a:srgbClr val="E2E8F0"/>
+              <a:srgbClr val="284B78"/>
             </a:solidFill>
           </a:ln>
         </p:spPr>
@@ -3590,7 +3604,7 @@
             <a:pPr>
               <a:defRPr sz="1100" b="1">
                 <a:solidFill>
-                  <a:srgbClr val="182B49"/>
+                  <a:srgbClr val="7DD3FC"/>
                 </a:solidFill>
                 <a:latin typeface="Segoe UI"/>
               </a:defRPr>
@@ -3606,7 +3620,7 @@
               </a:spcBef>
               <a:defRPr sz="1000" b="1">
                 <a:solidFill>
-                  <a:srgbClr val="334155"/>
+                  <a:srgbClr val="FFFFFF"/>
                 </a:solidFill>
                 <a:latin typeface="Segoe UI"/>
               </a:defRPr>
@@ -3617,7 +3631,7 @@
             <a:r>
               <a:rPr b="0">
                 <a:solidFill>
-                  <a:srgbClr val="64748B"/>
+                  <a:srgbClr val="CBD5E1"/>
                 </a:solidFill>
               </a:rPr>
               <a:t>That's how much merchandise gets wrecked in warehouses before even making it onto the highway. Most of it goes completely unrecorded.</a:t>
@@ -3630,7 +3644,7 @@
               </a:spcBef>
               <a:defRPr sz="1000" b="1">
                 <a:solidFill>
-                  <a:srgbClr val="334155"/>
+                  <a:srgbClr val="FFFFFF"/>
                 </a:solidFill>
                 <a:latin typeface="Segoe UI"/>
               </a:defRPr>
@@ -3641,10 +3655,10 @@
             <a:r>
               <a:rPr b="0">
                 <a:solidFill>
-                  <a:srgbClr val="64748B"/>
+                  <a:srgbClr val="CBD5E1"/>
                 </a:solidFill>
               </a:rPr>
-              <a:t>A single supervisor can't watch 10 bays, 40 fast-moving workers, and forklift traffic all at once. Blame usually turns into guessing games.</a:t>
+              <a:t>A single supervisor can't watch 10 bays, 40 fast-moving workers, and forklift traffic all at once. Blame turns into guessing games.</a:t>
             </a:r>
           </a:p>
           <a:p>
@@ -3654,7 +3668,7 @@
               </a:spcBef>
               <a:defRPr sz="1000" b="1">
                 <a:solidFill>
-                  <a:srgbClr val="334155"/>
+                  <a:srgbClr val="FFFFFF"/>
                 </a:solidFill>
                 <a:latin typeface="Segoe UI"/>
               </a:defRPr>
@@ -3665,7 +3679,7 @@
             <a:r>
               <a:rPr b="0">
                 <a:solidFill>
-                  <a:srgbClr val="64748B"/>
+                  <a:srgbClr val="CBD5E1"/>
                 </a:solidFill>
               </a:rPr>
               <a:t>If you catch a cracked box before it's loaded into the trailer, replacing it costs $10. If it reaches the customer, it costs $200+ and a bad review.</a:t>
@@ -3705,12 +3719,26 @@
           <a:prstGeom prst="rect">
             <a:avLst/>
           </a:prstGeom>
-          <a:solidFill>
-            <a:srgbClr val="FFFFFF"/>
-          </a:solidFill>
           <a:ln>
             <a:noFill/>
           </a:ln>
+          <a:gradFill flip="none" rotWithShape="1">
+            <a:gsLst>
+              <a:gs pos="0">
+                <a:srgbClr val="08192E"/>
+              </a:gs>
+              <a:gs pos="42000">
+                <a:srgbClr val="12335E"/>
+              </a:gs>
+              <a:gs pos="78000">
+                <a:srgbClr val="1A4982"/>
+              </a:gs>
+              <a:gs pos="100000">
+                <a:srgbClr val="0A2140"/>
+              </a:gs>
+            </a:gsLst>
+            <a:lin ang="3240000" scaled="1"/>
+          </a:gradFill>
         </p:spPr>
         <p:style>
           <a:lnRef idx="1">
@@ -3743,16 +3771,18 @@
         <p:spPr>
           <a:xfrm>
             <a:off x="731520" y="365760"/>
-            <a:ext cx="2560320" cy="292608"/>
+            <a:ext cx="2651760" cy="292608"/>
           </a:xfrm>
           <a:prstGeom prst="roundRect">
             <a:avLst/>
           </a:prstGeom>
           <a:solidFill>
-            <a:srgbClr val="F3E8FF"/>
+            <a:srgbClr val="143058"/>
           </a:solidFill>
-          <a:ln>
-            <a:noFill/>
+          <a:ln w="12700">
+            <a:solidFill>
+              <a:srgbClr val="3872BA"/>
+            </a:solidFill>
           </a:ln>
         </p:spPr>
         <p:style>
@@ -3776,7 +3806,7 @@
             <a:pPr algn="ctr">
               <a:defRPr sz="950" b="1">
                 <a:solidFill>
-                  <a:srgbClr val="6D28D9"/>
+                  <a:srgbClr val="93C5FD"/>
                 </a:solidFill>
                 <a:latin typeface="Segoe UI"/>
               </a:defRPr>
@@ -3812,7 +3842,7 @@
             <a:pPr>
               <a:defRPr sz="2100" b="1">
                 <a:solidFill>
-                  <a:srgbClr val="182B49"/>
+                  <a:srgbClr val="FFFFFF"/>
                 </a:solidFill>
                 <a:latin typeface="Segoe UI"/>
               </a:defRPr>
@@ -3832,13 +3862,13 @@
         <p:spPr>
           <a:xfrm>
             <a:off x="731520" y="1243584"/>
-            <a:ext cx="10728655" cy="13716"/>
+            <a:ext cx="10728655" cy="18288"/>
           </a:xfrm>
           <a:prstGeom prst="rect">
             <a:avLst/>
           </a:prstGeom>
           <a:solidFill>
-            <a:srgbClr val="E2E8F0"/>
+            <a:srgbClr val="2D558C"/>
           </a:solidFill>
           <a:ln>
             <a:noFill/>
@@ -3881,11 +3911,11 @@
             <a:avLst/>
           </a:prstGeom>
           <a:solidFill>
-            <a:srgbClr val="F8FAFC"/>
+            <a:srgbClr val="0E1E36"/>
           </a:solidFill>
           <a:ln w="12700">
             <a:solidFill>
-              <a:srgbClr val="E2E8F0"/>
+              <a:srgbClr val="284B78"/>
             </a:solidFill>
           </a:ln>
         </p:spPr>
@@ -3936,7 +3966,7 @@
             <a:pPr algn="ctr">
               <a:defRPr sz="1000" b="1">
                 <a:solidFill>
-                  <a:srgbClr val="182B49"/>
+                  <a:srgbClr val="FFFFFF"/>
                 </a:solidFill>
                 <a:latin typeface="Segoe UI"/>
               </a:defRPr>
@@ -3952,7 +3982,7 @@
               </a:spcBef>
               <a:defRPr sz="850">
                 <a:solidFill>
-                  <a:srgbClr val="64748B"/>
+                  <a:srgbClr val="CBD5E1"/>
                 </a:solidFill>
                 <a:latin typeface="Segoe UI"/>
               </a:defRPr>
@@ -3978,11 +4008,11 @@
             <a:avLst/>
           </a:prstGeom>
           <a:solidFill>
-            <a:srgbClr val="F8FAFC"/>
+            <a:srgbClr val="0E1E36"/>
           </a:solidFill>
           <a:ln w="12700">
             <a:solidFill>
-              <a:srgbClr val="E2E8F0"/>
+              <a:srgbClr val="284B78"/>
             </a:solidFill>
           </a:ln>
         </p:spPr>
@@ -4033,7 +4063,7 @@
             <a:pPr algn="ctr">
               <a:defRPr sz="1000" b="1">
                 <a:solidFill>
-                  <a:srgbClr val="182B49"/>
+                  <a:srgbClr val="FFFFFF"/>
                 </a:solidFill>
                 <a:latin typeface="Segoe UI"/>
               </a:defRPr>
@@ -4049,7 +4079,7 @@
               </a:spcBef>
               <a:defRPr sz="850">
                 <a:solidFill>
-                  <a:srgbClr val="64748B"/>
+                  <a:srgbClr val="CBD5E1"/>
                 </a:solidFill>
                 <a:latin typeface="Segoe UI"/>
               </a:defRPr>
@@ -4075,11 +4105,11 @@
             <a:avLst/>
           </a:prstGeom>
           <a:solidFill>
-            <a:srgbClr val="F8FAFC"/>
+            <a:srgbClr val="0E1E36"/>
           </a:solidFill>
           <a:ln w="12700">
             <a:solidFill>
-              <a:srgbClr val="E2E8F0"/>
+              <a:srgbClr val="284B78"/>
             </a:solidFill>
           </a:ln>
         </p:spPr>
@@ -4130,7 +4160,7 @@
             <a:pPr algn="ctr">
               <a:defRPr sz="1000" b="1">
                 <a:solidFill>
-                  <a:srgbClr val="182B49"/>
+                  <a:srgbClr val="FFFFFF"/>
                 </a:solidFill>
                 <a:latin typeface="Segoe UI"/>
               </a:defRPr>
@@ -4146,7 +4176,7 @@
               </a:spcBef>
               <a:defRPr sz="850">
                 <a:solidFill>
-                  <a:srgbClr val="64748B"/>
+                  <a:srgbClr val="CBD5E1"/>
                 </a:solidFill>
                 <a:latin typeface="Segoe UI"/>
               </a:defRPr>
@@ -4172,11 +4202,11 @@
             <a:avLst/>
           </a:prstGeom>
           <a:solidFill>
-            <a:srgbClr val="F3E8FF"/>
+            <a:srgbClr val="1E4173"/>
           </a:solidFill>
           <a:ln w="19050">
             <a:solidFill>
-              <a:srgbClr val="6D28D9"/>
+              <a:srgbClr val="38BDF8"/>
             </a:solidFill>
           </a:ln>
         </p:spPr>
@@ -4227,7 +4257,7 @@
             <a:pPr algn="ctr">
               <a:defRPr sz="1000" b="1">
                 <a:solidFill>
-                  <a:srgbClr val="6D28D9"/>
+                  <a:srgbClr val="7DD3FC"/>
                 </a:solidFill>
                 <a:latin typeface="Segoe UI"/>
               </a:defRPr>
@@ -4243,7 +4273,7 @@
               </a:spcBef>
               <a:defRPr sz="850">
                 <a:solidFill>
-                  <a:srgbClr val="64748B"/>
+                  <a:srgbClr val="CBD5E1"/>
                 </a:solidFill>
                 <a:latin typeface="Segoe UI"/>
               </a:defRPr>
@@ -4269,11 +4299,11 @@
             <a:avLst/>
           </a:prstGeom>
           <a:solidFill>
-            <a:srgbClr val="F3E8FF"/>
+            <a:srgbClr val="1E4173"/>
           </a:solidFill>
           <a:ln w="19050">
             <a:solidFill>
-              <a:srgbClr val="6D28D9"/>
+              <a:srgbClr val="38BDF8"/>
             </a:solidFill>
           </a:ln>
         </p:spPr>
@@ -4324,7 +4354,7 @@
             <a:pPr algn="ctr">
               <a:defRPr sz="1000" b="1">
                 <a:solidFill>
-                  <a:srgbClr val="6D28D9"/>
+                  <a:srgbClr val="7DD3FC"/>
                 </a:solidFill>
                 <a:latin typeface="Segoe UI"/>
               </a:defRPr>
@@ -4340,7 +4370,7 @@
               </a:spcBef>
               <a:defRPr sz="850">
                 <a:solidFill>
-                  <a:srgbClr val="64748B"/>
+                  <a:srgbClr val="CBD5E1"/>
                 </a:solidFill>
                 <a:latin typeface="Segoe UI"/>
               </a:defRPr>
@@ -4366,11 +4396,11 @@
             <a:avLst/>
           </a:prstGeom>
           <a:solidFill>
-            <a:srgbClr val="F8FAFC"/>
+            <a:srgbClr val="0E1E36"/>
           </a:solidFill>
           <a:ln w="12700">
             <a:solidFill>
-              <a:srgbClr val="E2E8F0"/>
+              <a:srgbClr val="284B78"/>
             </a:solidFill>
           </a:ln>
         </p:spPr>
@@ -4421,7 +4451,7 @@
             <a:pPr algn="ctr">
               <a:defRPr sz="1000" b="1">
                 <a:solidFill>
-                  <a:srgbClr val="182B49"/>
+                  <a:srgbClr val="FFFFFF"/>
                 </a:solidFill>
                 <a:latin typeface="Segoe UI"/>
               </a:defRPr>
@@ -4437,7 +4467,7 @@
               </a:spcBef>
               <a:defRPr sz="850">
                 <a:solidFill>
-                  <a:srgbClr val="64748B"/>
+                  <a:srgbClr val="CBD5E1"/>
                 </a:solidFill>
                 <a:latin typeface="Segoe UI"/>
               </a:defRPr>
@@ -4463,11 +4493,11 @@
             <a:avLst/>
           </a:prstGeom>
           <a:solidFill>
-            <a:srgbClr val="F3E8FF"/>
+            <a:srgbClr val="1E4173"/>
           </a:solidFill>
           <a:ln w="19050">
             <a:solidFill>
-              <a:srgbClr val="6D28D9"/>
+              <a:srgbClr val="38BDF8"/>
             </a:solidFill>
           </a:ln>
         </p:spPr>
@@ -4518,7 +4548,7 @@
             <a:pPr algn="ctr">
               <a:defRPr sz="1000" b="1">
                 <a:solidFill>
-                  <a:srgbClr val="6D28D9"/>
+                  <a:srgbClr val="7DD3FC"/>
                 </a:solidFill>
                 <a:latin typeface="Segoe UI"/>
               </a:defRPr>
@@ -4534,7 +4564,7 @@
               </a:spcBef>
               <a:defRPr sz="850">
                 <a:solidFill>
-                  <a:srgbClr val="64748B"/>
+                  <a:srgbClr val="CBD5E1"/>
                 </a:solidFill>
                 <a:latin typeface="Segoe UI"/>
               </a:defRPr>
@@ -4560,11 +4590,11 @@
             <a:avLst/>
           </a:prstGeom>
           <a:solidFill>
-            <a:srgbClr val="F8FAFC"/>
+            <a:srgbClr val="0E1E36"/>
           </a:solidFill>
           <a:ln>
             <a:solidFill>
-              <a:srgbClr val="E2E8F0"/>
+              <a:srgbClr val="284B78"/>
             </a:solidFill>
           </a:ln>
         </p:spPr>
@@ -4592,181 +4622,23 @@
       </p:sp>
       <p:sp>
         <p:nvSpPr>
-          <p:cNvPr id="21" name="TextBox 20"/>
-          <p:cNvSpPr txBox="1"/>
-          <p:nvPr/>
-        </p:nvSpPr>
-        <p:spPr>
-          <a:xfrm>
-            <a:off x="960120" y="2770632"/>
-            <a:ext cx="4754880" cy="3566160"/>
+          <p:cNvPr id="21" name="Rectangle 20"/>
+          <p:cNvSpPr/>
+          <p:nvPr/>
+        </p:nvSpPr>
+        <p:spPr>
+          <a:xfrm>
+            <a:off x="731520" y="2606040"/>
+            <a:ext cx="5212080" cy="45720"/>
           </a:xfrm>
           <a:prstGeom prst="rect">
             <a:avLst/>
           </a:prstGeom>
-          <a:noFill/>
-        </p:spPr>
-        <p:txBody>
-          <a:bodyPr wrap="square">
-            <a:spAutoFit/>
-          </a:bodyPr>
-          <a:lstStyle/>
-          <a:p>
-            <a:pPr>
-              <a:defRPr sz="1100" b="1">
-                <a:solidFill>
-                  <a:srgbClr val="182B49"/>
-                </a:solidFill>
-                <a:latin typeface="Segoe UI"/>
-              </a:defRPr>
-            </a:pPr>
-            <a:r>
-              <a:t>THE LOADER'S STORY: Ramesh at Loading Bay 3</a:t>
-            </a:r>
-          </a:p>
-          <a:p>
-            <a:pPr>
-              <a:spcBef>
-                <a:spcPts val="600"/>
-              </a:spcBef>
-              <a:defRPr sz="950" b="1">
-                <a:solidFill>
-                  <a:srgbClr val="334155"/>
-                </a:solidFill>
-                <a:latin typeface="Segoe UI"/>
-              </a:defRPr>
-            </a:pPr>
-            <a:r>
-              <a:t>• The Rush: </a:t>
-            </a:r>
-            <a:r>
-              <a:rPr b="0">
-                <a:solidFill>
-                  <a:srgbClr val="64748B"/>
-                </a:solidFill>
-              </a:rPr>
-              <a:t>It's 4:15 PM, 34°C, and Ramesh has 45 minutes to finish packing a 40-foot trailer.</a:t>
-            </a:r>
-          </a:p>
-          <a:p>
-            <a:pPr>
-              <a:spcBef>
-                <a:spcPts val="600"/>
-              </a:spcBef>
-              <a:defRPr sz="950" b="1">
-                <a:solidFill>
-                  <a:srgbClr val="334155"/>
-                </a:solidFill>
-                <a:latin typeface="Segoe UI"/>
-              </a:defRPr>
-            </a:pPr>
-            <a:r>
-              <a:t>• The Slip: </a:t>
-            </a:r>
-            <a:r>
-              <a:rPr b="0">
-                <a:solidFill>
-                  <a:srgbClr val="64748B"/>
-                </a:solidFill>
-              </a:rPr>
-              <a:t>He lifts a 25kg crate without a partner. His grip slips, and the box crashes 1.2 meters to the concrete.</a:t>
-            </a:r>
-          </a:p>
-          <a:p>
-            <a:pPr>
-              <a:spcBef>
-                <a:spcPts val="600"/>
-              </a:spcBef>
-              <a:defRPr sz="950" b="1">
-                <a:solidFill>
-                  <a:srgbClr val="334155"/>
-                </a:solidFill>
-                <a:latin typeface="Segoe UI"/>
-              </a:defRPr>
-            </a:pPr>
-            <a:r>
-              <a:t>• No Panic Siren: </a:t>
-            </a:r>
-            <a:r>
-              <a:rPr b="0">
-                <a:solidFill>
-                  <a:srgbClr val="64748B"/>
-                </a:solidFill>
-              </a:rPr>
-              <a:t>Instead of an ear-piercing fire alarm that makes everyone freeze, a friendly, microwave-style *ding* chimes at Bay 3, and his dock screen flashes yellow.</a:t>
-            </a:r>
-          </a:p>
-          <a:p>
-            <a:pPr>
-              <a:spcBef>
-                <a:spcPts val="600"/>
-              </a:spcBef>
-              <a:defRPr sz="950" b="1">
-                <a:solidFill>
-                  <a:srgbClr val="334155"/>
-                </a:solidFill>
-                <a:latin typeface="Segoe UI"/>
-              </a:defRPr>
-            </a:pPr>
-            <a:r>
-              <a:t>• What He Does: </a:t>
-            </a:r>
-            <a:r>
-              <a:rPr b="0">
-                <a:solidFill>
-                  <a:srgbClr val="64748B"/>
-                </a:solidFill>
-              </a:rPr>
-              <a:t>Instead of sheepishly hiding the box in the back of the truck, Ramesh stops, inspects the tape, calls his teammate for a 2-person lift, and sets the item aside.</a:t>
-            </a:r>
-          </a:p>
-          <a:p>
-            <a:pPr>
-              <a:spcBef>
-                <a:spcPts val="600"/>
-              </a:spcBef>
-              <a:defRPr sz="950" b="1">
-                <a:solidFill>
-                  <a:srgbClr val="334155"/>
-                </a:solidFill>
-                <a:latin typeface="Segoe UI"/>
-              </a:defRPr>
-            </a:pPr>
-            <a:r>
-              <a:t>• The Win: </a:t>
-            </a:r>
-            <a:r>
-              <a:rPr b="0">
-                <a:solidFill>
-                  <a:srgbClr val="64748B"/>
-                </a:solidFill>
-              </a:rPr>
-              <a:t>No broken microwave sent to a furious customer, and Ramesh learns to ask for a hand with heavy loads.</a:t>
-            </a:r>
-          </a:p>
-        </p:txBody>
-      </p:sp>
-      <p:sp>
-        <p:nvSpPr>
-          <p:cNvPr id="22" name="Rounded Rectangle 21"/>
-          <p:cNvSpPr/>
-          <p:nvPr/>
-        </p:nvSpPr>
-        <p:spPr>
-          <a:xfrm>
-            <a:off x="6248095" y="2606040"/>
-            <a:ext cx="5212080" cy="3840480"/>
-          </a:xfrm>
-          <a:prstGeom prst="roundRect">
-            <a:avLst/>
-          </a:prstGeom>
           <a:solidFill>
-            <a:srgbClr val="F8FAFC"/>
+            <a:srgbClr val="38BDF8"/>
           </a:solidFill>
           <a:ln>
-            <a:solidFill>
-              <a:srgbClr val="E2E8F0"/>
-            </a:solidFill>
+            <a:noFill/>
           </a:ln>
         </p:spPr>
         <p:style>
@@ -4793,13 +4665,13 @@
       </p:sp>
       <p:sp>
         <p:nvSpPr>
-          <p:cNvPr id="23" name="TextBox 22"/>
+          <p:cNvPr id="22" name="TextBox 21"/>
           <p:cNvSpPr txBox="1"/>
           <p:nvPr/>
         </p:nvSpPr>
         <p:spPr>
           <a:xfrm>
-            <a:off x="6473952" y="2770632"/>
+            <a:off x="960120" y="2770632"/>
             <a:ext cx="4754880" cy="3566160"/>
           </a:xfrm>
           <a:prstGeom prst="rect">
@@ -4816,13 +4688,13 @@
             <a:pPr>
               <a:defRPr sz="1100" b="1">
                 <a:solidFill>
-                  <a:srgbClr val="6D28D9"/>
-                </a:solidFill>
-                <a:latin typeface="Segoe UI"/>
-              </a:defRPr>
-            </a:pPr>
-            <a:r>
-              <a:t>THE SUPERVISOR'S STORY: Pooja with her iPad</a:t>
+                  <a:srgbClr val="7DD3FC"/>
+                </a:solidFill>
+                <a:latin typeface="Segoe UI"/>
+              </a:defRPr>
+            </a:pPr>
+            <a:r>
+              <a:t>THE LOADER'S STORY: Ramesh at Loading Bay 3</a:t>
             </a:r>
           </a:p>
           <a:p>
@@ -4832,21 +4704,21 @@
               </a:spcBef>
               <a:defRPr sz="950" b="1">
                 <a:solidFill>
-                  <a:srgbClr val="334155"/>
-                </a:solidFill>
-                <a:latin typeface="Segoe UI"/>
-              </a:defRPr>
-            </a:pPr>
-            <a:r>
-              <a:t>• The Daily Nightmare: </a:t>
+                  <a:srgbClr val="FFFFFF"/>
+                </a:solidFill>
+                <a:latin typeface="Segoe UI"/>
+              </a:defRPr>
+            </a:pPr>
+            <a:r>
+              <a:t>• The Rush: </a:t>
             </a:r>
             <a:r>
               <a:rPr b="0">
                 <a:solidFill>
-                  <a:srgbClr val="64748B"/>
+                  <a:srgbClr val="CBD5E1"/>
                 </a:solidFill>
               </a:rPr>
-              <a:t>Pooja used to spend 45 minutes every evening fast-forwarding through blurry CCTV tapes trying to figure out who dropped a customer's TV.</a:t>
+              <a:t>It's 4:15 PM, 34°C, and Ramesh has 45 minutes to finish packing a 40-foot trailer.</a:t>
             </a:r>
           </a:p>
           <a:p>
@@ -4856,21 +4728,21 @@
               </a:spcBef>
               <a:defRPr sz="950" b="1">
                 <a:solidFill>
-                  <a:srgbClr val="334155"/>
-                </a:solidFill>
-                <a:latin typeface="Segoe UI"/>
-              </a:defRPr>
-            </a:pPr>
-            <a:r>
-              <a:t>• Instant Notification: </a:t>
+                  <a:srgbClr val="FFFFFF"/>
+                </a:solidFill>
+                <a:latin typeface="Segoe UI"/>
+              </a:defRPr>
+            </a:pPr>
+            <a:r>
+              <a:t>• The Slip: </a:t>
             </a:r>
             <a:r>
               <a:rPr b="0">
                 <a:solidFill>
-                  <a:srgbClr val="64748B"/>
+                  <a:srgbClr val="CBD5E1"/>
                 </a:solidFill>
               </a:rPr>
-              <a:t>Her tablet buzzes: 'Bay 3: High-Velocity Drop Flagged (10:14 AM)'.</a:t>
+              <a:t>He tries lifting a 25kg crate without a partner. His grip slips, and the box crashes 1.2 meters to the concrete.</a:t>
             </a:r>
           </a:p>
           <a:p>
@@ -4880,21 +4752,21 @@
               </a:spcBef>
               <a:defRPr sz="950" b="1">
                 <a:solidFill>
-                  <a:srgbClr val="334155"/>
-                </a:solidFill>
-                <a:latin typeface="Segoe UI"/>
-              </a:defRPr>
-            </a:pPr>
-            <a:r>
-              <a:t>• TikTok-Length Replay: </a:t>
+                  <a:srgbClr val="FFFFFF"/>
+                </a:solidFill>
+                <a:latin typeface="Segoe UI"/>
+              </a:defRPr>
+            </a:pPr>
+            <a:r>
+              <a:t>• No Panic Siren: </a:t>
             </a:r>
             <a:r>
               <a:rPr b="0">
                 <a:solidFill>
-                  <a:srgbClr val="64748B"/>
+                  <a:srgbClr val="CBD5E1"/>
                 </a:solidFill>
               </a:rPr>
-              <a:t>She taps it and immediately watches a 5-second replay showing the carton falling, complete with bounding box tracking and impact velocity.</a:t>
+              <a:t>Instead of an ear-piercing fire alarm that makes everyone freeze, a friendly, microwave-style *ding* chimes at Bay 3, and his dock screen flashes yellow.</a:t>
             </a:r>
           </a:p>
           <a:p>
@@ -4904,21 +4776,21 @@
               </a:spcBef>
               <a:defRPr sz="950" b="1">
                 <a:solidFill>
-                  <a:srgbClr val="334155"/>
-                </a:solidFill>
-                <a:latin typeface="Segoe UI"/>
-              </a:defRPr>
-            </a:pPr>
-            <a:r>
-              <a:t>• Quick Resolution: </a:t>
+                  <a:srgbClr val="FFFFFF"/>
+                </a:solidFill>
+                <a:latin typeface="Segoe UI"/>
+              </a:defRPr>
+            </a:pPr>
+            <a:r>
+              <a:t>• What He Does: </a:t>
             </a:r>
             <a:r>
               <a:rPr b="0">
                 <a:solidFill>
-                  <a:srgbClr val="64748B"/>
+                  <a:srgbClr val="CBD5E1"/>
                 </a:solidFill>
               </a:rPr>
-              <a:t>She signs off on a packaging replacement in 10 seconds flat—no shouting matches, no guessing.</a:t>
+              <a:t>Instead of sheepishly hiding the box in the back of the truck, Ramesh stops, inspects the tape, calls his teammate for a 2-person lift, and sets the item aside.</a:t>
             </a:r>
           </a:p>
           <a:p>
@@ -4928,7 +4800,251 @@
               </a:spcBef>
               <a:defRPr sz="950" b="1">
                 <a:solidFill>
-                  <a:srgbClr val="334155"/>
+                  <a:srgbClr val="FFFFFF"/>
+                </a:solidFill>
+                <a:latin typeface="Segoe UI"/>
+              </a:defRPr>
+            </a:pPr>
+            <a:r>
+              <a:t>• The Win: </a:t>
+            </a:r>
+            <a:r>
+              <a:rPr b="0">
+                <a:solidFill>
+                  <a:srgbClr val="CBD5E1"/>
+                </a:solidFill>
+              </a:rPr>
+              <a:t>No broken microwave sent to a customer, and Ramesh learns to ask for a hand with heavy loads.</a:t>
+            </a:r>
+          </a:p>
+        </p:txBody>
+      </p:sp>
+      <p:sp>
+        <p:nvSpPr>
+          <p:cNvPr id="23" name="Rounded Rectangle 22"/>
+          <p:cNvSpPr/>
+          <p:nvPr/>
+        </p:nvSpPr>
+        <p:spPr>
+          <a:xfrm>
+            <a:off x="6248095" y="2606040"/>
+            <a:ext cx="5212080" cy="3840480"/>
+          </a:xfrm>
+          <a:prstGeom prst="roundRect">
+            <a:avLst/>
+          </a:prstGeom>
+          <a:solidFill>
+            <a:srgbClr val="0E1E36"/>
+          </a:solidFill>
+          <a:ln>
+            <a:solidFill>
+              <a:srgbClr val="284B78"/>
+            </a:solidFill>
+          </a:ln>
+        </p:spPr>
+        <p:style>
+          <a:lnRef idx="1">
+            <a:schemeClr val="accent1"/>
+          </a:lnRef>
+          <a:fillRef idx="3">
+            <a:schemeClr val="accent1"/>
+          </a:fillRef>
+          <a:effectRef idx="2">
+            <a:schemeClr val="accent1"/>
+          </a:effectRef>
+          <a:fontRef idx="minor">
+            <a:schemeClr val="lt1"/>
+          </a:fontRef>
+        </p:style>
+        <p:txBody>
+          <a:bodyPr rtlCol="0" anchor="ctr"/>
+          <a:lstStyle/>
+          <a:p>
+            <a:pPr algn="ctr"/>
+          </a:p>
+        </p:txBody>
+      </p:sp>
+      <p:sp>
+        <p:nvSpPr>
+          <p:cNvPr id="24" name="Rectangle 23"/>
+          <p:cNvSpPr/>
+          <p:nvPr/>
+        </p:nvSpPr>
+        <p:spPr>
+          <a:xfrm>
+            <a:off x="6248095" y="2606040"/>
+            <a:ext cx="5212080" cy="45720"/>
+          </a:xfrm>
+          <a:prstGeom prst="rect">
+            <a:avLst/>
+          </a:prstGeom>
+          <a:solidFill>
+            <a:srgbClr val="C084FC"/>
+          </a:solidFill>
+          <a:ln>
+            <a:noFill/>
+          </a:ln>
+        </p:spPr>
+        <p:style>
+          <a:lnRef idx="1">
+            <a:schemeClr val="accent1"/>
+          </a:lnRef>
+          <a:fillRef idx="3">
+            <a:schemeClr val="accent1"/>
+          </a:fillRef>
+          <a:effectRef idx="2">
+            <a:schemeClr val="accent1"/>
+          </a:effectRef>
+          <a:fontRef idx="minor">
+            <a:schemeClr val="lt1"/>
+          </a:fontRef>
+        </p:style>
+        <p:txBody>
+          <a:bodyPr rtlCol="0" anchor="ctr"/>
+          <a:lstStyle/>
+          <a:p>
+            <a:pPr algn="ctr"/>
+          </a:p>
+        </p:txBody>
+      </p:sp>
+      <p:sp>
+        <p:nvSpPr>
+          <p:cNvPr id="25" name="TextBox 24"/>
+          <p:cNvSpPr txBox="1"/>
+          <p:nvPr/>
+        </p:nvSpPr>
+        <p:spPr>
+          <a:xfrm>
+            <a:off x="6473952" y="2770632"/>
+            <a:ext cx="4754880" cy="3566160"/>
+          </a:xfrm>
+          <a:prstGeom prst="rect">
+            <a:avLst/>
+          </a:prstGeom>
+          <a:noFill/>
+        </p:spPr>
+        <p:txBody>
+          <a:bodyPr wrap="square">
+            <a:spAutoFit/>
+          </a:bodyPr>
+          <a:lstStyle/>
+          <a:p>
+            <a:pPr>
+              <a:defRPr sz="1100" b="1">
+                <a:solidFill>
+                  <a:srgbClr val="C084FC"/>
+                </a:solidFill>
+                <a:latin typeface="Segoe UI"/>
+              </a:defRPr>
+            </a:pPr>
+            <a:r>
+              <a:t>THE SUPERVISOR'S STORY: Pooja with her iPad</a:t>
+            </a:r>
+          </a:p>
+          <a:p>
+            <a:pPr>
+              <a:spcBef>
+                <a:spcPts val="600"/>
+              </a:spcBef>
+              <a:defRPr sz="950" b="1">
+                <a:solidFill>
+                  <a:srgbClr val="FFFFFF"/>
+                </a:solidFill>
+                <a:latin typeface="Segoe UI"/>
+              </a:defRPr>
+            </a:pPr>
+            <a:r>
+              <a:t>• The Daily Nightmare: </a:t>
+            </a:r>
+            <a:r>
+              <a:rPr b="0">
+                <a:solidFill>
+                  <a:srgbClr val="CBD5E1"/>
+                </a:solidFill>
+              </a:rPr>
+              <a:t>Pooja used to spend 45 minutes every evening fast-forwarding through blurry CCTV tapes trying to figure out who dropped a customer's TV.</a:t>
+            </a:r>
+          </a:p>
+          <a:p>
+            <a:pPr>
+              <a:spcBef>
+                <a:spcPts val="600"/>
+              </a:spcBef>
+              <a:defRPr sz="950" b="1">
+                <a:solidFill>
+                  <a:srgbClr val="FFFFFF"/>
+                </a:solidFill>
+                <a:latin typeface="Segoe UI"/>
+              </a:defRPr>
+            </a:pPr>
+            <a:r>
+              <a:t>• Instant Notification: </a:t>
+            </a:r>
+            <a:r>
+              <a:rPr b="0">
+                <a:solidFill>
+                  <a:srgbClr val="CBD5E1"/>
+                </a:solidFill>
+              </a:rPr>
+              <a:t>Her tablet buzzes: 'Bay 3: High-Velocity Drop Flagged (10:14 AM)'.</a:t>
+            </a:r>
+          </a:p>
+          <a:p>
+            <a:pPr>
+              <a:spcBef>
+                <a:spcPts val="600"/>
+              </a:spcBef>
+              <a:defRPr sz="950" b="1">
+                <a:solidFill>
+                  <a:srgbClr val="FFFFFF"/>
+                </a:solidFill>
+                <a:latin typeface="Segoe UI"/>
+              </a:defRPr>
+            </a:pPr>
+            <a:r>
+              <a:t>• TikTok-Length Replay: </a:t>
+            </a:r>
+            <a:r>
+              <a:rPr b="0">
+                <a:solidFill>
+                  <a:srgbClr val="CBD5E1"/>
+                </a:solidFill>
+              </a:rPr>
+              <a:t>She taps it and immediately watches a 5-second replay showing the carton falling, complete with bounding box tracking and impact velocity.</a:t>
+            </a:r>
+          </a:p>
+          <a:p>
+            <a:pPr>
+              <a:spcBef>
+                <a:spcPts val="600"/>
+              </a:spcBef>
+              <a:defRPr sz="950" b="1">
+                <a:solidFill>
+                  <a:srgbClr val="FFFFFF"/>
+                </a:solidFill>
+                <a:latin typeface="Segoe UI"/>
+              </a:defRPr>
+            </a:pPr>
+            <a:r>
+              <a:t>• Quick Resolution: </a:t>
+            </a:r>
+            <a:r>
+              <a:rPr b="0">
+                <a:solidFill>
+                  <a:srgbClr val="CBD5E1"/>
+                </a:solidFill>
+              </a:rPr>
+              <a:t>She signs off on a packaging replacement in 10 seconds flat—no shouting matches, no guessing.</a:t>
+            </a:r>
+          </a:p>
+          <a:p>
+            <a:pPr>
+              <a:spcBef>
+                <a:spcPts val="600"/>
+              </a:spcBef>
+              <a:defRPr sz="950" b="1">
+                <a:solidFill>
+                  <a:srgbClr val="FFFFFF"/>
                 </a:solidFill>
                 <a:latin typeface="Segoe UI"/>
               </a:defRPr>
@@ -4939,7 +5055,7 @@
             <a:r>
               <a:rPr b="0">
                 <a:solidFill>
-                  <a:srgbClr val="64748B"/>
+                  <a:srgbClr val="CBD5E1"/>
                 </a:solidFill>
               </a:rPr>
               <a:t>At the end of the week, she asks the Gemini chat: 'Which shift has the most drops?' and instantly gets an answer for Monday's safety huddle.</a:t>
@@ -4979,12 +5095,26 @@
           <a:prstGeom prst="rect">
             <a:avLst/>
           </a:prstGeom>
-          <a:solidFill>
-            <a:srgbClr val="FFFFFF"/>
-          </a:solidFill>
           <a:ln>
             <a:noFill/>
           </a:ln>
+          <a:gradFill flip="none" rotWithShape="1">
+            <a:gsLst>
+              <a:gs pos="0">
+                <a:srgbClr val="08192E"/>
+              </a:gs>
+              <a:gs pos="42000">
+                <a:srgbClr val="12335E"/>
+              </a:gs>
+              <a:gs pos="78000">
+                <a:srgbClr val="1A4982"/>
+              </a:gs>
+              <a:gs pos="100000">
+                <a:srgbClr val="0A2140"/>
+              </a:gs>
+            </a:gsLst>
+            <a:lin ang="3240000" scaled="1"/>
+          </a:gradFill>
         </p:spPr>
         <p:style>
           <a:lnRef idx="1">
@@ -5017,16 +5147,18 @@
         <p:spPr>
           <a:xfrm>
             <a:off x="731520" y="365760"/>
-            <a:ext cx="2560320" cy="292608"/>
+            <a:ext cx="2651760" cy="292608"/>
           </a:xfrm>
           <a:prstGeom prst="roundRect">
             <a:avLst/>
           </a:prstGeom>
           <a:solidFill>
-            <a:srgbClr val="F3E8FF"/>
+            <a:srgbClr val="143058"/>
           </a:solidFill>
-          <a:ln>
-            <a:noFill/>
+          <a:ln w="12700">
+            <a:solidFill>
+              <a:srgbClr val="3872BA"/>
+            </a:solidFill>
           </a:ln>
         </p:spPr>
         <p:style>
@@ -5050,7 +5182,7 @@
             <a:pPr algn="ctr">
               <a:defRPr sz="950" b="1">
                 <a:solidFill>
-                  <a:srgbClr val="6D28D9"/>
+                  <a:srgbClr val="93C5FD"/>
                 </a:solidFill>
                 <a:latin typeface="Segoe UI"/>
               </a:defRPr>
@@ -5086,7 +5218,7 @@
             <a:pPr>
               <a:defRPr sz="2100" b="1">
                 <a:solidFill>
-                  <a:srgbClr val="182B49"/>
+                  <a:srgbClr val="FFFFFF"/>
                 </a:solidFill>
                 <a:latin typeface="Segoe UI"/>
               </a:defRPr>
@@ -5122,7 +5254,7 @@
             <a:pPr algn="r">
               <a:defRPr sz="850" b="1">
                 <a:solidFill>
-                  <a:srgbClr val="E11D48"/>
+                  <a:srgbClr val="FB7185"/>
                 </a:solidFill>
                 <a:latin typeface="Segoe UI"/>
               </a:defRPr>
@@ -5142,13 +5274,13 @@
         <p:spPr>
           <a:xfrm>
             <a:off x="731520" y="1243584"/>
-            <a:ext cx="10728655" cy="13716"/>
+            <a:ext cx="10728655" cy="18288"/>
           </a:xfrm>
           <a:prstGeom prst="rect">
             <a:avLst/>
           </a:prstGeom>
           <a:solidFill>
-            <a:srgbClr val="E2E8F0"/>
+            <a:srgbClr val="2D558C"/>
           </a:solidFill>
           <a:ln>
             <a:noFill/>
@@ -5191,11 +5323,11 @@
             <a:avLst/>
           </a:prstGeom>
           <a:solidFill>
-            <a:srgbClr val="F8FAFC"/>
+            <a:srgbClr val="0E1E36"/>
           </a:solidFill>
           <a:ln>
             <a:solidFill>
-              <a:srgbClr val="E2E8F0"/>
+              <a:srgbClr val="284B78"/>
             </a:solidFill>
           </a:ln>
         </p:spPr>
@@ -5236,7 +5368,7 @@
             <a:avLst/>
           </a:prstGeom>
           <a:solidFill>
-            <a:srgbClr val="2563EB"/>
+            <a:srgbClr val="38BDF8"/>
           </a:solidFill>
           <a:ln>
             <a:noFill/>
@@ -5289,7 +5421,7 @@
             <a:pPr>
               <a:defRPr sz="1100" b="1">
                 <a:solidFill>
-                  <a:srgbClr val="182B49"/>
+                  <a:srgbClr val="7DD3FC"/>
                 </a:solidFill>
                 <a:latin typeface="Segoe UI"/>
               </a:defRPr>
@@ -5305,7 +5437,7 @@
               </a:spcBef>
               <a:defRPr sz="950" b="1">
                 <a:solidFill>
-                  <a:srgbClr val="334155"/>
+                  <a:srgbClr val="FFFFFF"/>
                 </a:solidFill>
                 <a:latin typeface="Segoe UI"/>
               </a:defRPr>
@@ -5316,7 +5448,7 @@
             <a:r>
               <a:rPr b="0">
                 <a:solidFill>
-                  <a:srgbClr val="64748B"/>
+                  <a:srgbClr val="CBD5E1"/>
                 </a:solidFill>
               </a:rPr>
               <a:t>Ultralytics YOLOv8 fine-tuned on warehouse objects.</a:t>
@@ -5329,7 +5461,7 @@
               </a:spcBef>
               <a:defRPr sz="950" b="1">
                 <a:solidFill>
-                  <a:srgbClr val="334155"/>
+                  <a:srgbClr val="FFFFFF"/>
                 </a:solidFill>
                 <a:latin typeface="Segoe UI"/>
               </a:defRPr>
@@ -5340,7 +5472,7 @@
             <a:r>
               <a:rPr b="0">
                 <a:solidFill>
-                  <a:srgbClr val="64748B"/>
+                  <a:srgbClr val="CBD5E1"/>
                 </a:solidFill>
               </a:rPr>
               <a:t>Workers, cardboard cartons, wooden pallets, and forklifts.</a:t>
@@ -5353,7 +5485,7 @@
               </a:spcBef>
               <a:defRPr sz="950" b="1">
                 <a:solidFill>
-                  <a:srgbClr val="334155"/>
+                  <a:srgbClr val="FFFFFF"/>
                 </a:solidFill>
                 <a:latin typeface="Segoe UI"/>
               </a:defRPr>
@@ -5364,7 +5496,7 @@
             <a:r>
               <a:rPr b="0">
                 <a:solidFill>
-                  <a:srgbClr val="64748B"/>
+                  <a:srgbClr val="CBD5E1"/>
                 </a:solidFill>
               </a:rPr>
               <a:t>Keeps track of 'Box #4' even when a worker walks in front of it so the ID doesn't get lost.</a:t>
@@ -5387,11 +5519,11 @@
             <a:avLst/>
           </a:prstGeom>
           <a:solidFill>
-            <a:srgbClr val="F8FAFC"/>
+            <a:srgbClr val="0E1E36"/>
           </a:solidFill>
           <a:ln>
             <a:solidFill>
-              <a:srgbClr val="E2E8F0"/>
+              <a:srgbClr val="284B78"/>
             </a:solidFill>
           </a:ln>
         </p:spPr>
@@ -5432,7 +5564,7 @@
             <a:avLst/>
           </a:prstGeom>
           <a:solidFill>
-            <a:srgbClr val="6D28D9"/>
+            <a:srgbClr val="C084FC"/>
           </a:solidFill>
           <a:ln>
             <a:noFill/>
@@ -5485,7 +5617,7 @@
             <a:pPr>
               <a:defRPr sz="1100" b="1">
                 <a:solidFill>
-                  <a:srgbClr val="182B49"/>
+                  <a:srgbClr val="7DD3FC"/>
                 </a:solidFill>
                 <a:latin typeface="Segoe UI"/>
               </a:defRPr>
@@ -5501,7 +5633,7 @@
               </a:spcBef>
               <a:defRPr sz="950" b="1">
                 <a:solidFill>
-                  <a:srgbClr val="334155"/>
+                  <a:srgbClr val="FFFFFF"/>
                 </a:solidFill>
                 <a:latin typeface="Segoe UI"/>
               </a:defRPr>
@@ -5512,7 +5644,7 @@
             <a:r>
               <a:rPr b="0">
                 <a:solidFill>
-                  <a:srgbClr val="64748B"/>
+                  <a:srgbClr val="CBD5E1"/>
                 </a:solidFill>
               </a:rPr>
               <a:t>If a box's downward Y-velocity spikes &gt; 2.5 m/s and suddenly hits zero, that's a crash.</a:t>
@@ -5525,7 +5657,7 @@
               </a:spcBef>
               <a:defRPr sz="950" b="1">
                 <a:solidFill>
-                  <a:srgbClr val="334155"/>
+                  <a:srgbClr val="FFFFFF"/>
                 </a:solidFill>
                 <a:latin typeface="Segoe UI"/>
               </a:defRPr>
@@ -5536,7 +5668,7 @@
             <a:r>
               <a:rPr b="0">
                 <a:solidFill>
-                  <a:srgbClr val="64748B"/>
+                  <a:srgbClr val="CBD5E1"/>
                 </a:solidFill>
               </a:rPr>
               <a:t>If a carton slides &gt; 2 meters across the floor without lifting, it flags rough dragging.</a:t>
@@ -5549,7 +5681,7 @@
               </a:spcBef>
               <a:defRPr sz="950" b="1">
                 <a:solidFill>
-                  <a:srgbClr val="334155"/>
+                  <a:srgbClr val="FFFFFF"/>
                 </a:solidFill>
                 <a:latin typeface="Segoe UI"/>
               </a:defRPr>
@@ -5560,7 +5692,7 @@
             <a:r>
               <a:rPr b="0">
                 <a:solidFill>
-                  <a:srgbClr val="64748B"/>
+                  <a:srgbClr val="CBD5E1"/>
                 </a:solidFill>
               </a:rPr>
               <a:t>Measures the angle of boxes on pallets—anything tilted &gt; 15° triggers a wobble warning.</a:t>
@@ -5583,11 +5715,11 @@
             <a:avLst/>
           </a:prstGeom>
           <a:solidFill>
-            <a:srgbClr val="F8FAFC"/>
+            <a:srgbClr val="0E1E36"/>
           </a:solidFill>
           <a:ln>
             <a:solidFill>
-              <a:srgbClr val="E2E8F0"/>
+              <a:srgbClr val="284B78"/>
             </a:solidFill>
           </a:ln>
         </p:spPr>
@@ -5628,7 +5760,7 @@
             <a:avLst/>
           </a:prstGeom>
           <a:solidFill>
-            <a:srgbClr val="E11D48"/>
+            <a:srgbClr val="FB7185"/>
           </a:solidFill>
           <a:ln>
             <a:noFill/>
@@ -5681,7 +5813,7 @@
             <a:pPr>
               <a:defRPr sz="1100" b="1">
                 <a:solidFill>
-                  <a:srgbClr val="182B49"/>
+                  <a:srgbClr val="7DD3FC"/>
                 </a:solidFill>
                 <a:latin typeface="Segoe UI"/>
               </a:defRPr>
@@ -5697,7 +5829,7 @@
               </a:spcBef>
               <a:defRPr sz="950" b="1">
                 <a:solidFill>
-                  <a:srgbClr val="334155"/>
+                  <a:srgbClr val="FFFFFF"/>
                 </a:solidFill>
                 <a:latin typeface="Segoe UI"/>
               </a:defRPr>
@@ -5708,7 +5840,7 @@
             <a:r>
               <a:rPr b="0">
                 <a:solidFill>
-                  <a:srgbClr val="64748B"/>
+                  <a:srgbClr val="CBD5E1"/>
                 </a:solidFill>
               </a:rPr>
               <a:t>Supervisors hate writing SQL queries or clicking 20 filters.</a:t>
@@ -5721,7 +5853,7 @@
               </a:spcBef>
               <a:defRPr sz="950" b="1">
                 <a:solidFill>
-                  <a:srgbClr val="334155"/>
+                  <a:srgbClr val="FFFFFF"/>
                 </a:solidFill>
                 <a:latin typeface="Segoe UI"/>
               </a:defRPr>
@@ -5732,7 +5864,7 @@
             <a:r>
               <a:rPr b="0">
                 <a:solidFill>
-                  <a:srgbClr val="64748B"/>
+                  <a:srgbClr val="CBD5E1"/>
                 </a:solidFill>
               </a:rPr>
               <a:t>We feed SQLite telemetry logs into Gemini so supervisors can ask plain questions like: 'Did Bay 3 drop anything today?'</a:t>
@@ -5745,7 +5877,7 @@
               </a:spcBef>
               <a:defRPr sz="950" b="1">
                 <a:solidFill>
-                  <a:srgbClr val="334155"/>
+                  <a:srgbClr val="FFFFFF"/>
                 </a:solidFill>
                 <a:latin typeface="Segoe UI"/>
               </a:defRPr>
@@ -5756,7 +5888,7 @@
             <a:r>
               <a:rPr b="0">
                 <a:solidFill>
-                  <a:srgbClr val="64748B"/>
+                  <a:srgbClr val="CBD5E1"/>
                 </a:solidFill>
               </a:rPr>
               <a:t>Instant plain-English answers with timestamps.</a:t>
@@ -5779,11 +5911,11 @@
             <a:avLst/>
           </a:prstGeom>
           <a:solidFill>
-            <a:srgbClr val="F8FAFC"/>
+            <a:srgbClr val="0E1E36"/>
           </a:solidFill>
           <a:ln>
             <a:solidFill>
-              <a:srgbClr val="E2E8F0"/>
+              <a:srgbClr val="284B78"/>
             </a:solidFill>
           </a:ln>
         </p:spPr>
@@ -5824,7 +5956,7 @@
             <a:avLst/>
           </a:prstGeom>
           <a:solidFill>
-            <a:srgbClr val="F59E0B"/>
+            <a:srgbClr val="FBBF24"/>
           </a:solidFill>
           <a:ln>
             <a:noFill/>
@@ -5877,7 +6009,7 @@
             <a:pPr>
               <a:defRPr sz="1100" b="1">
                 <a:solidFill>
-                  <a:srgbClr val="182B49"/>
+                  <a:srgbClr val="7DD3FC"/>
                 </a:solidFill>
                 <a:latin typeface="Segoe UI"/>
               </a:defRPr>
@@ -5893,7 +6025,7 @@
               </a:spcBef>
               <a:defRPr sz="950" b="1">
                 <a:solidFill>
-                  <a:srgbClr val="334155"/>
+                  <a:srgbClr val="FFFFFF"/>
                 </a:solidFill>
                 <a:latin typeface="Segoe UI"/>
               </a:defRPr>
@@ -5904,7 +6036,7 @@
             <a:r>
               <a:rPr b="0">
                 <a:solidFill>
-                  <a:srgbClr val="64748B"/>
+                  <a:srgbClr val="CBD5E1"/>
                 </a:solidFill>
               </a:rPr>
               <a:t>We don't save 24 hours of boring empty dock video.</a:t>
@@ -5917,7 +6049,7 @@
               </a:spcBef>
               <a:defRPr sz="950" b="1">
                 <a:solidFill>
-                  <a:srgbClr val="334155"/>
+                  <a:srgbClr val="FFFFFF"/>
                 </a:solidFill>
                 <a:latin typeface="Segoe UI"/>
               </a:defRPr>
@@ -5928,7 +6060,7 @@
             <a:r>
               <a:rPr b="0">
                 <a:solidFill>
-                  <a:srgbClr val="64748B"/>
+                  <a:srgbClr val="CBD5E1"/>
                 </a:solidFill>
               </a:rPr>
               <a:t>Keeps the last 15 seconds in memory. When a drop triggers, it automatically cuts a neat 5-second replay clip.</a:t>
@@ -5941,7 +6073,7 @@
               </a:spcBef>
               <a:defRPr sz="950" b="1">
                 <a:solidFill>
-                  <a:srgbClr val="334155"/>
+                  <a:srgbClr val="FFFFFF"/>
                 </a:solidFill>
                 <a:latin typeface="Segoe UI"/>
               </a:defRPr>
@@ -5952,7 +6084,7 @@
             <a:r>
               <a:rPr b="0">
                 <a:solidFill>
-                  <a:srgbClr val="64748B"/>
+                  <a:srgbClr val="CBD5E1"/>
                 </a:solidFill>
               </a:rPr>
               <a:t>Encodes to lightweight H.264 so it plays instantly in the browser.</a:t>
@@ -5975,11 +6107,11 @@
             <a:avLst/>
           </a:prstGeom>
           <a:solidFill>
-            <a:srgbClr val="F8FAFC"/>
+            <a:srgbClr val="0E1E36"/>
           </a:solidFill>
           <a:ln>
             <a:solidFill>
-              <a:srgbClr val="E2E8F0"/>
+              <a:srgbClr val="284B78"/>
             </a:solidFill>
           </a:ln>
         </p:spPr>
@@ -6020,7 +6152,7 @@
             <a:avLst/>
           </a:prstGeom>
           <a:solidFill>
-            <a:srgbClr val="10B981"/>
+            <a:srgbClr val="34D399"/>
           </a:solidFill>
           <a:ln>
             <a:noFill/>
@@ -6073,7 +6205,7 @@
             <a:pPr>
               <a:defRPr sz="1100" b="1">
                 <a:solidFill>
-                  <a:srgbClr val="182B49"/>
+                  <a:srgbClr val="7DD3FC"/>
                 </a:solidFill>
                 <a:latin typeface="Segoe UI"/>
               </a:defRPr>
@@ -6089,7 +6221,7 @@
               </a:spcBef>
               <a:defRPr sz="950" b="1">
                 <a:solidFill>
-                  <a:srgbClr val="334155"/>
+                  <a:srgbClr val="FFFFFF"/>
                 </a:solidFill>
                 <a:latin typeface="Segoe UI"/>
               </a:defRPr>
@@ -6100,7 +6232,7 @@
             <a:r>
               <a:rPr b="0">
                 <a:solidFill>
-                  <a:srgbClr val="64748B"/>
+                  <a:srgbClr val="CBD5E1"/>
                 </a:solidFill>
               </a:rPr>
               <a:t>Super-fast async Python framework handling video uploads, alert websockets, and stats.</a:t>
@@ -6113,7 +6245,7 @@
               </a:spcBef>
               <a:defRPr sz="950" b="1">
                 <a:solidFill>
-                  <a:srgbClr val="334155"/>
+                  <a:srgbClr val="FFFFFF"/>
                 </a:solidFill>
                 <a:latin typeface="Segoe UI"/>
               </a:defRPr>
@@ -6124,7 +6256,7 @@
             <a:r>
               <a:rPr b="0">
                 <a:solidFill>
-                  <a:srgbClr val="64748B"/>
+                  <a:srgbClr val="CBD5E1"/>
                 </a:solidFill>
               </a:rPr>
               <a:t>Simple, reliable local database storing incident records, drop heights, and camera IDs.</a:t>
@@ -6137,7 +6269,7 @@
               </a:spcBef>
               <a:defRPr sz="950" b="1">
                 <a:solidFill>
-                  <a:srgbClr val="334155"/>
+                  <a:srgbClr val="FFFFFF"/>
                 </a:solidFill>
                 <a:latin typeface="Segoe UI"/>
               </a:defRPr>
@@ -6148,7 +6280,7 @@
             <a:r>
               <a:rPr b="0">
                 <a:solidFill>
-                  <a:srgbClr val="64748B"/>
+                  <a:srgbClr val="CBD5E1"/>
                 </a:solidFill>
               </a:rPr>
               <a:t>Well-documented REST routes for the frontend to poll.</a:t>
@@ -6171,11 +6303,11 @@
             <a:avLst/>
           </a:prstGeom>
           <a:solidFill>
-            <a:srgbClr val="F8FAFC"/>
+            <a:srgbClr val="0E1E36"/>
           </a:solidFill>
           <a:ln>
             <a:solidFill>
-              <a:srgbClr val="E2E8F0"/>
+              <a:srgbClr val="284B78"/>
             </a:solidFill>
           </a:ln>
         </p:spPr>
@@ -6216,7 +6348,7 @@
             <a:avLst/>
           </a:prstGeom>
           <a:solidFill>
-            <a:srgbClr val="2563EB"/>
+            <a:srgbClr val="38BDF8"/>
           </a:solidFill>
           <a:ln>
             <a:noFill/>
@@ -6269,7 +6401,7 @@
             <a:pPr>
               <a:defRPr sz="1100" b="1">
                 <a:solidFill>
-                  <a:srgbClr val="182B49"/>
+                  <a:srgbClr val="7DD3FC"/>
                 </a:solidFill>
                 <a:latin typeface="Segoe UI"/>
               </a:defRPr>
@@ -6285,7 +6417,7 @@
               </a:spcBef>
               <a:defRPr sz="950" b="1">
                 <a:solidFill>
-                  <a:srgbClr val="334155"/>
+                  <a:srgbClr val="FFFFFF"/>
                 </a:solidFill>
                 <a:latin typeface="Segoe UI"/>
               </a:defRPr>
@@ -6296,7 +6428,7 @@
             <a:r>
               <a:rPr b="0">
                 <a:solidFill>
-                  <a:srgbClr val="64748B"/>
+                  <a:srgbClr val="CBD5E1"/>
                 </a:solidFill>
               </a:rPr>
               <a:t>React 18, TypeScript, and Tailwind CSS for a crisp, responsive layout.</a:t>
@@ -6309,7 +6441,7 @@
               </a:spcBef>
               <a:defRPr sz="950" b="1">
                 <a:solidFill>
-                  <a:srgbClr val="334155"/>
+                  <a:srgbClr val="FFFFFF"/>
                 </a:solidFill>
                 <a:latin typeface="Segoe UI"/>
               </a:defRPr>
@@ -6320,7 +6452,7 @@
             <a:r>
               <a:rPr b="0">
                 <a:solidFill>
-                  <a:srgbClr val="64748B"/>
+                  <a:srgbClr val="CBD5E1"/>
                 </a:solidFill>
               </a:rPr>
               <a:t>Recharts rendering 7-day risk trends and KPI cards.</a:t>
@@ -6333,7 +6465,7 @@
               </a:spcBef>
               <a:defRPr sz="950" b="1">
                 <a:solidFill>
-                  <a:srgbClr val="334155"/>
+                  <a:srgbClr val="FFFFFF"/>
                 </a:solidFill>
                 <a:latin typeface="Segoe UI"/>
               </a:defRPr>
@@ -6344,7 +6476,7 @@
             <a:r>
               <a:rPr b="0">
                 <a:solidFill>
-                  <a:srgbClr val="64748B"/>
+                  <a:srgbClr val="CBD5E1"/>
                 </a:solidFill>
               </a:rPr>
               <a:t>Web Audio API generates soft synthetic tones right inside the browser without downloading sound files.</a:t>
@@ -6384,12 +6516,26 @@
           <a:prstGeom prst="rect">
             <a:avLst/>
           </a:prstGeom>
-          <a:solidFill>
-            <a:srgbClr val="FFFFFF"/>
-          </a:solidFill>
           <a:ln>
             <a:noFill/>
           </a:ln>
+          <a:gradFill flip="none" rotWithShape="1">
+            <a:gsLst>
+              <a:gs pos="0">
+                <a:srgbClr val="08192E"/>
+              </a:gs>
+              <a:gs pos="42000">
+                <a:srgbClr val="12335E"/>
+              </a:gs>
+              <a:gs pos="78000">
+                <a:srgbClr val="1A4982"/>
+              </a:gs>
+              <a:gs pos="100000">
+                <a:srgbClr val="0A2140"/>
+              </a:gs>
+            </a:gsLst>
+            <a:lin ang="3240000" scaled="1"/>
+          </a:gradFill>
         </p:spPr>
         <p:style>
           <a:lnRef idx="1">
@@ -6422,16 +6568,18 @@
         <p:spPr>
           <a:xfrm>
             <a:off x="731520" y="365760"/>
-            <a:ext cx="2560320" cy="292608"/>
+            <a:ext cx="2651760" cy="292608"/>
           </a:xfrm>
           <a:prstGeom prst="roundRect">
             <a:avLst/>
           </a:prstGeom>
           <a:solidFill>
-            <a:srgbClr val="F3E8FF"/>
+            <a:srgbClr val="143058"/>
           </a:solidFill>
-          <a:ln>
-            <a:noFill/>
+          <a:ln w="12700">
+            <a:solidFill>
+              <a:srgbClr val="3872BA"/>
+            </a:solidFill>
           </a:ln>
         </p:spPr>
         <p:style>
@@ -6455,7 +6603,7 @@
             <a:pPr algn="ctr">
               <a:defRPr sz="950" b="1">
                 <a:solidFill>
-                  <a:srgbClr val="6D28D9"/>
+                  <a:srgbClr val="93C5FD"/>
                 </a:solidFill>
                 <a:latin typeface="Segoe UI"/>
               </a:defRPr>
@@ -6491,7 +6639,7 @@
             <a:pPr>
               <a:defRPr sz="2100" b="1">
                 <a:solidFill>
-                  <a:srgbClr val="182B49"/>
+                  <a:srgbClr val="FFFFFF"/>
                 </a:solidFill>
                 <a:latin typeface="Segoe UI"/>
               </a:defRPr>
@@ -6511,13 +6659,13 @@
         <p:spPr>
           <a:xfrm>
             <a:off x="731520" y="1243584"/>
-            <a:ext cx="10728655" cy="13716"/>
+            <a:ext cx="10728655" cy="18288"/>
           </a:xfrm>
           <a:prstGeom prst="rect">
             <a:avLst/>
           </a:prstGeom>
           <a:solidFill>
-            <a:srgbClr val="E2E8F0"/>
+            <a:srgbClr val="2D558C"/>
           </a:solidFill>
           <a:ln>
             <a:noFill/>
@@ -6594,7 +6742,7 @@
             <a:pPr>
               <a:defRPr sz="850">
                 <a:solidFill>
-                  <a:srgbClr val="64748B"/>
+                  <a:srgbClr val="94A3B8"/>
                 </a:solidFill>
                 <a:latin typeface="Segoe UI"/>
               </a:defRPr>
@@ -6654,7 +6802,7 @@
             <a:pPr>
               <a:defRPr sz="850">
                 <a:solidFill>
-                  <a:srgbClr val="64748B"/>
+                  <a:srgbClr val="94A3B8"/>
                 </a:solidFill>
                 <a:latin typeface="Segoe UI"/>
               </a:defRPr>
@@ -6714,7 +6862,7 @@
             <a:pPr>
               <a:defRPr sz="850">
                 <a:solidFill>
-                  <a:srgbClr val="64748B"/>
+                  <a:srgbClr val="94A3B8"/>
                 </a:solidFill>
                 <a:latin typeface="Segoe UI"/>
               </a:defRPr>
@@ -6740,11 +6888,11 @@
             <a:avLst/>
           </a:prstGeom>
           <a:solidFill>
-            <a:srgbClr val="F8FAFC"/>
+            <a:srgbClr val="0E1E36"/>
           </a:solidFill>
           <a:ln>
             <a:solidFill>
-              <a:srgbClr val="E2E8F0"/>
+              <a:srgbClr val="284B78"/>
             </a:solidFill>
           </a:ln>
         </p:spPr>
@@ -6795,7 +6943,7 @@
             <a:pPr>
               <a:defRPr sz="1100" b="1">
                 <a:solidFill>
-                  <a:srgbClr val="6D28D9"/>
+                  <a:srgbClr val="7DD3FC"/>
                 </a:solidFill>
                 <a:latin typeface="Segoe UI"/>
               </a:defRPr>
@@ -6811,7 +6959,7 @@
               </a:spcBef>
               <a:defRPr sz="1000" b="1">
                 <a:solidFill>
-                  <a:srgbClr val="182B49"/>
+                  <a:srgbClr val="FFFFFF"/>
                 </a:solidFill>
                 <a:latin typeface="Segoe UI"/>
               </a:defRPr>
@@ -6822,7 +6970,7 @@
             <a:r>
               <a:rPr b="0">
                 <a:solidFill>
-                  <a:srgbClr val="64748B"/>
+                  <a:srgbClr val="CBD5E1"/>
                 </a:solidFill>
               </a:rPr>
               <a:t> Carton slips from 1.3m off pallet staging. The camera spots the free-fall spike and triggers a CRITICAL alert in 1.2s flat.</a:t>
@@ -6835,7 +6983,7 @@
               </a:spcBef>
               <a:defRPr sz="1000" b="1">
                 <a:solidFill>
-                  <a:srgbClr val="182B49"/>
+                  <a:srgbClr val="FFFFFF"/>
                 </a:solidFill>
                 <a:latin typeface="Segoe UI"/>
               </a:defRPr>
@@ -6846,7 +6994,7 @@
             <a:r>
               <a:rPr b="0">
                 <a:solidFill>
-                  <a:srgbClr val="64748B"/>
+                  <a:srgbClr val="CBD5E1"/>
                 </a:solidFill>
               </a:rPr>
               <a:t> A worker slides a 20kg box 4.6m across wet concrete. The system measures the ground distance and flags HIGH risk dragging.</a:t>
@@ -6859,7 +7007,7 @@
               </a:spcBef>
               <a:defRPr sz="1000" b="1">
                 <a:solidFill>
-                  <a:srgbClr val="182B49"/>
+                  <a:srgbClr val="FFFFFF"/>
                 </a:solidFill>
                 <a:latin typeface="Segoe UI"/>
               </a:defRPr>
@@ -6870,7 +7018,7 @@
             <a:r>
               <a:rPr b="0">
                 <a:solidFill>
-                  <a:srgbClr val="64748B"/>
+                  <a:srgbClr val="CBD5E1"/>
                 </a:solidFill>
               </a:rPr>
               <a:t> Boxes stacked with a 17° tilt without proper interlocking are flagged as CAUTION so the loader can straighten the pile.</a:t>
@@ -6883,7 +7031,7 @@
               </a:spcBef>
               <a:defRPr sz="1000" b="1">
                 <a:solidFill>
-                  <a:srgbClr val="182B49"/>
+                  <a:srgbClr val="FFFFFF"/>
                 </a:solidFill>
                 <a:latin typeface="Segoe UI"/>
               </a:defRPr>
@@ -6894,7 +7042,7 @@
             <a:r>
               <a:rPr b="0">
                 <a:solidFill>
-                  <a:srgbClr val="64748B"/>
+                  <a:srgbClr val="CBD5E1"/>
                 </a:solidFill>
               </a:rPr>
               <a:t> We typed: 'Which bay had drops today?' and Gemini parsed the database logs to tell us Bay 3 had 2 drop incidents at 10:14 AM and 2:30 PM.</a:t>
@@ -6907,7 +7055,7 @@
               </a:spcBef>
               <a:defRPr sz="1000" b="1">
                 <a:solidFill>
-                  <a:srgbClr val="2563EB"/>
+                  <a:srgbClr val="38BDF8"/>
                 </a:solidFill>
                 <a:latin typeface="Segoe UI"/>
               </a:defRPr>
@@ -6923,7 +7071,7 @@
               </a:spcBef>
               <a:defRPr sz="850">
                 <a:solidFill>
-                  <a:srgbClr val="64748B"/>
+                  <a:srgbClr val="CBD5E1"/>
                 </a:solidFill>
                 <a:latin typeface="Segoe UI"/>
               </a:defRPr>
@@ -6939,7 +7087,7 @@
               </a:spcBef>
               <a:defRPr sz="850">
                 <a:solidFill>
-                  <a:srgbClr val="64748B"/>
+                  <a:srgbClr val="CBD5E1"/>
                 </a:solidFill>
                 <a:latin typeface="Segoe UI"/>
               </a:defRPr>
@@ -6955,7 +7103,7 @@
               </a:spcBef>
               <a:defRPr sz="850">
                 <a:solidFill>
-                  <a:srgbClr val="64748B"/>
+                  <a:srgbClr val="CBD5E1"/>
                 </a:solidFill>
                 <a:latin typeface="Segoe UI"/>
               </a:defRPr>
@@ -6998,12 +7146,26 @@
           <a:prstGeom prst="rect">
             <a:avLst/>
           </a:prstGeom>
-          <a:solidFill>
-            <a:srgbClr val="FFFFFF"/>
-          </a:solidFill>
           <a:ln>
             <a:noFill/>
           </a:ln>
+          <a:gradFill flip="none" rotWithShape="1">
+            <a:gsLst>
+              <a:gs pos="0">
+                <a:srgbClr val="08192E"/>
+              </a:gs>
+              <a:gs pos="42000">
+                <a:srgbClr val="12335E"/>
+              </a:gs>
+              <a:gs pos="78000">
+                <a:srgbClr val="1A4982"/>
+              </a:gs>
+              <a:gs pos="100000">
+                <a:srgbClr val="0A2140"/>
+              </a:gs>
+            </a:gsLst>
+            <a:lin ang="3240000" scaled="1"/>
+          </a:gradFill>
         </p:spPr>
         <p:style>
           <a:lnRef idx="1">
@@ -7036,16 +7198,18 @@
         <p:spPr>
           <a:xfrm>
             <a:off x="731520" y="365760"/>
-            <a:ext cx="2560320" cy="292608"/>
+            <a:ext cx="2651760" cy="292608"/>
           </a:xfrm>
           <a:prstGeom prst="roundRect">
             <a:avLst/>
           </a:prstGeom>
           <a:solidFill>
-            <a:srgbClr val="F3E8FF"/>
+            <a:srgbClr val="143058"/>
           </a:solidFill>
-          <a:ln>
-            <a:noFill/>
+          <a:ln w="12700">
+            <a:solidFill>
+              <a:srgbClr val="3872BA"/>
+            </a:solidFill>
           </a:ln>
         </p:spPr>
         <p:style>
@@ -7069,7 +7233,7 @@
             <a:pPr algn="ctr">
               <a:defRPr sz="950" b="1">
                 <a:solidFill>
-                  <a:srgbClr val="6D28D9"/>
+                  <a:srgbClr val="93C5FD"/>
                 </a:solidFill>
                 <a:latin typeface="Segoe UI"/>
               </a:defRPr>
@@ -7105,7 +7269,7 @@
             <a:pPr>
               <a:defRPr sz="2100" b="1">
                 <a:solidFill>
-                  <a:srgbClr val="182B49"/>
+                  <a:srgbClr val="FFFFFF"/>
                 </a:solidFill>
                 <a:latin typeface="Segoe UI"/>
               </a:defRPr>
@@ -7125,13 +7289,13 @@
         <p:spPr>
           <a:xfrm>
             <a:off x="731520" y="1243584"/>
-            <a:ext cx="10728655" cy="13716"/>
+            <a:ext cx="10728655" cy="18288"/>
           </a:xfrm>
           <a:prstGeom prst="rect">
             <a:avLst/>
           </a:prstGeom>
           <a:solidFill>
-            <a:srgbClr val="E2E8F0"/>
+            <a:srgbClr val="2D558C"/>
           </a:solidFill>
           <a:ln>
             <a:noFill/>
@@ -7174,11 +7338,11 @@
             <a:avLst/>
           </a:prstGeom>
           <a:solidFill>
-            <a:srgbClr val="F8FAFC"/>
+            <a:srgbClr val="0E1E36"/>
           </a:solidFill>
           <a:ln>
             <a:solidFill>
-              <a:srgbClr val="E2E8F0"/>
+              <a:srgbClr val="284B78"/>
             </a:solidFill>
           </a:ln>
         </p:spPr>
@@ -7219,7 +7383,7 @@
             <a:avLst/>
           </a:prstGeom>
           <a:solidFill>
-            <a:srgbClr val="6D28D9"/>
+            <a:srgbClr val="C084FC"/>
           </a:solidFill>
           <a:ln>
             <a:noFill/>
@@ -7272,7 +7436,7 @@
             <a:pPr>
               <a:defRPr sz="1000" b="1">
                 <a:solidFill>
-                  <a:srgbClr val="182B49"/>
+                  <a:srgbClr val="7DD3FC"/>
                 </a:solidFill>
                 <a:latin typeface="Segoe UI"/>
               </a:defRPr>
@@ -7283,7 +7447,7 @@
             <a:r>
               <a:rPr b="0" i="1">
                 <a:solidFill>
-                  <a:srgbClr val="E11D48"/>
+                  <a:srgbClr val="FB7185"/>
                 </a:solidFill>
               </a:rPr>
               <a:t>"I can't watch hours of boring CCTV tapes while running around 6 bays."</a:t>
@@ -7296,7 +7460,7 @@
               </a:spcBef>
               <a:defRPr sz="900">
                 <a:solidFill>
-                  <a:srgbClr val="64748B"/>
+                  <a:srgbClr val="CBD5E1"/>
                 </a:solidFill>
                 <a:latin typeface="Segoe UI"/>
               </a:defRPr>
@@ -7322,11 +7486,11 @@
             <a:avLst/>
           </a:prstGeom>
           <a:solidFill>
-            <a:srgbClr val="F8FAFC"/>
+            <a:srgbClr val="0E1E36"/>
           </a:solidFill>
           <a:ln>
             <a:solidFill>
-              <a:srgbClr val="E2E8F0"/>
+              <a:srgbClr val="284B78"/>
             </a:solidFill>
           </a:ln>
         </p:spPr>
@@ -7367,7 +7531,7 @@
             <a:avLst/>
           </a:prstGeom>
           <a:solidFill>
-            <a:srgbClr val="2563EB"/>
+            <a:srgbClr val="38BDF8"/>
           </a:solidFill>
           <a:ln>
             <a:noFill/>
@@ -7420,7 +7584,7 @@
             <a:pPr>
               <a:defRPr sz="1000" b="1">
                 <a:solidFill>
-                  <a:srgbClr val="182B49"/>
+                  <a:srgbClr val="7DD3FC"/>
                 </a:solidFill>
                 <a:latin typeface="Segoe UI"/>
               </a:defRPr>
@@ -7431,7 +7595,7 @@
             <a:r>
               <a:rPr b="0" i="1">
                 <a:solidFill>
-                  <a:srgbClr val="E11D48"/>
+                  <a:srgbClr val="FB7185"/>
                 </a:solidFill>
               </a:rPr>
               <a:t>"Your first alarm sounded like a nuclear meltdown siren. Everyone hated it."</a:t>
@@ -7444,7 +7608,7 @@
               </a:spcBef>
               <a:defRPr sz="900">
                 <a:solidFill>
-                  <a:srgbClr val="64748B"/>
+                  <a:srgbClr val="CBD5E1"/>
                 </a:solidFill>
                 <a:latin typeface="Segoe UI"/>
               </a:defRPr>
@@ -7470,11 +7634,11 @@
             <a:avLst/>
           </a:prstGeom>
           <a:solidFill>
-            <a:srgbClr val="F8FAFC"/>
+            <a:srgbClr val="0E1E36"/>
           </a:solidFill>
           <a:ln>
             <a:solidFill>
-              <a:srgbClr val="E2E8F0"/>
+              <a:srgbClr val="284B78"/>
             </a:solidFill>
           </a:ln>
         </p:spPr>
@@ -7515,7 +7679,7 @@
             <a:avLst/>
           </a:prstGeom>
           <a:solidFill>
-            <a:srgbClr val="6D28D9"/>
+            <a:srgbClr val="C084FC"/>
           </a:solidFill>
           <a:ln>
             <a:noFill/>
@@ -7568,7 +7732,7 @@
             <a:pPr>
               <a:defRPr sz="1000" b="1">
                 <a:solidFill>
-                  <a:srgbClr val="182B49"/>
+                  <a:srgbClr val="7DD3FC"/>
                 </a:solidFill>
                 <a:latin typeface="Segoe UI"/>
               </a:defRPr>
@@ -7579,7 +7743,7 @@
             <a:r>
               <a:rPr b="0" i="1">
                 <a:solidFill>
-                  <a:srgbClr val="E11D48"/>
+                  <a:srgbClr val="FB7185"/>
                 </a:solidFill>
               </a:rPr>
               <a:t>"Cool tech, but how do I prove to my boss that we're actually breaking fewer things?"</a:t>
@@ -7592,7 +7756,7 @@
               </a:spcBef>
               <a:defRPr sz="900">
                 <a:solidFill>
-                  <a:srgbClr val="64748B"/>
+                  <a:srgbClr val="CBD5E1"/>
                 </a:solidFill>
                 <a:latin typeface="Segoe UI"/>
               </a:defRPr>
@@ -7618,11 +7782,11 @@
             <a:avLst/>
           </a:prstGeom>
           <a:solidFill>
-            <a:srgbClr val="F8FAFC"/>
+            <a:srgbClr val="0E1E36"/>
           </a:solidFill>
           <a:ln>
             <a:solidFill>
-              <a:srgbClr val="E2E8F0"/>
+              <a:srgbClr val="284B78"/>
             </a:solidFill>
           </a:ln>
         </p:spPr>
@@ -7663,7 +7827,7 @@
             <a:avLst/>
           </a:prstGeom>
           <a:solidFill>
-            <a:srgbClr val="2563EB"/>
+            <a:srgbClr val="38BDF8"/>
           </a:solidFill>
           <a:ln>
             <a:noFill/>
@@ -7716,7 +7880,7 @@
             <a:pPr>
               <a:defRPr sz="1000" b="1">
                 <a:solidFill>
-                  <a:srgbClr val="182B49"/>
+                  <a:srgbClr val="7DD3FC"/>
                 </a:solidFill>
                 <a:latin typeface="Segoe UI"/>
               </a:defRPr>
@@ -7727,7 +7891,7 @@
             <a:r>
               <a:rPr b="0" i="1">
                 <a:solidFill>
-                  <a:srgbClr val="E11D48"/>
+                  <a:srgbClr val="FB7185"/>
                 </a:solidFill>
               </a:rPr>
               <a:t>"When customers return broken ceramics, the freight company claims we dropped it."</a:t>
@@ -7740,7 +7904,7 @@
               </a:spcBef>
               <a:defRPr sz="900">
                 <a:solidFill>
-                  <a:srgbClr val="64748B"/>
+                  <a:srgbClr val="CBD5E1"/>
                 </a:solidFill>
                 <a:latin typeface="Segoe UI"/>
               </a:defRPr>
@@ -7766,11 +7930,11 @@
             <a:avLst/>
           </a:prstGeom>
           <a:solidFill>
-            <a:srgbClr val="F8FAFC"/>
+            <a:srgbClr val="0E1E36"/>
           </a:solidFill>
           <a:ln>
             <a:solidFill>
-              <a:srgbClr val="E2E8F0"/>
+              <a:srgbClr val="284B78"/>
             </a:solidFill>
           </a:ln>
         </p:spPr>
@@ -7811,7 +7975,7 @@
             <a:avLst/>
           </a:prstGeom>
           <a:solidFill>
-            <a:srgbClr val="6D28D9"/>
+            <a:srgbClr val="C084FC"/>
           </a:solidFill>
           <a:ln>
             <a:noFill/>
@@ -7864,7 +8028,7 @@
             <a:pPr>
               <a:defRPr sz="1000" b="1">
                 <a:solidFill>
-                  <a:srgbClr val="182B49"/>
+                  <a:srgbClr val="7DD3FC"/>
                 </a:solidFill>
                 <a:latin typeface="Segoe UI"/>
               </a:defRPr>
@@ -7875,7 +8039,7 @@
             <a:r>
               <a:rPr b="0" i="1">
                 <a:solidFill>
-                  <a:srgbClr val="E11D48"/>
+                  <a:srgbClr val="FB7185"/>
                 </a:solidFill>
               </a:rPr>
               <a:t>"Workers drag heavy boxes across wet spots and blow out their backs."</a:t>
@@ -7888,7 +8052,7 @@
               </a:spcBef>
               <a:defRPr sz="900">
                 <a:solidFill>
-                  <a:srgbClr val="64748B"/>
+                  <a:srgbClr val="CBD5E1"/>
                 </a:solidFill>
                 <a:latin typeface="Segoe UI"/>
               </a:defRPr>
@@ -7914,11 +8078,11 @@
             <a:avLst/>
           </a:prstGeom>
           <a:solidFill>
-            <a:srgbClr val="F8FAFC"/>
+            <a:srgbClr val="0E1E36"/>
           </a:solidFill>
           <a:ln>
             <a:solidFill>
-              <a:srgbClr val="E2E8F0"/>
+              <a:srgbClr val="284B78"/>
             </a:solidFill>
           </a:ln>
         </p:spPr>
@@ -7969,7 +8133,7 @@
             <a:pPr>
               <a:defRPr sz="1100" b="1">
                 <a:solidFill>
-                  <a:srgbClr val="10B981"/>
+                  <a:srgbClr val="34D399"/>
                 </a:solidFill>
                 <a:latin typeface="Segoe UI"/>
               </a:defRPr>
@@ -7985,7 +8149,7 @@
               </a:spcBef>
               <a:defRPr sz="1000" b="1">
                 <a:solidFill>
-                  <a:srgbClr val="182B49"/>
+                  <a:srgbClr val="FFFFFF"/>
                 </a:solidFill>
                 <a:latin typeface="Segoe UI"/>
               </a:defRPr>
@@ -7996,7 +8160,7 @@
             <a:r>
               <a:rPr b="0">
                 <a:solidFill>
-                  <a:srgbClr val="64748B"/>
+                  <a:srgbClr val="CBD5E1"/>
                 </a:solidFill>
               </a:rPr>
               <a:t> From the instant a box crashes to the floor, the system detects it and plays a sound in under 1.5 seconds.</a:t>
@@ -8009,7 +8173,7 @@
               </a:spcBef>
               <a:defRPr sz="1000" b="1">
                 <a:solidFill>
-                  <a:srgbClr val="182B49"/>
+                  <a:srgbClr val="FFFFFF"/>
                 </a:solidFill>
                 <a:latin typeface="Segoe UI"/>
               </a:defRPr>
@@ -8020,7 +8184,7 @@
             <a:r>
               <a:rPr b="0">
                 <a:solidFill>
-                  <a:srgbClr val="64748B"/>
+                  <a:srgbClr val="CBD5E1"/>
                 </a:solidFill>
               </a:rPr>
               <a:t> Supervisors no longer waste half an hour hunting for incident timestamps—the 5-second replay is right there.</a:t>
@@ -8033,7 +8197,7 @@
               </a:spcBef>
               <a:defRPr sz="1000" b="1">
                 <a:solidFill>
-                  <a:srgbClr val="182B49"/>
+                  <a:srgbClr val="FFFFFF"/>
                 </a:solidFill>
                 <a:latin typeface="Segoe UI"/>
               </a:defRPr>
@@ -8044,7 +8208,7 @@
             <a:r>
               <a:rPr b="0">
                 <a:solidFill>
-                  <a:srgbClr val="64748B"/>
+                  <a:srgbClr val="CBD5E1"/>
                 </a:solidFill>
               </a:rPr>
               <a:t> In our test video footage, the AI caught 8 out of 9 drops that human workers didn't bother reporting.</a:t>
@@ -8057,7 +8221,7 @@
               </a:spcBef>
               <a:defRPr sz="1000" b="1">
                 <a:solidFill>
-                  <a:srgbClr val="182B49"/>
+                  <a:srgbClr val="FFFFFF"/>
                 </a:solidFill>
                 <a:latin typeface="Segoe UI"/>
               </a:defRPr>
@@ -8068,7 +8232,7 @@
             <a:r>
               <a:rPr b="0">
                 <a:solidFill>
-                  <a:srgbClr val="64748B"/>
+                  <a:srgbClr val="CBD5E1"/>
                 </a:solidFill>
               </a:rPr>
               <a:t> Having a video clip with a timestamp and drop height completely shuts down freight liability disputes.</a:t>
@@ -8108,12 +8272,26 @@
           <a:prstGeom prst="rect">
             <a:avLst/>
           </a:prstGeom>
-          <a:solidFill>
-            <a:srgbClr val="FFFFFF"/>
-          </a:solidFill>
           <a:ln>
             <a:noFill/>
           </a:ln>
+          <a:gradFill flip="none" rotWithShape="1">
+            <a:gsLst>
+              <a:gs pos="0">
+                <a:srgbClr val="08192E"/>
+              </a:gs>
+              <a:gs pos="42000">
+                <a:srgbClr val="12335E"/>
+              </a:gs>
+              <a:gs pos="78000">
+                <a:srgbClr val="1A4982"/>
+              </a:gs>
+              <a:gs pos="100000">
+                <a:srgbClr val="0A2140"/>
+              </a:gs>
+            </a:gsLst>
+            <a:lin ang="3240000" scaled="1"/>
+          </a:gradFill>
         </p:spPr>
         <p:style>
           <a:lnRef idx="1">
@@ -8146,16 +8324,18 @@
         <p:spPr>
           <a:xfrm>
             <a:off x="731520" y="365760"/>
-            <a:ext cx="2560320" cy="292608"/>
+            <a:ext cx="2651760" cy="292608"/>
           </a:xfrm>
           <a:prstGeom prst="roundRect">
             <a:avLst/>
           </a:prstGeom>
           <a:solidFill>
-            <a:srgbClr val="F3E8FF"/>
+            <a:srgbClr val="143058"/>
           </a:solidFill>
-          <a:ln>
-            <a:noFill/>
+          <a:ln w="12700">
+            <a:solidFill>
+              <a:srgbClr val="3872BA"/>
+            </a:solidFill>
           </a:ln>
         </p:spPr>
         <p:style>
@@ -8179,7 +8359,7 @@
             <a:pPr algn="ctr">
               <a:defRPr sz="950" b="1">
                 <a:solidFill>
-                  <a:srgbClr val="6D28D9"/>
+                  <a:srgbClr val="93C5FD"/>
                 </a:solidFill>
                 <a:latin typeface="Segoe UI"/>
               </a:defRPr>
@@ -8215,7 +8395,7 @@
             <a:pPr>
               <a:defRPr sz="2100" b="1">
                 <a:solidFill>
-                  <a:srgbClr val="182B49"/>
+                  <a:srgbClr val="FFFFFF"/>
                 </a:solidFill>
                 <a:latin typeface="Segoe UI"/>
               </a:defRPr>
@@ -8235,13 +8415,13 @@
         <p:spPr>
           <a:xfrm>
             <a:off x="731520" y="1243584"/>
-            <a:ext cx="10728655" cy="13716"/>
+            <a:ext cx="10728655" cy="18288"/>
           </a:xfrm>
           <a:prstGeom prst="rect">
             <a:avLst/>
           </a:prstGeom>
           <a:solidFill>
-            <a:srgbClr val="E2E8F0"/>
+            <a:srgbClr val="2D558C"/>
           </a:solidFill>
           <a:ln>
             <a:noFill/>
@@ -8284,11 +8464,11 @@
             <a:avLst/>
           </a:prstGeom>
           <a:solidFill>
-            <a:srgbClr val="F8FAFC"/>
+            <a:srgbClr val="0E1E36"/>
           </a:solidFill>
           <a:ln>
             <a:solidFill>
-              <a:srgbClr val="E2E8F0"/>
+              <a:srgbClr val="284B78"/>
             </a:solidFill>
           </a:ln>
         </p:spPr>
@@ -8329,7 +8509,7 @@
             <a:avLst/>
           </a:prstGeom>
           <a:solidFill>
-            <a:srgbClr val="10B981"/>
+            <a:srgbClr val="34D399"/>
           </a:solidFill>
           <a:ln>
             <a:noFill/>
@@ -8382,7 +8562,7 @@
             <a:pPr>
               <a:defRPr sz="1150" b="1">
                 <a:solidFill>
-                  <a:srgbClr val="10B981"/>
+                  <a:srgbClr val="34D399"/>
                 </a:solidFill>
                 <a:latin typeface="Segoe UI"/>
               </a:defRPr>
@@ -8398,7 +8578,7 @@
               </a:spcBef>
               <a:defRPr sz="950" b="1">
                 <a:solidFill>
-                  <a:srgbClr val="182B49"/>
+                  <a:srgbClr val="FFFFFF"/>
                 </a:solidFill>
                 <a:latin typeface="Segoe UI"/>
               </a:defRPr>
@@ -8409,7 +8589,7 @@
             <a:r>
               <a:rPr b="0">
                 <a:solidFill>
-                  <a:srgbClr val="64748B"/>
+                  <a:srgbClr val="CBD5E1"/>
                 </a:solidFill>
               </a:rPr>
               <a:t>Hosted online 24/7 on Render with working frontend, backend, and database.</a:t>
@@ -8422,7 +8602,7 @@
               </a:spcBef>
               <a:defRPr sz="950" b="1">
                 <a:solidFill>
-                  <a:srgbClr val="182B49"/>
+                  <a:srgbClr val="FFFFFF"/>
                 </a:solidFill>
                 <a:latin typeface="Segoe UI"/>
               </a:defRPr>
@@ -8433,7 +8613,7 @@
             <a:r>
               <a:rPr b="0">
                 <a:solidFill>
-                  <a:srgbClr val="64748B"/>
+                  <a:srgbClr val="CBD5E1"/>
                 </a:solidFill>
               </a:rPr>
               <a:t>Processes uploaded CCTV footage, draws bounding boxes, and flags drops and dragging.</a:t>
@@ -8446,7 +8626,7 @@
               </a:spcBef>
               <a:defRPr sz="950" b="1">
                 <a:solidFill>
-                  <a:srgbClr val="182B49"/>
+                  <a:srgbClr val="FFFFFF"/>
                 </a:solidFill>
                 <a:latin typeface="Segoe UI"/>
               </a:defRPr>
@@ -8457,7 +8637,7 @@
             <a:r>
               <a:rPr b="0">
                 <a:solidFill>
-                  <a:srgbClr val="64748B"/>
+                  <a:srgbClr val="CBD5E1"/>
                 </a:solidFill>
               </a:rPr>
               <a:t>Real-time KPI cards, 7-day risk trend curves, and in-browser audio chimes.</a:t>
@@ -8470,7 +8650,7 @@
               </a:spcBef>
               <a:defRPr sz="950" b="1">
                 <a:solidFill>
-                  <a:srgbClr val="182B49"/>
+                  <a:srgbClr val="FFFFFF"/>
                 </a:solidFill>
                 <a:latin typeface="Segoe UI"/>
               </a:defRPr>
@@ -8481,7 +8661,7 @@
             <a:r>
               <a:rPr b="0">
                 <a:solidFill>
-                  <a:srgbClr val="64748B"/>
+                  <a:srgbClr val="CBD5E1"/>
                 </a:solidFill>
               </a:rPr>
               <a:t>Actually answers conversational questions using real database records.</a:t>
@@ -8504,11 +8684,11 @@
             <a:avLst/>
           </a:prstGeom>
           <a:solidFill>
-            <a:srgbClr val="F8FAFC"/>
+            <a:srgbClr val="0E1E36"/>
           </a:solidFill>
           <a:ln>
             <a:solidFill>
-              <a:srgbClr val="E2E8F0"/>
+              <a:srgbClr val="284B78"/>
             </a:solidFill>
           </a:ln>
         </p:spPr>
@@ -8549,7 +8729,7 @@
             <a:avLst/>
           </a:prstGeom>
           <a:solidFill>
-            <a:srgbClr val="E11D48"/>
+            <a:srgbClr val="FB7185"/>
           </a:solidFill>
           <a:ln>
             <a:noFill/>
@@ -8602,7 +8782,7 @@
             <a:pPr>
               <a:defRPr sz="1150" b="1">
                 <a:solidFill>
-                  <a:srgbClr val="E11D48"/>
+                  <a:srgbClr val="FB7185"/>
                 </a:solidFill>
                 <a:latin typeface="Segoe UI"/>
               </a:defRPr>
@@ -8618,7 +8798,7 @@
               </a:spcBef>
               <a:defRPr sz="950" b="1">
                 <a:solidFill>
-                  <a:srgbClr val="182B49"/>
+                  <a:srgbClr val="FFFFFF"/>
                 </a:solidFill>
                 <a:latin typeface="Segoe UI"/>
               </a:defRPr>
@@ -8629,7 +8809,7 @@
             <a:r>
               <a:rPr b="0">
                 <a:solidFill>
-                  <a:srgbClr val="64748B"/>
+                  <a:srgbClr val="CBD5E1"/>
                 </a:solidFill>
               </a:rPr>
               <a:t>Running video analysis on a free CPU instance takes 5–8 seconds per clip. A dedicated GPU will make it instant.</a:t>
@@ -8642,7 +8822,7 @@
               </a:spcBef>
               <a:defRPr sz="950" b="1">
                 <a:solidFill>
-                  <a:srgbClr val="182B49"/>
+                  <a:srgbClr val="FFFFFF"/>
                 </a:solidFill>
                 <a:latin typeface="Segoe UI"/>
               </a:defRPr>
@@ -8653,7 +8833,7 @@
             <a:r>
               <a:rPr b="0">
                 <a:solidFill>
-                  <a:srgbClr val="64748B"/>
+                  <a:srgbClr val="CBD5E1"/>
                 </a:solidFill>
               </a:rPr>
               <a:t>When 3 workers crowd directly in front of a box, the camera can temporarily lose sight of it.</a:t>
@@ -8666,7 +8846,7 @@
               </a:spcBef>
               <a:defRPr sz="950" b="1">
                 <a:solidFill>
-                  <a:srgbClr val="182B49"/>
+                  <a:srgbClr val="FFFFFF"/>
                 </a:solidFill>
                 <a:latin typeface="Segoe UI"/>
               </a:defRPr>
@@ -8677,7 +8857,7 @@
             <a:r>
               <a:rPr b="0">
                 <a:solidFill>
-                  <a:srgbClr val="64748B"/>
+                  <a:srgbClr val="CBD5E1"/>
                 </a:solidFill>
               </a:rPr>
               <a:t>Intense morning glare through open truck doors can slightly lower detection confidence.</a:t>
@@ -8700,11 +8880,11 @@
             <a:avLst/>
           </a:prstGeom>
           <a:solidFill>
-            <a:srgbClr val="F8FAFC"/>
+            <a:srgbClr val="0E1E36"/>
           </a:solidFill>
           <a:ln>
             <a:solidFill>
-              <a:srgbClr val="E2E8F0"/>
+              <a:srgbClr val="284B78"/>
             </a:solidFill>
           </a:ln>
         </p:spPr>
@@ -8745,7 +8925,7 @@
             <a:avLst/>
           </a:prstGeom>
           <a:solidFill>
-            <a:srgbClr val="2563EB"/>
+            <a:srgbClr val="38BDF8"/>
           </a:solidFill>
           <a:ln>
             <a:noFill/>
@@ -8798,7 +8978,7 @@
             <a:pPr>
               <a:defRPr sz="1150" b="1">
                 <a:solidFill>
-                  <a:srgbClr val="2563EB"/>
+                  <a:srgbClr val="38BDF8"/>
                 </a:solidFill>
                 <a:latin typeface="Segoe UI"/>
               </a:defRPr>
@@ -8814,7 +8994,7 @@
               </a:spcBef>
               <a:defRPr sz="950" b="1">
                 <a:solidFill>
-                  <a:srgbClr val="182B49"/>
+                  <a:srgbClr val="FFFFFF"/>
                 </a:solidFill>
                 <a:latin typeface="Segoe UI"/>
               </a:defRPr>
@@ -8825,7 +9005,7 @@
             <a:r>
               <a:rPr b="0">
                 <a:solidFill>
-                  <a:srgbClr val="64748B"/>
+                  <a:srgbClr val="CBD5E1"/>
                 </a:solidFill>
               </a:rPr>
               <a:t>Run YOLOv8 right on the dock on a $150 Jetson nano for instant &lt;50ms processing.</a:t>
@@ -8838,7 +9018,7 @@
               </a:spcBef>
               <a:defRPr sz="950" b="1">
                 <a:solidFill>
-                  <a:srgbClr val="182B49"/>
+                  <a:srgbClr val="FFFFFF"/>
                 </a:solidFill>
                 <a:latin typeface="Segoe UI"/>
               </a:defRPr>
@@ -8849,7 +9029,7 @@
             <a:r>
               <a:rPr b="0">
                 <a:solidFill>
-                  <a:srgbClr val="64748B"/>
+                  <a:srgbClr val="CBD5E1"/>
                 </a:solidFill>
               </a:rPr>
               <a:t>Connect detection timestamps directly to package tracking numbers (WMS integration).</a:t>
@@ -8862,7 +9042,7 @@
               </a:spcBef>
               <a:defRPr sz="950" b="1">
                 <a:solidFill>
-                  <a:srgbClr val="182B49"/>
+                  <a:srgbClr val="FFFFFF"/>
                 </a:solidFill>
                 <a:latin typeface="Segoe UI"/>
               </a:defRPr>
@@ -8873,7 +9053,7 @@
             <a:r>
               <a:rPr b="0">
                 <a:solidFill>
-                  <a:srgbClr val="64748B"/>
+                  <a:srgbClr val="CBD5E1"/>
                 </a:solidFill>
               </a:rPr>
               <a:t>Warn workers if they bend at the back instead of lifting with their knees to prevent injury.</a:t>
@@ -8896,11 +9076,11 @@
             <a:avLst/>
           </a:prstGeom>
           <a:solidFill>
-            <a:srgbClr val="F3E8FF"/>
+            <a:srgbClr val="143058"/>
           </a:solidFill>
           <a:ln>
             <a:solidFill>
-              <a:srgbClr val="DDD6FE"/>
+              <a:srgbClr val="2D5F9B"/>
             </a:solidFill>
           </a:ln>
         </p:spPr>
@@ -8951,7 +9131,7 @@
             <a:pPr algn="ctr">
               <a:defRPr sz="1200" b="1">
                 <a:solidFill>
-                  <a:srgbClr val="6D28D9"/>
+                  <a:srgbClr val="7DD3FC"/>
                 </a:solidFill>
                 <a:latin typeface="Segoe UI"/>
               </a:defRPr>
@@ -8967,7 +9147,7 @@
               </a:spcBef>
               <a:defRPr sz="950">
                 <a:solidFill>
-                  <a:srgbClr val="64748B"/>
+                  <a:srgbClr val="CBD5E1"/>
                 </a:solidFill>
                 <a:latin typeface="Segoe UI"/>
               </a:defRPr>

</xml_diff>